<commit_message>
Remaster slides 7 and 11, light-touch pass on 2, 3, 5, 8, 9, 10, 12, 13
Co-Authored-By: Claude Sonnet 5.5 <noreply@anthropic.com>
Claude-Session: https://claude.ai/code/session_018FYC5nzQydn1DiijEsEsUi
</commit_message>
<xml_diff>
--- a/AMB_Draft_4_remaster_wip.pptx
+++ b/AMB_Draft_4_remaster_wip.pptx
@@ -3403,16 +3403,56 @@
               <a:gd name="adj" fmla="val 2807"/>
             </a:avLst>
           </a:prstGeom>
-          <a:solidFill>
-            <a:srgbClr val="F1F4F9"/>
-          </a:solidFill>
+          <a:noFill/>
           <a:ln w="12700">
-            <a:solidFill>
-              <a:srgbClr val="F1F4F9"/>
-            </a:solidFill>
+            <a:noFill/>
             <a:prstDash val="solid"/>
           </a:ln>
         </p:spPr>
+      </p:sp>
+      <p:sp>
+        <p:nvSpPr>
+          <p:cNvPr id="32" name="Rectangle 31"/>
+          <p:cNvSpPr/>
+          <p:nvPr/>
+        </p:nvSpPr>
+        <p:spPr>
+          <a:xfrm>
+            <a:off x="457200" y="1280160"/>
+            <a:ext cx="2651760" cy="36576"/>
+          </a:xfrm>
+          <a:prstGeom prst="rect">
+            <a:avLst/>
+          </a:prstGeom>
+          <a:solidFill>
+            <a:srgbClr val="1F8F74"/>
+          </a:solidFill>
+          <a:ln>
+            <a:noFill/>
+          </a:ln>
+          <a:effectLst/>
+        </p:spPr>
+        <p:style>
+          <a:lnRef idx="1">
+            <a:schemeClr val="accent1"/>
+          </a:lnRef>
+          <a:fillRef idx="3">
+            <a:schemeClr val="accent1"/>
+          </a:fillRef>
+          <a:effectRef idx="2">
+            <a:schemeClr val="accent1"/>
+          </a:effectRef>
+          <a:fontRef idx="minor">
+            <a:schemeClr val="lt1"/>
+          </a:fontRef>
+        </p:style>
+        <p:txBody>
+          <a:bodyPr rtlCol="0" anchor="ctr"/>
+          <a:lstStyle/>
+          <a:p>
+            <a:pPr algn="ctr"/>
+          </a:p>
+        </p:txBody>
       </p:sp>
       <p:sp>
         <p:nvSpPr>
@@ -3658,16 +3698,56 @@
               <a:gd name="adj" fmla="val 2807"/>
             </a:avLst>
           </a:prstGeom>
-          <a:solidFill>
-            <a:srgbClr val="F1F4F9"/>
-          </a:solidFill>
+          <a:noFill/>
           <a:ln w="12700">
-            <a:solidFill>
-              <a:srgbClr val="F1F4F9"/>
-            </a:solidFill>
+            <a:noFill/>
             <a:prstDash val="solid"/>
           </a:ln>
         </p:spPr>
+      </p:sp>
+      <p:sp>
+        <p:nvSpPr>
+          <p:cNvPr id="33" name="Rectangle 32"/>
+          <p:cNvSpPr/>
+          <p:nvPr/>
+        </p:nvSpPr>
+        <p:spPr>
+          <a:xfrm>
+            <a:off x="3246120" y="1280160"/>
+            <a:ext cx="2651760" cy="36576"/>
+          </a:xfrm>
+          <a:prstGeom prst="rect">
+            <a:avLst/>
+          </a:prstGeom>
+          <a:solidFill>
+            <a:srgbClr val="1F8F74"/>
+          </a:solidFill>
+          <a:ln>
+            <a:noFill/>
+          </a:ln>
+          <a:effectLst/>
+        </p:spPr>
+        <p:style>
+          <a:lnRef idx="1">
+            <a:schemeClr val="accent1"/>
+          </a:lnRef>
+          <a:fillRef idx="3">
+            <a:schemeClr val="accent1"/>
+          </a:fillRef>
+          <a:effectRef idx="2">
+            <a:schemeClr val="accent1"/>
+          </a:effectRef>
+          <a:fontRef idx="minor">
+            <a:schemeClr val="lt1"/>
+          </a:fontRef>
+        </p:style>
+        <p:txBody>
+          <a:bodyPr rtlCol="0" anchor="ctr"/>
+          <a:lstStyle/>
+          <a:p>
+            <a:pPr algn="ctr"/>
+          </a:p>
+        </p:txBody>
       </p:sp>
       <p:sp>
         <p:nvSpPr>
@@ -3913,16 +3993,56 @@
               <a:gd name="adj" fmla="val 2807"/>
             </a:avLst>
           </a:prstGeom>
-          <a:solidFill>
-            <a:srgbClr val="F1F4F9"/>
-          </a:solidFill>
+          <a:noFill/>
           <a:ln w="12700">
-            <a:solidFill>
-              <a:srgbClr val="F1F4F9"/>
-            </a:solidFill>
+            <a:noFill/>
             <a:prstDash val="solid"/>
           </a:ln>
         </p:spPr>
+      </p:sp>
+      <p:sp>
+        <p:nvSpPr>
+          <p:cNvPr id="34" name="Rectangle 33"/>
+          <p:cNvSpPr/>
+          <p:nvPr/>
+        </p:nvSpPr>
+        <p:spPr>
+          <a:xfrm>
+            <a:off x="6035040" y="1280160"/>
+            <a:ext cx="2651760" cy="36576"/>
+          </a:xfrm>
+          <a:prstGeom prst="rect">
+            <a:avLst/>
+          </a:prstGeom>
+          <a:solidFill>
+            <a:srgbClr val="1F8F74"/>
+          </a:solidFill>
+          <a:ln>
+            <a:noFill/>
+          </a:ln>
+          <a:effectLst/>
+        </p:spPr>
+        <p:style>
+          <a:lnRef idx="1">
+            <a:schemeClr val="accent1"/>
+          </a:lnRef>
+          <a:fillRef idx="3">
+            <a:schemeClr val="accent1"/>
+          </a:fillRef>
+          <a:effectRef idx="2">
+            <a:schemeClr val="accent1"/>
+          </a:effectRef>
+          <a:fontRef idx="minor">
+            <a:schemeClr val="lt1"/>
+          </a:fontRef>
+        </p:style>
+        <p:txBody>
+          <a:bodyPr rtlCol="0" anchor="ctr"/>
+          <a:lstStyle/>
+          <a:p>
+            <a:pPr algn="ctr"/>
+          </a:p>
+        </p:txBody>
       </p:sp>
       <p:sp>
         <p:nvSpPr>
@@ -4168,27 +4288,67 @@
               <a:gd name="adj" fmla="val 11765"/>
             </a:avLst>
           </a:prstGeom>
-          <a:solidFill>
-            <a:srgbClr val="E3F3EF"/>
-          </a:solidFill>
+          <a:noFill/>
           <a:ln w="12700">
-            <a:solidFill>
-              <a:srgbClr val="E3F3EF"/>
-            </a:solidFill>
+            <a:noFill/>
             <a:prstDash val="solid"/>
           </a:ln>
         </p:spPr>
       </p:sp>
       <p:sp>
         <p:nvSpPr>
+          <p:cNvPr id="35" name="Rectangle 34"/>
+          <p:cNvSpPr/>
+          <p:nvPr/>
+        </p:nvSpPr>
+        <p:spPr>
+          <a:xfrm>
+            <a:off x="457200" y="3977639"/>
+            <a:ext cx="45720" cy="621792"/>
+          </a:xfrm>
+          <a:prstGeom prst="rect">
+            <a:avLst/>
+          </a:prstGeom>
+          <a:solidFill>
+            <a:srgbClr val="1F8F74"/>
+          </a:solidFill>
+          <a:ln>
+            <a:noFill/>
+          </a:ln>
+          <a:effectLst/>
+        </p:spPr>
+        <p:style>
+          <a:lnRef idx="1">
+            <a:schemeClr val="accent1"/>
+          </a:lnRef>
+          <a:fillRef idx="3">
+            <a:schemeClr val="accent1"/>
+          </a:fillRef>
+          <a:effectRef idx="2">
+            <a:schemeClr val="accent1"/>
+          </a:effectRef>
+          <a:fontRef idx="minor">
+            <a:schemeClr val="lt1"/>
+          </a:fontRef>
+        </p:style>
+        <p:txBody>
+          <a:bodyPr rtlCol="0" anchor="ctr"/>
+          <a:lstStyle/>
+          <a:p>
+            <a:pPr algn="ctr"/>
+          </a:p>
+        </p:txBody>
+      </p:sp>
+      <p:sp>
+        <p:nvSpPr>
           <p:cNvPr id="30" name="Text 24"/>
           <p:cNvSpPr txBox="1"/>
           <p:nvPr/>
         </p:nvSpPr>
         <p:spPr>
           <a:xfrm>
-            <a:off x="640080" y="3995928"/>
-            <a:ext cx="7863840" cy="585216"/>
+            <a:off x="685800" y="3995928"/>
+            <a:ext cx="7772400" cy="585216"/>
           </a:xfrm>
           <a:prstGeom prst="rect">
             <a:avLst/>
@@ -4453,934 +4613,896 @@
       </p:sp>
       <p:sp>
         <p:nvSpPr>
-          <p:cNvPr id="5" name="Shape 2"/>
+          <p:cNvPr id="29" name="Text 23"/>
+          <p:cNvSpPr txBox="1"/>
+          <p:nvPr/>
+        </p:nvSpPr>
+        <p:spPr>
+          <a:xfrm>
+            <a:off x="457200" y="4645152"/>
+            <a:ext cx="7680960" cy="347472"/>
+          </a:xfrm>
+          <a:prstGeom prst="rect">
+            <a:avLst/>
+          </a:prstGeom>
+          <a:noFill/>
+          <a:ln/>
+        </p:spPr>
+        <p:txBody>
+          <a:bodyPr wrap="square" lIns="0" tIns="0" rIns="0" bIns="0" rtlCol="0" anchor="t"/>
+          <a:lstStyle/>
+          <a:p>
+            <a:pPr indent="0" marL="0">
+              <a:buNone/>
+            </a:pPr>
+            <a:r>
+              <a:rPr lang="en-US" sz="1000" dirty="0">
+                <a:solidFill>
+                  <a:srgbClr val="556070"/>
+                </a:solidFill>
+                <a:latin typeface="Calibri" pitchFamily="34" charset="0"/>
+                <a:ea typeface="Calibri" pitchFamily="34" charset="-122"/>
+                <a:cs typeface="Calibri" pitchFamily="34" charset="-120"/>
+              </a:rPr>
+              <a:t>Remaining 10% to measurement and testing. Split is indicative and will be re-derived from cost per funded loan by channel once the pilot reports.</a:t>
+            </a:r>
+            <a:endParaRPr lang="en-US" sz="1000" dirty="0"/>
+          </a:p>
+        </p:txBody>
+      </p:sp>
+      <p:sp>
+        <p:nvSpPr>
+          <p:cNvPr id="30" name="Text 24"/>
+          <p:cNvSpPr txBox="1"/>
+          <p:nvPr/>
+        </p:nvSpPr>
+        <p:spPr>
+          <a:xfrm>
+            <a:off x="8229600" y="4754880"/>
+            <a:ext cx="457200" cy="228600"/>
+          </a:xfrm>
+          <a:prstGeom prst="rect">
+            <a:avLst/>
+          </a:prstGeom>
+          <a:noFill/>
+          <a:ln/>
+        </p:spPr>
+        <p:txBody>
+          <a:bodyPr wrap="square" lIns="0" tIns="0" rIns="0" bIns="0" rtlCol="0" anchor="ctr"/>
+          <a:lstStyle/>
+          <a:p>
+            <a:pPr algn="r" indent="0" marL="0">
+              <a:buNone/>
+            </a:pPr>
+            <a:r>
+              <a:rPr lang="en-US" sz="1000" dirty="0">
+                <a:solidFill>
+                  <a:srgbClr val="556070"/>
+                </a:solidFill>
+                <a:latin typeface="Calibri" pitchFamily="34" charset="0"/>
+                <a:ea typeface="Calibri" pitchFamily="34" charset="-122"/>
+                <a:cs typeface="Calibri" pitchFamily="34" charset="-120"/>
+              </a:rPr>
+              <a:t>11</a:t>
+            </a:r>
+            <a:endParaRPr lang="en-US" sz="1000" dirty="0"/>
+          </a:p>
+        </p:txBody>
+      </p:sp>
+      <p:sp>
+        <p:nvSpPr>
+          <p:cNvPr id="31" name="Rectangle 30"/>
           <p:cNvSpPr/>
           <p:nvPr/>
         </p:nvSpPr>
         <p:spPr>
           <a:xfrm>
-            <a:off x="457200" y="1234440"/>
-            <a:ext cx="2651760" cy="3154680"/>
-          </a:xfrm>
-          <a:prstGeom prst="roundRect">
-            <a:avLst>
-              <a:gd name="adj" fmla="val 2759"/>
-            </a:avLst>
+            <a:off x="3177540" y="1325880"/>
+            <a:ext cx="9144" cy="3108960"/>
+          </a:xfrm>
+          <a:prstGeom prst="rect">
+            <a:avLst/>
           </a:prstGeom>
           <a:solidFill>
-            <a:srgbClr val="F1F4F9"/>
+            <a:srgbClr val="D9DEE7"/>
           </a:solidFill>
-          <a:ln w="12700">
-            <a:solidFill>
-              <a:srgbClr val="F1F4F9"/>
-            </a:solidFill>
-            <a:prstDash val="solid"/>
+          <a:ln>
+            <a:noFill/>
           </a:ln>
-        </p:spPr>
-      </p:sp>
-      <p:sp>
-        <p:nvSpPr>
-          <p:cNvPr id="6" name="Shape 3"/>
+          <a:effectLst/>
+        </p:spPr>
+        <p:style>
+          <a:lnRef idx="1">
+            <a:schemeClr val="accent1"/>
+          </a:lnRef>
+          <a:fillRef idx="3">
+            <a:schemeClr val="accent1"/>
+          </a:fillRef>
+          <a:effectRef idx="2">
+            <a:schemeClr val="accent1"/>
+          </a:effectRef>
+          <a:fontRef idx="minor">
+            <a:schemeClr val="lt1"/>
+          </a:fontRef>
+        </p:style>
+        <p:txBody>
+          <a:bodyPr rtlCol="0" anchor="ctr"/>
+          <a:lstStyle/>
+          <a:p>
+            <a:pPr algn="ctr"/>
+          </a:p>
+        </p:txBody>
+      </p:sp>
+      <p:sp>
+        <p:nvSpPr>
+          <p:cNvPr id="32" name="Rectangle 31"/>
           <p:cNvSpPr/>
           <p:nvPr/>
         </p:nvSpPr>
         <p:spPr>
           <a:xfrm>
-            <a:off x="685800" y="1389888"/>
-            <a:ext cx="420624" cy="420624"/>
-          </a:xfrm>
-          <a:prstGeom prst="ellipse">
+            <a:off x="5966460" y="1325880"/>
+            <a:ext cx="9144" cy="3108960"/>
+          </a:xfrm>
+          <a:prstGeom prst="rect">
             <a:avLst/>
           </a:prstGeom>
           <a:solidFill>
-            <a:srgbClr val="152B56"/>
+            <a:srgbClr val="D9DEE7"/>
           </a:solidFill>
-          <a:ln w="12700">
-            <a:solidFill>
-              <a:srgbClr val="152B56"/>
-            </a:solidFill>
-            <a:prstDash val="solid"/>
+          <a:ln>
+            <a:noFill/>
           </a:ln>
-        </p:spPr>
+          <a:effectLst/>
+        </p:spPr>
+        <p:style>
+          <a:lnRef idx="1">
+            <a:schemeClr val="accent1"/>
+          </a:lnRef>
+          <a:fillRef idx="3">
+            <a:schemeClr val="accent1"/>
+          </a:fillRef>
+          <a:effectRef idx="2">
+            <a:schemeClr val="accent1"/>
+          </a:effectRef>
+          <a:fontRef idx="minor">
+            <a:schemeClr val="lt1"/>
+          </a:fontRef>
+        </p:style>
+        <p:txBody>
+          <a:bodyPr rtlCol="0" anchor="ctr"/>
+          <a:lstStyle/>
+          <a:p>
+            <a:pPr algn="ctr"/>
+          </a:p>
+        </p:txBody>
       </p:sp>
       <p:pic>
         <p:nvPicPr>
-          <p:cNvPr id="7" name="Image 0" descr="preencoded.png">    </p:cNvPr>
+          <p:cNvPr id="33" name="Picture 32" descr="s11_pg4-001.jpg"/>
           <p:cNvPicPr>
             <a:picLocks noChangeAspect="1"/>
           </p:cNvPicPr>
           <p:nvPr/>
         </p:nvPicPr>
         <p:blipFill>
-          <a:blip r:embed="rId1"/>
+          <a:blip r:embed="rId6"/>
           <a:stretch>
             <a:fillRect/>
           </a:stretch>
         </p:blipFill>
         <p:spPr>
           <a:xfrm>
-            <a:off x="786750" y="1490838"/>
-            <a:ext cx="218724" cy="218724"/>
-          </a:xfrm>
-          <a:prstGeom prst="rect">
+            <a:off x="1280160" y="1298448"/>
+            <a:ext cx="1005840" cy="1005840"/>
+          </a:xfrm>
+          <a:prstGeom prst="ellipse">
             <a:avLst/>
           </a:prstGeom>
         </p:spPr>
       </p:pic>
       <p:sp>
         <p:nvSpPr>
-          <p:cNvPr id="8" name="Text 4"/>
-          <p:cNvSpPr txBox="1"/>
-          <p:nvPr/>
-        </p:nvSpPr>
-        <p:spPr>
-          <a:xfrm>
-            <a:off x="1554480" y="1298448"/>
-            <a:ext cx="1371600" cy="457200"/>
-          </a:xfrm>
-          <a:prstGeom prst="rect">
-            <a:avLst/>
-          </a:prstGeom>
-          <a:noFill/>
-          <a:ln/>
-        </p:spPr>
-        <p:txBody>
-          <a:bodyPr wrap="square" lIns="0" tIns="0" rIns="0" bIns="0" rtlCol="0" anchor="ctr"/>
-          <a:lstStyle/>
-          <a:p>
-            <a:pPr algn="r" indent="0" marL="0">
-              <a:buNone/>
-            </a:pPr>
-            <a:r>
-              <a:rPr lang="en-US" sz="3000" b="1" dirty="0">
-                <a:solidFill>
-                  <a:srgbClr val="166257"/>
-                </a:solidFill>
-                <a:latin typeface="Cambria" pitchFamily="34" charset="0"/>
-                <a:ea typeface="Cambria" pitchFamily="34" charset="-122"/>
-                <a:cs typeface="Cambria" pitchFamily="34" charset="-120"/>
-              </a:rPr>
-              <a:t>20%</a:t>
-            </a:r>
-            <a:endParaRPr lang="en-US" sz="3000" dirty="0"/>
-          </a:p>
-        </p:txBody>
-      </p:sp>
-      <p:sp>
-        <p:nvSpPr>
-          <p:cNvPr id="9" name="Text 5"/>
-          <p:cNvSpPr txBox="1"/>
-          <p:nvPr/>
-        </p:nvSpPr>
-        <p:spPr>
-          <a:xfrm>
-            <a:off x="1188720" y="1737360"/>
-            <a:ext cx="1737360" cy="228600"/>
-          </a:xfrm>
-          <a:prstGeom prst="rect">
-            <a:avLst/>
-          </a:prstGeom>
-          <a:noFill/>
-          <a:ln/>
-        </p:spPr>
-        <p:txBody>
-          <a:bodyPr wrap="square" lIns="0" tIns="0" rIns="0" bIns="0" rtlCol="0" anchor="t"/>
-          <a:lstStyle/>
-          <a:p>
-            <a:pPr algn="r" indent="0" marL="0">
-              <a:buNone/>
-            </a:pPr>
-            <a:r>
-              <a:rPr lang="en-US" sz="1100" dirty="0">
-                <a:solidFill>
-                  <a:srgbClr val="556070"/>
-                </a:solidFill>
-                <a:latin typeface="Calibri" pitchFamily="34" charset="0"/>
-                <a:ea typeface="Calibri" pitchFamily="34" charset="-122"/>
-                <a:cs typeface="Calibri" pitchFamily="34" charset="-120"/>
-              </a:rPr>
-              <a:t>$150k · owned + earned</a:t>
-            </a:r>
-            <a:endParaRPr lang="en-US" sz="1100" dirty="0"/>
-          </a:p>
-        </p:txBody>
-      </p:sp>
-      <p:sp>
-        <p:nvSpPr>
-          <p:cNvPr id="10" name="Text 6"/>
-          <p:cNvSpPr txBox="1"/>
-          <p:nvPr/>
-        </p:nvSpPr>
-        <p:spPr>
-          <a:xfrm>
-            <a:off x="685800" y="2029968"/>
-            <a:ext cx="2240280" cy="457200"/>
-          </a:xfrm>
-          <a:prstGeom prst="rect">
-            <a:avLst/>
-          </a:prstGeom>
-          <a:noFill/>
-          <a:ln/>
-        </p:spPr>
-        <p:txBody>
-          <a:bodyPr wrap="square" lIns="0" tIns="0" rIns="0" bIns="0" rtlCol="0" anchor="t"/>
-          <a:lstStyle/>
-          <a:p>
-            <a:pPr indent="0" marL="0">
-              <a:buNone/>
-            </a:pPr>
-            <a:r>
-              <a:rPr lang="en-US" sz="1500" b="1" dirty="0">
-                <a:solidFill>
-                  <a:srgbClr val="152B56"/>
-                </a:solidFill>
-                <a:latin typeface="Calibri" pitchFamily="34" charset="0"/>
-                <a:ea typeface="Calibri" pitchFamily="34" charset="-122"/>
-                <a:cs typeface="Calibri" pitchFamily="34" charset="-120"/>
-              </a:rPr>
-              <a:t>Make AMB easy to verify</a:t>
-            </a:r>
-            <a:endParaRPr lang="en-US" sz="1500" dirty="0"/>
-          </a:p>
-        </p:txBody>
-      </p:sp>
-      <p:sp>
-        <p:nvSpPr>
-          <p:cNvPr id="11" name="Text 7"/>
-          <p:cNvSpPr txBox="1"/>
-          <p:nvPr/>
-        </p:nvSpPr>
-        <p:spPr>
-          <a:xfrm>
-            <a:off x="685800" y="2514600"/>
-            <a:ext cx="2240280" cy="1325880"/>
-          </a:xfrm>
-          <a:prstGeom prst="rect">
-            <a:avLst/>
-          </a:prstGeom>
-          <a:noFill/>
-          <a:ln/>
-        </p:spPr>
-        <p:txBody>
-          <a:bodyPr wrap="square" lIns="0" tIns="0" rIns="0" bIns="0" rtlCol="0" anchor="t"/>
-          <a:lstStyle/>
-          <a:p>
-            <a:pPr indent="0" marL="0">
-              <a:buNone/>
-            </a:pPr>
-            <a:r>
-              <a:rPr lang="en-US" sz="1200" dirty="0">
-                <a:solidFill>
-                  <a:srgbClr val="1E2633"/>
-                </a:solidFill>
-                <a:latin typeface="Calibri" pitchFamily="34" charset="0"/>
-                <a:ea typeface="Calibri" pitchFamily="34" charset="-122"/>
-                <a:cs typeface="Calibri" pitchFamily="34" charset="-120"/>
-              </a:rPr>
-              <a:t>Reviews on Google and ProductReview, independent ratings, APRA and Roy Morgan proof, real rates, fees and approval times on the site; visible in search and AI answers.</a:t>
-            </a:r>
-            <a:endParaRPr lang="en-US" sz="1200" dirty="0"/>
-          </a:p>
-        </p:txBody>
-      </p:sp>
-      <p:sp>
-        <p:nvSpPr>
-          <p:cNvPr id="12" name="Text 8"/>
-          <p:cNvSpPr txBox="1"/>
-          <p:nvPr/>
-        </p:nvSpPr>
-        <p:spPr>
-          <a:xfrm>
-            <a:off x="685800" y="3931920"/>
-            <a:ext cx="2240280" cy="365760"/>
-          </a:xfrm>
-          <a:prstGeom prst="rect">
-            <a:avLst/>
-          </a:prstGeom>
-          <a:noFill/>
-          <a:ln/>
-        </p:spPr>
-        <p:txBody>
-          <a:bodyPr wrap="square" lIns="0" tIns="0" rIns="0" bIns="0" rtlCol="0" anchor="t"/>
-          <a:lstStyle/>
-          <a:p>
-            <a:pPr indent="0" marL="0">
-              <a:buNone/>
-            </a:pPr>
-            <a:r>
-              <a:rPr lang="en-US" sz="1150" b="1" dirty="0">
-                <a:solidFill>
-                  <a:srgbClr val="166257"/>
-                </a:solidFill>
-                <a:latin typeface="Calibri" pitchFamily="34" charset="0"/>
-                <a:ea typeface="Calibri" pitchFamily="34" charset="-122"/>
-                <a:cs typeface="Calibri" pitchFamily="34" charset="-120"/>
-              </a:rPr>
-              <a:t>Acts on: </a:t>
-            </a:r>
-            <a:pPr indent="0" marL="0">
-              <a:buNone/>
-            </a:pPr>
-            <a:r>
-              <a:rPr lang="en-US" sz="1150" dirty="0">
-                <a:solidFill>
-                  <a:srgbClr val="166257"/>
-                </a:solidFill>
-                <a:latin typeface="Calibri" pitchFamily="34" charset="0"/>
-                <a:ea typeface="Calibri" pitchFamily="34" charset="-122"/>
-                <a:cs typeface="Calibri" pitchFamily="34" charset="-120"/>
-              </a:rPr>
-              <a:t>The borrower's own check</a:t>
-            </a:r>
-            <a:endParaRPr lang="en-US" sz="1150" dirty="0"/>
-          </a:p>
-        </p:txBody>
-      </p:sp>
-      <p:sp>
-        <p:nvSpPr>
-          <p:cNvPr id="13" name="Shape 9"/>
+          <p:cNvPr id="34" name="Oval 33"/>
           <p:cNvSpPr/>
           <p:nvPr/>
         </p:nvSpPr>
         <p:spPr>
           <a:xfrm>
-            <a:off x="3246120" y="1234440"/>
-            <a:ext cx="2651760" cy="3154680"/>
-          </a:xfrm>
-          <a:prstGeom prst="roundRect">
-            <a:avLst>
-              <a:gd name="adj" fmla="val 2759"/>
-            </a:avLst>
-          </a:prstGeom>
-          <a:solidFill>
-            <a:srgbClr val="152B56"/>
-          </a:solidFill>
-          <a:ln w="12700">
-            <a:solidFill>
-              <a:srgbClr val="152B56"/>
-            </a:solidFill>
-            <a:prstDash val="solid"/>
-          </a:ln>
-        </p:spPr>
-      </p:sp>
-      <p:sp>
-        <p:nvSpPr>
-          <p:cNvPr id="14" name="Shape 10"/>
-          <p:cNvSpPr/>
-          <p:nvPr/>
-        </p:nvSpPr>
-        <p:spPr>
-          <a:xfrm>
-            <a:off x="3474720" y="1389888"/>
-            <a:ext cx="420624" cy="420624"/>
+            <a:off x="1216151" y="1234439"/>
+            <a:ext cx="1133856" cy="1133856"/>
           </a:xfrm>
           <a:prstGeom prst="ellipse">
             <a:avLst/>
           </a:prstGeom>
-          <a:solidFill>
-            <a:srgbClr val="1F8F74"/>
-          </a:solidFill>
-          <a:ln w="12700">
+          <a:noFill/>
+          <a:ln w="15875">
             <a:solidFill>
               <a:srgbClr val="1F8F74"/>
             </a:solidFill>
-            <a:prstDash val="solid"/>
           </a:ln>
-        </p:spPr>
+          <a:effectLst/>
+        </p:spPr>
+        <p:style>
+          <a:lnRef idx="1">
+            <a:schemeClr val="accent1"/>
+          </a:lnRef>
+          <a:fillRef idx="3">
+            <a:schemeClr val="accent1"/>
+          </a:fillRef>
+          <a:effectRef idx="2">
+            <a:schemeClr val="accent1"/>
+          </a:effectRef>
+          <a:fontRef idx="minor">
+            <a:schemeClr val="lt1"/>
+          </a:fontRef>
+        </p:style>
+        <p:txBody>
+          <a:bodyPr rtlCol="0" anchor="ctr"/>
+          <a:lstStyle/>
+          <a:p>
+            <a:pPr algn="ctr"/>
+          </a:p>
+        </p:txBody>
+      </p:sp>
+      <p:sp>
+        <p:nvSpPr>
+          <p:cNvPr id="35" name="TextBox 34"/>
+          <p:cNvSpPr txBox="1"/>
+          <p:nvPr/>
+        </p:nvSpPr>
+        <p:spPr>
+          <a:xfrm>
+            <a:off x="548640" y="2523744"/>
+            <a:ext cx="2468879" cy="457200"/>
+          </a:xfrm>
+          <a:prstGeom prst="rect">
+            <a:avLst/>
+          </a:prstGeom>
+          <a:noFill/>
+        </p:spPr>
+        <p:txBody>
+          <a:bodyPr wrap="square" lIns="0" rIns="0" tIns="0" bIns="0" anchor="t">
+            <a:spAutoFit/>
+          </a:bodyPr>
+          <a:lstStyle/>
+          <a:p>
+            <a:pPr algn="ctr"/>
+            <a:r>
+              <a:rPr sz="3000" b="1">
+                <a:solidFill>
+                  <a:srgbClr val="152B56"/>
+                </a:solidFill>
+                <a:latin typeface="Cambria"/>
+              </a:rPr>
+              <a:t>20%</a:t>
+            </a:r>
+          </a:p>
+        </p:txBody>
+      </p:sp>
+      <p:sp>
+        <p:nvSpPr>
+          <p:cNvPr id="36" name="TextBox 35"/>
+          <p:cNvSpPr txBox="1"/>
+          <p:nvPr/>
+        </p:nvSpPr>
+        <p:spPr>
+          <a:xfrm>
+            <a:off x="548640" y="2980944"/>
+            <a:ext cx="2468879" cy="201168"/>
+          </a:xfrm>
+          <a:prstGeom prst="rect">
+            <a:avLst/>
+          </a:prstGeom>
+          <a:noFill/>
+        </p:spPr>
+        <p:txBody>
+          <a:bodyPr wrap="square" lIns="0" rIns="0" tIns="0" bIns="0" anchor="t">
+            <a:spAutoFit/>
+          </a:bodyPr>
+          <a:lstStyle/>
+          <a:p>
+            <a:pPr algn="ctr"/>
+            <a:r>
+              <a:rPr sz="1050" b="0">
+                <a:solidFill>
+                  <a:srgbClr val="166257"/>
+                </a:solidFill>
+                <a:latin typeface="Calibri"/>
+              </a:rPr>
+              <a:t>$150k · owned + earned</a:t>
+            </a:r>
+          </a:p>
+        </p:txBody>
+      </p:sp>
+      <p:sp>
+        <p:nvSpPr>
+          <p:cNvPr id="37" name="TextBox 36"/>
+          <p:cNvSpPr txBox="1"/>
+          <p:nvPr/>
+        </p:nvSpPr>
+        <p:spPr>
+          <a:xfrm>
+            <a:off x="548640" y="3218688"/>
+            <a:ext cx="2468879" cy="256032"/>
+          </a:xfrm>
+          <a:prstGeom prst="rect">
+            <a:avLst/>
+          </a:prstGeom>
+          <a:noFill/>
+        </p:spPr>
+        <p:txBody>
+          <a:bodyPr wrap="square" lIns="0" rIns="0" tIns="0" bIns="0" anchor="t">
+            <a:spAutoFit/>
+          </a:bodyPr>
+          <a:lstStyle/>
+          <a:p>
+            <a:pPr algn="ctr"/>
+            <a:r>
+              <a:rPr sz="1400" b="1">
+                <a:solidFill>
+                  <a:srgbClr val="152B56"/>
+                </a:solidFill>
+                <a:latin typeface="Calibri"/>
+              </a:rPr>
+              <a:t>Make AMB easy to verify</a:t>
+            </a:r>
+          </a:p>
+        </p:txBody>
+      </p:sp>
+      <p:sp>
+        <p:nvSpPr>
+          <p:cNvPr id="38" name="TextBox 37"/>
+          <p:cNvSpPr txBox="1"/>
+          <p:nvPr/>
+        </p:nvSpPr>
+        <p:spPr>
+          <a:xfrm>
+            <a:off x="594360" y="3511296"/>
+            <a:ext cx="2377439" cy="731520"/>
+          </a:xfrm>
+          <a:prstGeom prst="rect">
+            <a:avLst/>
+          </a:prstGeom>
+          <a:noFill/>
+        </p:spPr>
+        <p:txBody>
+          <a:bodyPr wrap="square" lIns="0" rIns="0" tIns="0" bIns="0" anchor="t">
+            <a:spAutoFit/>
+          </a:bodyPr>
+          <a:lstStyle/>
+          <a:p>
+            <a:pPr algn="ctr"/>
+            <a:r>
+              <a:rPr sz="1000" b="0">
+                <a:solidFill>
+                  <a:srgbClr val="556070"/>
+                </a:solidFill>
+                <a:latin typeface="Calibri"/>
+              </a:rPr>
+              <a:t>Reviews on Google and ProductReview, independent ratings, APRA and Roy Morgan proof, real rates, fees and approval times on the site; visible in search and AI answers.</a:t>
+            </a:r>
+          </a:p>
+        </p:txBody>
+      </p:sp>
+      <p:sp>
+        <p:nvSpPr>
+          <p:cNvPr id="39" name="TextBox 38"/>
+          <p:cNvSpPr txBox="1"/>
+          <p:nvPr/>
+        </p:nvSpPr>
+        <p:spPr>
+          <a:xfrm>
+            <a:off x="548640" y="4352544"/>
+            <a:ext cx="2468879" cy="201168"/>
+          </a:xfrm>
+          <a:prstGeom prst="rect">
+            <a:avLst/>
+          </a:prstGeom>
+          <a:noFill/>
+        </p:spPr>
+        <p:txBody>
+          <a:bodyPr wrap="square" lIns="0" rIns="0" tIns="0" bIns="0" anchor="t">
+            <a:spAutoFit/>
+          </a:bodyPr>
+          <a:lstStyle/>
+          <a:p>
+            <a:pPr algn="ctr"/>
+            <a:r>
+              <a:rPr sz="1050" b="1">
+                <a:solidFill>
+                  <a:srgbClr val="166257"/>
+                </a:solidFill>
+                <a:latin typeface="Calibri"/>
+              </a:rPr>
+              <a:t>Acts on: The borrower's own check</a:t>
+            </a:r>
+          </a:p>
+        </p:txBody>
       </p:sp>
       <p:pic>
         <p:nvPicPr>
-          <p:cNvPr id="15" name="Image 1" descr="preencoded.png">    </p:cNvPr>
+          <p:cNvPr id="40" name="Picture 39" descr="s11_pg4-005.jpg"/>
           <p:cNvPicPr>
             <a:picLocks noChangeAspect="1"/>
           </p:cNvPicPr>
           <p:nvPr/>
         </p:nvPicPr>
         <p:blipFill>
-          <a:blip r:embed="rId2"/>
+          <a:blip r:embed="rId7"/>
           <a:stretch>
             <a:fillRect/>
           </a:stretch>
         </p:blipFill>
         <p:spPr>
           <a:xfrm>
-            <a:off x="3575670" y="1490838"/>
-            <a:ext cx="218724" cy="218724"/>
-          </a:xfrm>
-          <a:prstGeom prst="rect">
+            <a:off x="3959352" y="1188719"/>
+            <a:ext cx="1225296" cy="1225296"/>
+          </a:xfrm>
+          <a:prstGeom prst="ellipse">
             <a:avLst/>
           </a:prstGeom>
         </p:spPr>
       </p:pic>
       <p:sp>
         <p:nvSpPr>
-          <p:cNvPr id="16" name="Text 11"/>
-          <p:cNvSpPr txBox="1"/>
-          <p:nvPr/>
-        </p:nvSpPr>
-        <p:spPr>
-          <a:xfrm>
-            <a:off x="4343400" y="1298448"/>
-            <a:ext cx="1371600" cy="457200"/>
-          </a:xfrm>
-          <a:prstGeom prst="rect">
-            <a:avLst/>
-          </a:prstGeom>
-          <a:noFill/>
-          <a:ln/>
-        </p:spPr>
-        <p:txBody>
-          <a:bodyPr wrap="square" lIns="0" tIns="0" rIns="0" bIns="0" rtlCol="0" anchor="ctr"/>
-          <a:lstStyle/>
-          <a:p>
-            <a:pPr algn="r" indent="0" marL="0">
-              <a:buNone/>
-            </a:pPr>
-            <a:r>
-              <a:rPr lang="en-US" sz="3000" b="1" dirty="0">
-                <a:solidFill>
-                  <a:srgbClr val="1F8F74"/>
-                </a:solidFill>
-                <a:latin typeface="Cambria" pitchFamily="34" charset="0"/>
-                <a:ea typeface="Cambria" pitchFamily="34" charset="-122"/>
-                <a:cs typeface="Cambria" pitchFamily="34" charset="-120"/>
+          <p:cNvPr id="41" name="Oval 40"/>
+          <p:cNvSpPr/>
+          <p:nvPr/>
+        </p:nvSpPr>
+        <p:spPr>
+          <a:xfrm>
+            <a:off x="3895344" y="1124711"/>
+            <a:ext cx="1353312" cy="1353312"/>
+          </a:xfrm>
+          <a:prstGeom prst="ellipse">
+            <a:avLst/>
+          </a:prstGeom>
+          <a:noFill/>
+          <a:ln w="15875">
+            <a:solidFill>
+              <a:srgbClr val="1F8F74"/>
+            </a:solidFill>
+          </a:ln>
+          <a:effectLst/>
+        </p:spPr>
+        <p:style>
+          <a:lnRef idx="1">
+            <a:schemeClr val="accent1"/>
+          </a:lnRef>
+          <a:fillRef idx="3">
+            <a:schemeClr val="accent1"/>
+          </a:fillRef>
+          <a:effectRef idx="2">
+            <a:schemeClr val="accent1"/>
+          </a:effectRef>
+          <a:fontRef idx="minor">
+            <a:schemeClr val="lt1"/>
+          </a:fontRef>
+        </p:style>
+        <p:txBody>
+          <a:bodyPr rtlCol="0" anchor="ctr"/>
+          <a:lstStyle/>
+          <a:p>
+            <a:pPr algn="ctr"/>
+          </a:p>
+        </p:txBody>
+      </p:sp>
+      <p:sp>
+        <p:nvSpPr>
+          <p:cNvPr id="42" name="TextBox 41"/>
+          <p:cNvSpPr txBox="1"/>
+          <p:nvPr/>
+        </p:nvSpPr>
+        <p:spPr>
+          <a:xfrm>
+            <a:off x="3337560" y="2523744"/>
+            <a:ext cx="2468879" cy="457200"/>
+          </a:xfrm>
+          <a:prstGeom prst="rect">
+            <a:avLst/>
+          </a:prstGeom>
+          <a:noFill/>
+        </p:spPr>
+        <p:txBody>
+          <a:bodyPr wrap="square" lIns="0" rIns="0" tIns="0" bIns="0" anchor="t">
+            <a:spAutoFit/>
+          </a:bodyPr>
+          <a:lstStyle/>
+          <a:p>
+            <a:pPr algn="ctr"/>
+            <a:r>
+              <a:rPr sz="3000" b="1">
+                <a:solidFill>
+                  <a:srgbClr val="152B56"/>
+                </a:solidFill>
+                <a:latin typeface="Cambria"/>
               </a:rPr>
               <a:t>55%</a:t>
             </a:r>
-            <a:endParaRPr lang="en-US" sz="3000" dirty="0"/>
-          </a:p>
-        </p:txBody>
-      </p:sp>
-      <p:sp>
-        <p:nvSpPr>
-          <p:cNvPr id="17" name="Text 12"/>
-          <p:cNvSpPr txBox="1"/>
-          <p:nvPr/>
-        </p:nvSpPr>
-        <p:spPr>
-          <a:xfrm>
-            <a:off x="3977640" y="1737360"/>
-            <a:ext cx="1737360" cy="228600"/>
-          </a:xfrm>
-          <a:prstGeom prst="rect">
-            <a:avLst/>
-          </a:prstGeom>
-          <a:noFill/>
-          <a:ln/>
-        </p:spPr>
-        <p:txBody>
-          <a:bodyPr wrap="square" lIns="0" tIns="0" rIns="0" bIns="0" rtlCol="0" anchor="t"/>
-          <a:lstStyle/>
-          <a:p>
-            <a:pPr algn="r" indent="0" marL="0">
-              <a:buNone/>
-            </a:pPr>
-            <a:r>
-              <a:rPr lang="en-US" sz="1100" dirty="0">
-                <a:solidFill>
-                  <a:srgbClr val="C9D6E8"/>
-                </a:solidFill>
-                <a:latin typeface="Calibri" pitchFamily="34" charset="0"/>
-                <a:ea typeface="Calibri" pitchFamily="34" charset="-122"/>
-                <a:cs typeface="Calibri" pitchFamily="34" charset="-120"/>
+          </a:p>
+        </p:txBody>
+      </p:sp>
+      <p:sp>
+        <p:nvSpPr>
+          <p:cNvPr id="43" name="TextBox 42"/>
+          <p:cNvSpPr txBox="1"/>
+          <p:nvPr/>
+        </p:nvSpPr>
+        <p:spPr>
+          <a:xfrm>
+            <a:off x="3337560" y="2980944"/>
+            <a:ext cx="2468879" cy="201168"/>
+          </a:xfrm>
+          <a:prstGeom prst="rect">
+            <a:avLst/>
+          </a:prstGeom>
+          <a:noFill/>
+        </p:spPr>
+        <p:txBody>
+          <a:bodyPr wrap="square" lIns="0" rIns="0" tIns="0" bIns="0" anchor="t">
+            <a:spAutoFit/>
+          </a:bodyPr>
+          <a:lstStyle/>
+          <a:p>
+            <a:pPr algn="ctr"/>
+            <a:r>
+              <a:rPr sz="1050" b="0">
+                <a:solidFill>
+                  <a:srgbClr val="166257"/>
+                </a:solidFill>
+                <a:latin typeface="Calibri"/>
               </a:rPr>
               <a:t>$412.5k · paid + owned</a:t>
             </a:r>
-            <a:endParaRPr lang="en-US" sz="1100" dirty="0"/>
-          </a:p>
-        </p:txBody>
-      </p:sp>
-      <p:sp>
-        <p:nvSpPr>
-          <p:cNvPr id="18" name="Text 13"/>
-          <p:cNvSpPr txBox="1"/>
-          <p:nvPr/>
-        </p:nvSpPr>
-        <p:spPr>
-          <a:xfrm>
-            <a:off x="3474720" y="2029968"/>
-            <a:ext cx="2240280" cy="457200"/>
-          </a:xfrm>
-          <a:prstGeom prst="rect">
-            <a:avLst/>
-          </a:prstGeom>
-          <a:noFill/>
-          <a:ln/>
-        </p:spPr>
-        <p:txBody>
-          <a:bodyPr wrap="square" lIns="0" tIns="0" rIns="0" bIns="0" rtlCol="0" anchor="t"/>
-          <a:lstStyle/>
-          <a:p>
-            <a:pPr indent="0" marL="0">
-              <a:buNone/>
-            </a:pPr>
-            <a:r>
-              <a:rPr lang="en-US" sz="1500" b="1" dirty="0">
-                <a:solidFill>
-                  <a:srgbClr val="FFFFFF"/>
-                </a:solidFill>
-                <a:latin typeface="Calibri" pitchFamily="34" charset="0"/>
-                <a:ea typeface="Calibri" pitchFamily="34" charset="-122"/>
-                <a:cs typeface="Calibri" pitchFamily="34" charset="-120"/>
+          </a:p>
+        </p:txBody>
+      </p:sp>
+      <p:sp>
+        <p:nvSpPr>
+          <p:cNvPr id="44" name="TextBox 43"/>
+          <p:cNvSpPr txBox="1"/>
+          <p:nvPr/>
+        </p:nvSpPr>
+        <p:spPr>
+          <a:xfrm>
+            <a:off x="3337560" y="3218688"/>
+            <a:ext cx="2468879" cy="256032"/>
+          </a:xfrm>
+          <a:prstGeom prst="rect">
+            <a:avLst/>
+          </a:prstGeom>
+          <a:noFill/>
+        </p:spPr>
+        <p:txBody>
+          <a:bodyPr wrap="square" lIns="0" rIns="0" tIns="0" bIns="0" anchor="t">
+            <a:spAutoFit/>
+          </a:bodyPr>
+          <a:lstStyle/>
+          <a:p>
+            <a:pPr algn="ctr"/>
+            <a:r>
+              <a:rPr sz="1400" b="1">
+                <a:solidFill>
+                  <a:srgbClr val="152B56"/>
+                </a:solidFill>
+                <a:latin typeface="Calibri"/>
               </a:rPr>
               <a:t>Enter the broker's working set</a:t>
             </a:r>
-            <a:endParaRPr lang="en-US" sz="1500" dirty="0"/>
-          </a:p>
-        </p:txBody>
-      </p:sp>
-      <p:sp>
-        <p:nvSpPr>
-          <p:cNvPr id="19" name="Text 14"/>
-          <p:cNvSpPr txBox="1"/>
-          <p:nvPr/>
-        </p:nvSpPr>
-        <p:spPr>
-          <a:xfrm>
-            <a:off x="3474720" y="2514600"/>
-            <a:ext cx="2240280" cy="1325880"/>
-          </a:xfrm>
-          <a:prstGeom prst="rect">
-            <a:avLst/>
-          </a:prstGeom>
-          <a:noFill/>
-          <a:ln/>
-        </p:spPr>
-        <p:txBody>
-          <a:bodyPr wrap="square" lIns="0" tIns="0" rIns="0" bIns="0" rtlCol="0" anchor="t"/>
-          <a:lstStyle/>
-          <a:p>
-            <a:pPr indent="0" marL="0">
-              <a:buNone/>
-            </a:pPr>
-            <a:r>
-              <a:rPr lang="en-US" sz="1200" dirty="0">
-                <a:solidFill>
-                  <a:srgbClr val="C9D6E8"/>
-                </a:solidFill>
-                <a:latin typeface="Calibri" pitchFamily="34" charset="0"/>
-                <a:ea typeface="Calibri" pitchFamily="34" charset="-122"/>
-                <a:cs typeface="Calibri" pitchFamily="34" charset="-120"/>
+          </a:p>
+        </p:txBody>
+      </p:sp>
+      <p:sp>
+        <p:nvSpPr>
+          <p:cNvPr id="45" name="TextBox 44"/>
+          <p:cNvSpPr txBox="1"/>
+          <p:nvPr/>
+        </p:nvSpPr>
+        <p:spPr>
+          <a:xfrm>
+            <a:off x="3383279" y="3511296"/>
+            <a:ext cx="2377439" cy="731520"/>
+          </a:xfrm>
+          <a:prstGeom prst="rect">
+            <a:avLst/>
+          </a:prstGeom>
+          <a:noFill/>
+        </p:spPr>
+        <p:txBody>
+          <a:bodyPr wrap="square" lIns="0" rIns="0" tIns="0" bIns="0" anchor="t">
+            <a:spAutoFit/>
+          </a:bodyPr>
+          <a:lstStyle/>
+          <a:p>
+            <a:pPr algn="ctr"/>
+            <a:r>
+              <a:rPr sz="1000" b="0">
+                <a:solidFill>
+                  <a:srgbClr val="556070"/>
+                </a:solidFill>
+                <a:latin typeface="Calibri"/>
               </a:rPr>
               <a:t>Confirm AMB brand accreditation on the major panels (XXX); a digital proof pack and listing on aggregator broker platforms; live tracking of a 48-hour turnaround commitment; BDM coverage behind it.</a:t>
             </a:r>
-            <a:endParaRPr lang="en-US" sz="1200" dirty="0"/>
-          </a:p>
-        </p:txBody>
-      </p:sp>
-      <p:sp>
-        <p:nvSpPr>
-          <p:cNvPr id="20" name="Text 15"/>
-          <p:cNvSpPr txBox="1"/>
-          <p:nvPr/>
-        </p:nvSpPr>
-        <p:spPr>
-          <a:xfrm>
-            <a:off x="3474720" y="3931920"/>
-            <a:ext cx="2240280" cy="365760"/>
-          </a:xfrm>
-          <a:prstGeom prst="rect">
-            <a:avLst/>
-          </a:prstGeom>
-          <a:noFill/>
-          <a:ln/>
-        </p:spPr>
-        <p:txBody>
-          <a:bodyPr wrap="square" lIns="0" tIns="0" rIns="0" bIns="0" rtlCol="0" anchor="t"/>
-          <a:lstStyle/>
-          <a:p>
-            <a:pPr indent="0" marL="0">
-              <a:buNone/>
-            </a:pPr>
-            <a:r>
-              <a:rPr lang="en-US" sz="1150" b="1" dirty="0">
-                <a:solidFill>
-                  <a:srgbClr val="1F8F74"/>
-                </a:solidFill>
-                <a:latin typeface="Calibri" pitchFamily="34" charset="0"/>
-                <a:ea typeface="Calibri" pitchFamily="34" charset="-122"/>
-                <a:cs typeface="Calibri" pitchFamily="34" charset="-120"/>
-              </a:rPr>
-              <a:t>Acts on: </a:t>
-            </a:r>
-            <a:pPr indent="0" marL="0">
-              <a:buNone/>
-            </a:pPr>
-            <a:r>
-              <a:rPr lang="en-US" sz="1150" dirty="0">
-                <a:solidFill>
-                  <a:srgbClr val="1F8F74"/>
-                </a:solidFill>
-                <a:latin typeface="Calibri" pitchFamily="34" charset="0"/>
-                <a:ea typeface="Calibri" pitchFamily="34" charset="-122"/>
-                <a:cs typeface="Calibri" pitchFamily="34" charset="-120"/>
-              </a:rPr>
-              <a:t>The broker's shortlist</a:t>
-            </a:r>
-            <a:endParaRPr lang="en-US" sz="1150" dirty="0"/>
-          </a:p>
-        </p:txBody>
-      </p:sp>
-      <p:sp>
-        <p:nvSpPr>
-          <p:cNvPr id="21" name="Shape 16"/>
-          <p:cNvSpPr/>
-          <p:nvPr/>
-        </p:nvSpPr>
-        <p:spPr>
-          <a:xfrm>
-            <a:off x="6035040" y="1234440"/>
-            <a:ext cx="2651760" cy="3154680"/>
-          </a:xfrm>
-          <a:prstGeom prst="roundRect">
-            <a:avLst>
-              <a:gd name="adj" fmla="val 2759"/>
-            </a:avLst>
-          </a:prstGeom>
-          <a:solidFill>
-            <a:srgbClr val="F1F4F9"/>
-          </a:solidFill>
-          <a:ln w="12700">
-            <a:solidFill>
-              <a:srgbClr val="F1F4F9"/>
-            </a:solidFill>
-            <a:prstDash val="solid"/>
-          </a:ln>
-        </p:spPr>
-      </p:sp>
-      <p:sp>
-        <p:nvSpPr>
-          <p:cNvPr id="22" name="Shape 17"/>
-          <p:cNvSpPr/>
-          <p:nvPr/>
-        </p:nvSpPr>
-        <p:spPr>
-          <a:xfrm>
-            <a:off x="6263640" y="1389888"/>
-            <a:ext cx="420624" cy="420624"/>
-          </a:xfrm>
-          <a:prstGeom prst="ellipse">
-            <a:avLst/>
-          </a:prstGeom>
-          <a:solidFill>
-            <a:srgbClr val="152B56"/>
-          </a:solidFill>
-          <a:ln w="12700">
-            <a:solidFill>
-              <a:srgbClr val="152B56"/>
-            </a:solidFill>
-            <a:prstDash val="solid"/>
-          </a:ln>
-        </p:spPr>
+          </a:p>
+        </p:txBody>
+      </p:sp>
+      <p:sp>
+        <p:nvSpPr>
+          <p:cNvPr id="46" name="TextBox 45"/>
+          <p:cNvSpPr txBox="1"/>
+          <p:nvPr/>
+        </p:nvSpPr>
+        <p:spPr>
+          <a:xfrm>
+            <a:off x="3337560" y="4352544"/>
+            <a:ext cx="2468879" cy="201168"/>
+          </a:xfrm>
+          <a:prstGeom prst="rect">
+            <a:avLst/>
+          </a:prstGeom>
+          <a:noFill/>
+        </p:spPr>
+        <p:txBody>
+          <a:bodyPr wrap="square" lIns="0" rIns="0" tIns="0" bIns="0" anchor="t">
+            <a:spAutoFit/>
+          </a:bodyPr>
+          <a:lstStyle/>
+          <a:p>
+            <a:pPr algn="ctr"/>
+            <a:r>
+              <a:rPr sz="1050" b="1">
+                <a:solidFill>
+                  <a:srgbClr val="166257"/>
+                </a:solidFill>
+                <a:latin typeface="Calibri"/>
+              </a:rPr>
+              <a:t>Acts on: The broker's shortlist</a:t>
+            </a:r>
+          </a:p>
+        </p:txBody>
       </p:sp>
       <p:pic>
         <p:nvPicPr>
-          <p:cNvPr id="23" name="Image 2" descr="preencoded.png">    </p:cNvPr>
+          <p:cNvPr id="47" name="Picture 46" descr="s11_pg4-002.jpg"/>
           <p:cNvPicPr>
             <a:picLocks noChangeAspect="1"/>
           </p:cNvPicPr>
           <p:nvPr/>
         </p:nvPicPr>
         <p:blipFill>
-          <a:blip r:embed="rId3"/>
+          <a:blip r:embed="rId8"/>
           <a:stretch>
             <a:fillRect/>
           </a:stretch>
         </p:blipFill>
         <p:spPr>
           <a:xfrm>
-            <a:off x="6364590" y="1490838"/>
-            <a:ext cx="218724" cy="218724"/>
-          </a:xfrm>
-          <a:prstGeom prst="rect">
+            <a:off x="6949439" y="1389888"/>
+            <a:ext cx="822960" cy="822960"/>
+          </a:xfrm>
+          <a:prstGeom prst="ellipse">
             <a:avLst/>
           </a:prstGeom>
         </p:spPr>
       </p:pic>
       <p:sp>
         <p:nvSpPr>
-          <p:cNvPr id="24" name="Text 18"/>
-          <p:cNvSpPr txBox="1"/>
-          <p:nvPr/>
-        </p:nvSpPr>
-        <p:spPr>
-          <a:xfrm>
-            <a:off x="7132320" y="1298448"/>
-            <a:ext cx="1371600" cy="457200"/>
-          </a:xfrm>
-          <a:prstGeom prst="rect">
-            <a:avLst/>
-          </a:prstGeom>
-          <a:noFill/>
-          <a:ln/>
-        </p:spPr>
-        <p:txBody>
-          <a:bodyPr wrap="square" lIns="0" tIns="0" rIns="0" bIns="0" rtlCol="0" anchor="ctr"/>
-          <a:lstStyle/>
-          <a:p>
-            <a:pPr algn="r" indent="0" marL="0">
-              <a:buNone/>
-            </a:pPr>
-            <a:r>
-              <a:rPr lang="en-US" sz="3000" b="1" dirty="0">
+          <p:cNvPr id="48" name="Oval 47"/>
+          <p:cNvSpPr/>
+          <p:nvPr/>
+        </p:nvSpPr>
+        <p:spPr>
+          <a:xfrm>
+            <a:off x="6885431" y="1325880"/>
+            <a:ext cx="950976" cy="950976"/>
+          </a:xfrm>
+          <a:prstGeom prst="ellipse">
+            <a:avLst/>
+          </a:prstGeom>
+          <a:noFill/>
+          <a:ln w="15875">
+            <a:solidFill>
+              <a:srgbClr val="1F8F74"/>
+            </a:solidFill>
+          </a:ln>
+          <a:effectLst/>
+        </p:spPr>
+        <p:style>
+          <a:lnRef idx="1">
+            <a:schemeClr val="accent1"/>
+          </a:lnRef>
+          <a:fillRef idx="3">
+            <a:schemeClr val="accent1"/>
+          </a:fillRef>
+          <a:effectRef idx="2">
+            <a:schemeClr val="accent1"/>
+          </a:effectRef>
+          <a:fontRef idx="minor">
+            <a:schemeClr val="lt1"/>
+          </a:fontRef>
+        </p:style>
+        <p:txBody>
+          <a:bodyPr rtlCol="0" anchor="ctr"/>
+          <a:lstStyle/>
+          <a:p>
+            <a:pPr algn="ctr"/>
+          </a:p>
+        </p:txBody>
+      </p:sp>
+      <p:sp>
+        <p:nvSpPr>
+          <p:cNvPr id="49" name="TextBox 48"/>
+          <p:cNvSpPr txBox="1"/>
+          <p:nvPr/>
+        </p:nvSpPr>
+        <p:spPr>
+          <a:xfrm>
+            <a:off x="6126479" y="2523744"/>
+            <a:ext cx="2468879" cy="457200"/>
+          </a:xfrm>
+          <a:prstGeom prst="rect">
+            <a:avLst/>
+          </a:prstGeom>
+          <a:noFill/>
+        </p:spPr>
+        <p:txBody>
+          <a:bodyPr wrap="square" lIns="0" rIns="0" tIns="0" bIns="0" anchor="t">
+            <a:spAutoFit/>
+          </a:bodyPr>
+          <a:lstStyle/>
+          <a:p>
+            <a:pPr algn="ctr"/>
+            <a:r>
+              <a:rPr sz="3000" b="1">
+                <a:solidFill>
+                  <a:srgbClr val="152B56"/>
+                </a:solidFill>
+                <a:latin typeface="Cambria"/>
+              </a:rPr>
+              <a:t>15%</a:t>
+            </a:r>
+          </a:p>
+        </p:txBody>
+      </p:sp>
+      <p:sp>
+        <p:nvSpPr>
+          <p:cNvPr id="50" name="TextBox 49"/>
+          <p:cNvSpPr txBox="1"/>
+          <p:nvPr/>
+        </p:nvSpPr>
+        <p:spPr>
+          <a:xfrm>
+            <a:off x="6126479" y="2980944"/>
+            <a:ext cx="2468879" cy="201168"/>
+          </a:xfrm>
+          <a:prstGeom prst="rect">
+            <a:avLst/>
+          </a:prstGeom>
+          <a:noFill/>
+        </p:spPr>
+        <p:txBody>
+          <a:bodyPr wrap="square" lIns="0" rIns="0" tIns="0" bIns="0" anchor="t">
+            <a:spAutoFit/>
+          </a:bodyPr>
+          <a:lstStyle/>
+          <a:p>
+            <a:pPr algn="ctr"/>
+            <a:r>
+              <a:rPr sz="1050" b="0">
                 <a:solidFill>
                   <a:srgbClr val="166257"/>
                 </a:solidFill>
-                <a:latin typeface="Cambria" pitchFamily="34" charset="0"/>
-                <a:ea typeface="Cambria" pitchFamily="34" charset="-122"/>
-                <a:cs typeface="Cambria" pitchFamily="34" charset="-120"/>
-              </a:rPr>
-              <a:t>15%</a:t>
-            </a:r>
-            <a:endParaRPr lang="en-US" sz="3000" dirty="0"/>
-          </a:p>
-        </p:txBody>
-      </p:sp>
-      <p:sp>
-        <p:nvSpPr>
-          <p:cNvPr id="25" name="Text 19"/>
-          <p:cNvSpPr txBox="1"/>
-          <p:nvPr/>
-        </p:nvSpPr>
-        <p:spPr>
-          <a:xfrm>
-            <a:off x="6766560" y="1737360"/>
-            <a:ext cx="1737360" cy="228600"/>
-          </a:xfrm>
-          <a:prstGeom prst="rect">
-            <a:avLst/>
-          </a:prstGeom>
-          <a:noFill/>
-          <a:ln/>
-        </p:spPr>
-        <p:txBody>
-          <a:bodyPr wrap="square" lIns="0" tIns="0" rIns="0" bIns="0" rtlCol="0" anchor="t"/>
-          <a:lstStyle/>
-          <a:p>
-            <a:pPr algn="r" indent="0" marL="0">
-              <a:buNone/>
-            </a:pPr>
-            <a:r>
-              <a:rPr lang="en-US" sz="1100" dirty="0">
+                <a:latin typeface="Calibri"/>
+              </a:rPr>
+              <a:t>$112.5k · earned</a:t>
+            </a:r>
+          </a:p>
+        </p:txBody>
+      </p:sp>
+      <p:sp>
+        <p:nvSpPr>
+          <p:cNvPr id="51" name="TextBox 50"/>
+          <p:cNvSpPr txBox="1"/>
+          <p:nvPr/>
+        </p:nvSpPr>
+        <p:spPr>
+          <a:xfrm>
+            <a:off x="6126479" y="3218688"/>
+            <a:ext cx="2468879" cy="256032"/>
+          </a:xfrm>
+          <a:prstGeom prst="rect">
+            <a:avLst/>
+          </a:prstGeom>
+          <a:noFill/>
+        </p:spPr>
+        <p:txBody>
+          <a:bodyPr wrap="square" lIns="0" rIns="0" tIns="0" bIns="0" anchor="t">
+            <a:spAutoFit/>
+          </a:bodyPr>
+          <a:lstStyle/>
+          <a:p>
+            <a:pPr algn="ctr"/>
+            <a:r>
+              <a:rPr sz="1400" b="1">
+                <a:solidFill>
+                  <a:srgbClr val="152B56"/>
+                </a:solidFill>
+                <a:latin typeface="Calibri"/>
+              </a:rPr>
+              <a:t>Member check-your-offer link</a:t>
+            </a:r>
+          </a:p>
+        </p:txBody>
+      </p:sp>
+      <p:sp>
+        <p:nvSpPr>
+          <p:cNvPr id="52" name="TextBox 51"/>
+          <p:cNvSpPr txBox="1"/>
+          <p:nvPr/>
+        </p:nvSpPr>
+        <p:spPr>
+          <a:xfrm>
+            <a:off x="6172199" y="3511296"/>
+            <a:ext cx="2377439" cy="731520"/>
+          </a:xfrm>
+          <a:prstGeom prst="rect">
+            <a:avLst/>
+          </a:prstGeom>
+          <a:noFill/>
+        </p:spPr>
+        <p:txBody>
+          <a:bodyPr wrap="square" lIns="0" rIns="0" tIns="0" bIns="0" anchor="t">
+            <a:spAutoFit/>
+          </a:bodyPr>
+          <a:lstStyle/>
+          <a:p>
+            <a:pPr algn="ctr"/>
+            <a:r>
+              <a:rPr sz="1000" b="0">
                 <a:solidFill>
                   <a:srgbClr val="556070"/>
                 </a:solidFill>
-                <a:latin typeface="Calibri" pitchFamily="34" charset="0"/>
-                <a:ea typeface="Calibri" pitchFamily="34" charset="-122"/>
-                <a:cs typeface="Calibri" pitchFamily="34" charset="-120"/>
-              </a:rPr>
-              <a:t>$112.5k · earned</a:t>
-            </a:r>
-            <a:endParaRPr lang="en-US" sz="1100" dirty="0"/>
-          </a:p>
-        </p:txBody>
-      </p:sp>
-      <p:sp>
-        <p:nvSpPr>
-          <p:cNvPr id="26" name="Text 20"/>
-          <p:cNvSpPr txBox="1"/>
-          <p:nvPr/>
-        </p:nvSpPr>
-        <p:spPr>
-          <a:xfrm>
-            <a:off x="6263640" y="2029968"/>
-            <a:ext cx="2240280" cy="457200"/>
-          </a:xfrm>
-          <a:prstGeom prst="rect">
-            <a:avLst/>
-          </a:prstGeom>
-          <a:noFill/>
-          <a:ln/>
-        </p:spPr>
-        <p:txBody>
-          <a:bodyPr wrap="square" lIns="0" tIns="0" rIns="0" bIns="0" rtlCol="0" anchor="t"/>
-          <a:lstStyle/>
-          <a:p>
-            <a:pPr indent="0" marL="0">
-              <a:buNone/>
-            </a:pPr>
-            <a:r>
-              <a:rPr lang="en-US" sz="1500" b="1" dirty="0">
-                <a:solidFill>
-                  <a:srgbClr val="152B56"/>
-                </a:solidFill>
-                <a:latin typeface="Calibri" pitchFamily="34" charset="0"/>
-                <a:ea typeface="Calibri" pitchFamily="34" charset="-122"/>
-                <a:cs typeface="Calibri" pitchFamily="34" charset="-120"/>
-              </a:rPr>
-              <a:t>Member check-your-offer link</a:t>
-            </a:r>
-            <a:endParaRPr lang="en-US" sz="1500" dirty="0"/>
-          </a:p>
-        </p:txBody>
-      </p:sp>
-      <p:sp>
-        <p:nvSpPr>
-          <p:cNvPr id="27" name="Text 21"/>
-          <p:cNvSpPr txBox="1"/>
-          <p:nvPr/>
-        </p:nvSpPr>
-        <p:spPr>
-          <a:xfrm>
-            <a:off x="6263640" y="2514600"/>
-            <a:ext cx="2240280" cy="1325880"/>
-          </a:xfrm>
-          <a:prstGeom prst="rect">
-            <a:avLst/>
-          </a:prstGeom>
-          <a:noFill/>
-          <a:ln/>
-        </p:spPr>
-        <p:txBody>
-          <a:bodyPr wrap="square" lIns="0" tIns="0" rIns="0" bIns="0" rtlCol="0" anchor="t"/>
-          <a:lstStyle/>
-          <a:p>
-            <a:pPr indent="0" marL="0">
-              <a:buNone/>
-            </a:pPr>
-            <a:r>
-              <a:rPr lang="en-US" sz="1200" dirty="0">
-                <a:solidFill>
-                  <a:srgbClr val="1E2633"/>
-                </a:solidFill>
-                <a:latin typeface="Calibri" pitchFamily="34" charset="0"/>
-                <a:ea typeface="Calibri" pitchFamily="34" charset="-122"/>
-                <a:cs typeface="Calibri" pitchFamily="34" charset="-120"/>
+                <a:latin typeface="Calibri"/>
               </a:rPr>
               <a:t>A member sends a friend one link; the friend uploads the offer they already have; AMB returns a firm rate within 24 hours. Tracked from link to settlement.</a:t>
             </a:r>
-            <a:endParaRPr lang="en-US" sz="1200" dirty="0"/>
-          </a:p>
-        </p:txBody>
-      </p:sp>
-      <p:sp>
-        <p:nvSpPr>
-          <p:cNvPr id="28" name="Text 22"/>
-          <p:cNvSpPr txBox="1"/>
-          <p:nvPr/>
-        </p:nvSpPr>
-        <p:spPr>
-          <a:xfrm>
-            <a:off x="6263640" y="3931920"/>
-            <a:ext cx="2240280" cy="365760"/>
-          </a:xfrm>
-          <a:prstGeom prst="rect">
-            <a:avLst/>
-          </a:prstGeom>
-          <a:noFill/>
-          <a:ln/>
-        </p:spPr>
-        <p:txBody>
-          <a:bodyPr wrap="square" lIns="0" tIns="0" rIns="0" bIns="0" rtlCol="0" anchor="t"/>
-          <a:lstStyle/>
-          <a:p>
-            <a:pPr indent="0" marL="0">
-              <a:buNone/>
-            </a:pPr>
-            <a:r>
-              <a:rPr lang="en-US" sz="1150" b="1" dirty="0">
+          </a:p>
+        </p:txBody>
+      </p:sp>
+      <p:sp>
+        <p:nvSpPr>
+          <p:cNvPr id="53" name="TextBox 52"/>
+          <p:cNvSpPr txBox="1"/>
+          <p:nvPr/>
+        </p:nvSpPr>
+        <p:spPr>
+          <a:xfrm>
+            <a:off x="6126479" y="4352544"/>
+            <a:ext cx="2468879" cy="201168"/>
+          </a:xfrm>
+          <a:prstGeom prst="rect">
+            <a:avLst/>
+          </a:prstGeom>
+          <a:noFill/>
+        </p:spPr>
+        <p:txBody>
+          <a:bodyPr wrap="square" lIns="0" rIns="0" tIns="0" bIns="0" anchor="t">
+            <a:spAutoFit/>
+          </a:bodyPr>
+          <a:lstStyle/>
+          <a:p>
+            <a:pPr algn="ctr"/>
+            <a:r>
+              <a:rPr sz="1050" b="1">
                 <a:solidFill>
                   <a:srgbClr val="166257"/>
                 </a:solidFill>
-                <a:latin typeface="Calibri" pitchFamily="34" charset="0"/>
-                <a:ea typeface="Calibri" pitchFamily="34" charset="-122"/>
-                <a:cs typeface="Calibri" pitchFamily="34" charset="-120"/>
-              </a:rPr>
-              <a:t>Acts on: </a:t>
-            </a:r>
-            <a:pPr indent="0" marL="0">
-              <a:buNone/>
-            </a:pPr>
-            <a:r>
-              <a:rPr lang="en-US" sz="1150" dirty="0">
-                <a:solidFill>
-                  <a:srgbClr val="166257"/>
-                </a:solidFill>
-                <a:latin typeface="Calibri" pitchFamily="34" charset="0"/>
-                <a:ea typeface="Calibri" pitchFamily="34" charset="-122"/>
-                <a:cs typeface="Calibri" pitchFamily="34" charset="-120"/>
-              </a:rPr>
-              <a:t>The friend's recommendation</a:t>
-            </a:r>
-            <a:endParaRPr lang="en-US" sz="1150" dirty="0"/>
-          </a:p>
-        </p:txBody>
-      </p:sp>
-      <p:sp>
-        <p:nvSpPr>
-          <p:cNvPr id="29" name="Text 23"/>
-          <p:cNvSpPr txBox="1"/>
-          <p:nvPr/>
-        </p:nvSpPr>
-        <p:spPr>
-          <a:xfrm>
-            <a:off x="457200" y="4645152"/>
-            <a:ext cx="7680960" cy="347472"/>
-          </a:xfrm>
-          <a:prstGeom prst="rect">
-            <a:avLst/>
-          </a:prstGeom>
-          <a:noFill/>
-          <a:ln/>
-        </p:spPr>
-        <p:txBody>
-          <a:bodyPr wrap="square" lIns="0" tIns="0" rIns="0" bIns="0" rtlCol="0" anchor="t"/>
-          <a:lstStyle/>
-          <a:p>
-            <a:pPr indent="0" marL="0">
-              <a:buNone/>
-            </a:pPr>
-            <a:r>
-              <a:rPr lang="en-US" sz="1000" dirty="0">
-                <a:solidFill>
-                  <a:srgbClr val="556070"/>
-                </a:solidFill>
-                <a:latin typeface="Calibri" pitchFamily="34" charset="0"/>
-                <a:ea typeface="Calibri" pitchFamily="34" charset="-122"/>
-                <a:cs typeface="Calibri" pitchFamily="34" charset="-120"/>
-              </a:rPr>
-              <a:t>Remaining 10% to measurement and testing. Split is indicative and will be re-derived from cost per funded loan by channel once the pilot reports.</a:t>
-            </a:r>
-            <a:endParaRPr lang="en-US" sz="1000" dirty="0"/>
-          </a:p>
-        </p:txBody>
-      </p:sp>
-      <p:sp>
-        <p:nvSpPr>
-          <p:cNvPr id="30" name="Text 24"/>
-          <p:cNvSpPr txBox="1"/>
-          <p:nvPr/>
-        </p:nvSpPr>
-        <p:spPr>
-          <a:xfrm>
-            <a:off x="8229600" y="4754880"/>
-            <a:ext cx="457200" cy="228600"/>
-          </a:xfrm>
-          <a:prstGeom prst="rect">
-            <a:avLst/>
-          </a:prstGeom>
-          <a:noFill/>
-          <a:ln/>
-        </p:spPr>
-        <p:txBody>
-          <a:bodyPr wrap="square" lIns="0" tIns="0" rIns="0" bIns="0" rtlCol="0" anchor="ctr"/>
-          <a:lstStyle/>
-          <a:p>
-            <a:pPr algn="r" indent="0" marL="0">
-              <a:buNone/>
-            </a:pPr>
-            <a:r>
-              <a:rPr lang="en-US" sz="1000" dirty="0">
-                <a:solidFill>
-                  <a:srgbClr val="556070"/>
-                </a:solidFill>
-                <a:latin typeface="Calibri" pitchFamily="34" charset="0"/>
-                <a:ea typeface="Calibri" pitchFamily="34" charset="-122"/>
-                <a:cs typeface="Calibri" pitchFamily="34" charset="-120"/>
-              </a:rPr>
-              <a:t>11</a:t>
-            </a:r>
-            <a:endParaRPr lang="en-US" sz="1000" dirty="0"/>
+                <a:latin typeface="Calibri"/>
+              </a:rPr>
+              <a:t>Acts on: The friend's recommendation</a:t>
+            </a:r>
           </a:p>
         </p:txBody>
       </p:sp>
@@ -5890,6 +6012,50 @@
       </p:sp>
       <p:sp>
         <p:nvSpPr>
+          <p:cNvPr id="39" name="Rectangle 38"/>
+          <p:cNvSpPr/>
+          <p:nvPr/>
+        </p:nvSpPr>
+        <p:spPr>
+          <a:xfrm>
+            <a:off x="457200" y="2194560"/>
+            <a:ext cx="8229600" cy="9144"/>
+          </a:xfrm>
+          <a:prstGeom prst="rect">
+            <a:avLst/>
+          </a:prstGeom>
+          <a:solidFill>
+            <a:srgbClr val="D9DEE7"/>
+          </a:solidFill>
+          <a:ln>
+            <a:noFill/>
+          </a:ln>
+          <a:effectLst/>
+        </p:spPr>
+        <p:style>
+          <a:lnRef idx="1">
+            <a:schemeClr val="accent1"/>
+          </a:lnRef>
+          <a:fillRef idx="3">
+            <a:schemeClr val="accent1"/>
+          </a:fillRef>
+          <a:effectRef idx="2">
+            <a:schemeClr val="accent1"/>
+          </a:effectRef>
+          <a:fontRef idx="minor">
+            <a:schemeClr val="lt1"/>
+          </a:fontRef>
+        </p:style>
+        <p:txBody>
+          <a:bodyPr rtlCol="0" anchor="ctr"/>
+          <a:lstStyle/>
+          <a:p>
+            <a:pPr algn="ctr"/>
+          </a:p>
+        </p:txBody>
+      </p:sp>
+      <p:sp>
+        <p:nvSpPr>
           <p:cNvPr id="14" name="Shape 10"/>
           <p:cNvSpPr/>
           <p:nvPr/>
@@ -5904,9 +6070,7 @@
               <a:gd name="adj" fmla="val 10909"/>
             </a:avLst>
           </a:prstGeom>
-          <a:solidFill>
-            <a:srgbClr val="F1F4F9"/>
-          </a:solidFill>
+          <a:noFill/>
           <a:ln w="12700">
             <a:solidFill>
               <a:srgbClr val="F1F4F9"/>
@@ -6110,6 +6274,50 @@
       </p:sp>
       <p:sp>
         <p:nvSpPr>
+          <p:cNvPr id="40" name="Rectangle 39"/>
+          <p:cNvSpPr/>
+          <p:nvPr/>
+        </p:nvSpPr>
+        <p:spPr>
+          <a:xfrm>
+            <a:off x="457200" y="2926080"/>
+            <a:ext cx="8229600" cy="9144"/>
+          </a:xfrm>
+          <a:prstGeom prst="rect">
+            <a:avLst/>
+          </a:prstGeom>
+          <a:solidFill>
+            <a:srgbClr val="D9DEE7"/>
+          </a:solidFill>
+          <a:ln>
+            <a:noFill/>
+          </a:ln>
+          <a:effectLst/>
+        </p:spPr>
+        <p:style>
+          <a:lnRef idx="1">
+            <a:schemeClr val="accent1"/>
+          </a:lnRef>
+          <a:fillRef idx="3">
+            <a:schemeClr val="accent1"/>
+          </a:fillRef>
+          <a:effectRef idx="2">
+            <a:schemeClr val="accent1"/>
+          </a:effectRef>
+          <a:fontRef idx="minor">
+            <a:schemeClr val="lt1"/>
+          </a:fontRef>
+        </p:style>
+        <p:txBody>
+          <a:bodyPr rtlCol="0" anchor="ctr"/>
+          <a:lstStyle/>
+          <a:p>
+            <a:pPr algn="ctr"/>
+          </a:p>
+        </p:txBody>
+      </p:sp>
+      <p:sp>
+        <p:nvSpPr>
           <p:cNvPr id="21" name="Shape 16"/>
           <p:cNvSpPr/>
           <p:nvPr/>
@@ -6124,9 +6332,7 @@
               <a:gd name="adj" fmla="val 10909"/>
             </a:avLst>
           </a:prstGeom>
-          <a:solidFill>
-            <a:srgbClr val="F1F4F9"/>
-          </a:solidFill>
+          <a:noFill/>
           <a:ln w="12700">
             <a:solidFill>
               <a:srgbClr val="F1F4F9"/>
@@ -6330,6 +6536,50 @@
       </p:sp>
       <p:sp>
         <p:nvSpPr>
+          <p:cNvPr id="41" name="Rectangle 40"/>
+          <p:cNvSpPr/>
+          <p:nvPr/>
+        </p:nvSpPr>
+        <p:spPr>
+          <a:xfrm>
+            <a:off x="457200" y="3657600"/>
+            <a:ext cx="8229600" cy="9144"/>
+          </a:xfrm>
+          <a:prstGeom prst="rect">
+            <a:avLst/>
+          </a:prstGeom>
+          <a:solidFill>
+            <a:srgbClr val="D9DEE7"/>
+          </a:solidFill>
+          <a:ln>
+            <a:noFill/>
+          </a:ln>
+          <a:effectLst/>
+        </p:spPr>
+        <p:style>
+          <a:lnRef idx="1">
+            <a:schemeClr val="accent1"/>
+          </a:lnRef>
+          <a:fillRef idx="3">
+            <a:schemeClr val="accent1"/>
+          </a:fillRef>
+          <a:effectRef idx="2">
+            <a:schemeClr val="accent1"/>
+          </a:effectRef>
+          <a:fontRef idx="minor">
+            <a:schemeClr val="lt1"/>
+          </a:fontRef>
+        </p:style>
+        <p:txBody>
+          <a:bodyPr rtlCol="0" anchor="ctr"/>
+          <a:lstStyle/>
+          <a:p>
+            <a:pPr algn="ctr"/>
+          </a:p>
+        </p:txBody>
+      </p:sp>
+      <p:sp>
+        <p:nvSpPr>
           <p:cNvPr id="28" name="Shape 22"/>
           <p:cNvSpPr/>
           <p:nvPr/>
@@ -6344,9 +6594,7 @@
               <a:gd name="adj" fmla="val 10909"/>
             </a:avLst>
           </a:prstGeom>
-          <a:solidFill>
-            <a:srgbClr val="F1F4F9"/>
-          </a:solidFill>
+          <a:noFill/>
           <a:ln w="12700">
             <a:solidFill>
               <a:srgbClr val="F1F4F9"/>
@@ -6550,6 +6798,50 @@
       </p:sp>
       <p:sp>
         <p:nvSpPr>
+          <p:cNvPr id="42" name="Rectangle 41"/>
+          <p:cNvSpPr/>
+          <p:nvPr/>
+        </p:nvSpPr>
+        <p:spPr>
+          <a:xfrm>
+            <a:off x="457200" y="4389120"/>
+            <a:ext cx="8229600" cy="9144"/>
+          </a:xfrm>
+          <a:prstGeom prst="rect">
+            <a:avLst/>
+          </a:prstGeom>
+          <a:solidFill>
+            <a:srgbClr val="D9DEE7"/>
+          </a:solidFill>
+          <a:ln>
+            <a:noFill/>
+          </a:ln>
+          <a:effectLst/>
+        </p:spPr>
+        <p:style>
+          <a:lnRef idx="1">
+            <a:schemeClr val="accent1"/>
+          </a:lnRef>
+          <a:fillRef idx="3">
+            <a:schemeClr val="accent1"/>
+          </a:fillRef>
+          <a:effectRef idx="2">
+            <a:schemeClr val="accent1"/>
+          </a:effectRef>
+          <a:fontRef idx="minor">
+            <a:schemeClr val="lt1"/>
+          </a:fontRef>
+        </p:style>
+        <p:txBody>
+          <a:bodyPr rtlCol="0" anchor="ctr"/>
+          <a:lstStyle/>
+          <a:p>
+            <a:pPr algn="ctr"/>
+          </a:p>
+        </p:txBody>
+      </p:sp>
+      <p:sp>
+        <p:nvSpPr>
           <p:cNvPr id="35" name="Shape 28"/>
           <p:cNvSpPr/>
           <p:nvPr/>
@@ -6564,9 +6856,7 @@
               <a:gd name="adj" fmla="val 10909"/>
             </a:avLst>
           </a:prstGeom>
-          <a:solidFill>
-            <a:srgbClr val="F1F4F9"/>
-          </a:solidFill>
+          <a:noFill/>
           <a:ln w="12700">
             <a:solidFill>
               <a:srgbClr val="F1F4F9"/>
@@ -6689,6 +6979,50 @@
               <a:t>12</a:t>
             </a:r>
             <a:endParaRPr lang="en-US" sz="1000" dirty="0"/>
+          </a:p>
+        </p:txBody>
+      </p:sp>
+      <p:sp>
+        <p:nvSpPr>
+          <p:cNvPr id="43" name="Rectangle 42"/>
+          <p:cNvSpPr/>
+          <p:nvPr/>
+        </p:nvSpPr>
+        <p:spPr>
+          <a:xfrm>
+            <a:off x="457200" y="1554480"/>
+            <a:ext cx="8229600" cy="27432"/>
+          </a:xfrm>
+          <a:prstGeom prst="rect">
+            <a:avLst/>
+          </a:prstGeom>
+          <a:solidFill>
+            <a:srgbClr val="1F8F74"/>
+          </a:solidFill>
+          <a:ln>
+            <a:noFill/>
+          </a:ln>
+          <a:effectLst/>
+        </p:spPr>
+        <p:style>
+          <a:lnRef idx="1">
+            <a:schemeClr val="accent1"/>
+          </a:lnRef>
+          <a:fillRef idx="3">
+            <a:schemeClr val="accent1"/>
+          </a:fillRef>
+          <a:effectRef idx="2">
+            <a:schemeClr val="accent1"/>
+          </a:effectRef>
+          <a:fontRef idx="minor">
+            <a:schemeClr val="lt1"/>
+          </a:fontRef>
+        </p:style>
+        <p:txBody>
+          <a:bodyPr rtlCol="0" anchor="ctr"/>
+          <a:lstStyle/>
+          <a:p>
+            <a:pPr algn="ctr"/>
           </a:p>
         </p:txBody>
       </p:sp>
@@ -7337,9 +7671,9 @@
         <p:spPr>
           <a:xfrm>
             <a:off x="6172200" y="1280160"/>
-            <a:ext cx="2514600" cy="3200400"/>
-          </a:xfrm>
-          <a:prstGeom prst="roundRect">
+            <a:ext cx="2971800" cy="3863339"/>
+          </a:xfrm>
+          <a:prstGeom prst="rect">
             <a:avLst>
               <a:gd name="adj" fmla="val 2909"/>
             </a:avLst>
@@ -7481,7 +7815,7 @@
         <p:spPr>
           <a:xfrm>
             <a:off x="457200" y="4645152"/>
-            <a:ext cx="7680960" cy="347472"/>
+            <a:ext cx="5394960" cy="347472"/>
           </a:xfrm>
           <a:prstGeom prst="rect">
             <a:avLst/>
@@ -7538,7 +7872,7 @@
             <a:r>
               <a:rPr lang="en-US" sz="1000" dirty="0">
                 <a:solidFill>
-                  <a:srgbClr val="556070"/>
+                  <a:srgbClr val="FFFFFF"/>
                 </a:solidFill>
                 <a:latin typeface="Calibri" pitchFamily="34" charset="0"/>
                 <a:ea typeface="Calibri" pitchFamily="34" charset="-122"/>
@@ -8396,7 +8730,7 @@
         <p:spPr>
           <a:xfrm>
             <a:off x="1051560" y="1261872"/>
-            <a:ext cx="7635240" cy="256032"/>
+            <a:ext cx="5760720" cy="256032"/>
           </a:xfrm>
           <a:prstGeom prst="rect">
             <a:avLst/>
@@ -8435,7 +8769,7 @@
         <p:spPr>
           <a:xfrm>
             <a:off x="1051560" y="1536192"/>
-            <a:ext cx="7635240" cy="475488"/>
+            <a:ext cx="5760720" cy="475488"/>
           </a:xfrm>
           <a:prstGeom prst="rect">
             <a:avLst/>
@@ -8451,7 +8785,7 @@
               <a:buNone/>
             </a:pPr>
             <a:r>
-              <a:rPr lang="en-US" sz="1300" dirty="0">
+              <a:rPr lang="en-US" sz="1170" dirty="0">
                 <a:solidFill>
                   <a:srgbClr val="1E2633"/>
                 </a:solidFill>
@@ -8461,7 +8795,7 @@
               </a:rPr>
               <a:t>In all six borrower groups we studied, people compared two to four lenders they already knew. AMB was never among them, whether the borrower built the list or a broker did.</a:t>
             </a:r>
-            <a:endParaRPr lang="en-US" sz="1300" dirty="0"/>
+            <a:endParaRPr lang="en-US" sz="1170" dirty="0"/>
           </a:p>
         </p:txBody>
       </p:sp>
@@ -8473,8 +8807,8 @@
         </p:nvSpPr>
         <p:spPr>
           <a:xfrm>
-            <a:off x="1051560" y="2066544"/>
-            <a:ext cx="7635240" cy="0"/>
+            <a:off x="1051560" y="2130552"/>
+            <a:ext cx="5760720" cy="0"/>
           </a:xfrm>
           <a:prstGeom prst="line">
             <a:avLst/>
@@ -8496,7 +8830,7 @@
         </p:nvSpPr>
         <p:spPr>
           <a:xfrm>
-            <a:off x="457200" y="2130552"/>
+            <a:off x="457200" y="2194560"/>
             <a:ext cx="420624" cy="420624"/>
           </a:xfrm>
           <a:prstGeom prst="ellipse">
@@ -8529,7 +8863,7 @@
         </p:blipFill>
         <p:spPr>
           <a:xfrm>
-            <a:off x="558150" y="2231502"/>
+            <a:off x="558150" y="2295510"/>
             <a:ext cx="218724" cy="218724"/>
           </a:xfrm>
           <a:prstGeom prst="rect">
@@ -8545,8 +8879,8 @@
         </p:nvSpPr>
         <p:spPr>
           <a:xfrm>
-            <a:off x="1051560" y="2112264"/>
-            <a:ext cx="7635240" cy="256032"/>
+            <a:off x="1051560" y="2176272"/>
+            <a:ext cx="5760720" cy="256032"/>
           </a:xfrm>
           <a:prstGeom prst="rect">
             <a:avLst/>
@@ -8584,8 +8918,8 @@
         </p:nvSpPr>
         <p:spPr>
           <a:xfrm>
-            <a:off x="1051560" y="2386584"/>
-            <a:ext cx="7635240" cy="475488"/>
+            <a:off x="1051560" y="2450592"/>
+            <a:ext cx="5760720" cy="475488"/>
           </a:xfrm>
           <a:prstGeom prst="rect">
             <a:avLst/>
@@ -8601,7 +8935,7 @@
               <a:buNone/>
             </a:pPr>
             <a:r>
-              <a:rPr lang="en-US" sz="1300" dirty="0">
+              <a:rPr lang="en-US" sz="1170" dirty="0">
                 <a:solidFill>
                   <a:srgbClr val="1E2633"/>
                 </a:solidFill>
@@ -8611,7 +8945,7 @@
               </a:rPr>
               <a:t>Its advertised variable rate is competitive with the big four's (5.94% up to 60% LVR), and customer-owned banks are the most trusted sector in banking (Roy Morgan). Neither fact reaches the moment of decision.</a:t>
             </a:r>
-            <a:endParaRPr lang="en-US" sz="1300" dirty="0"/>
+            <a:endParaRPr lang="en-US" sz="1170" dirty="0"/>
           </a:p>
         </p:txBody>
       </p:sp>
@@ -8623,8 +8957,8 @@
         </p:nvSpPr>
         <p:spPr>
           <a:xfrm>
-            <a:off x="1051560" y="2916936"/>
-            <a:ext cx="7635240" cy="0"/>
+            <a:off x="1051560" y="3044952"/>
+            <a:ext cx="5760720" cy="0"/>
           </a:xfrm>
           <a:prstGeom prst="line">
             <a:avLst/>
@@ -8646,7 +8980,7 @@
         </p:nvSpPr>
         <p:spPr>
           <a:xfrm>
-            <a:off x="457200" y="2980944"/>
+            <a:off x="457200" y="3108960"/>
             <a:ext cx="420624" cy="420624"/>
           </a:xfrm>
           <a:prstGeom prst="ellipse">
@@ -8679,7 +9013,7 @@
         </p:blipFill>
         <p:spPr>
           <a:xfrm>
-            <a:off x="558150" y="3081894"/>
+            <a:off x="558150" y="3209910"/>
             <a:ext cx="218724" cy="218724"/>
           </a:xfrm>
           <a:prstGeom prst="rect">
@@ -8695,8 +9029,8 @@
         </p:nvSpPr>
         <p:spPr>
           <a:xfrm>
-            <a:off x="1051560" y="2962656"/>
-            <a:ext cx="7635240" cy="256032"/>
+            <a:off x="1051560" y="3090672"/>
+            <a:ext cx="5760720" cy="256032"/>
           </a:xfrm>
           <a:prstGeom prst="rect">
             <a:avLst/>
@@ -8734,8 +9068,8 @@
         </p:nvSpPr>
         <p:spPr>
           <a:xfrm>
-            <a:off x="1051560" y="3236976"/>
-            <a:ext cx="7635240" cy="475488"/>
+            <a:off x="1051560" y="3364992"/>
+            <a:ext cx="5760720" cy="475488"/>
           </a:xfrm>
           <a:prstGeom prst="rect">
             <a:avLst/>
@@ -8751,7 +9085,7 @@
               <a:buNone/>
             </a:pPr>
             <a:r>
-              <a:rPr lang="en-US" sz="1300" dirty="0">
+              <a:rPr lang="en-US" sz="1170" dirty="0">
                 <a:solidFill>
                   <a:srgbClr val="1E2633"/>
                 </a:solidFill>
@@ -8761,7 +9095,7 @@
               </a:rPr>
               <a:t>Make AMB easy to verify online; get it into the broker's working set; and give the 280,000 existing members a check-your-offer link to send a friend.</a:t>
             </a:r>
-            <a:endParaRPr lang="en-US" sz="1300" dirty="0"/>
+            <a:endParaRPr lang="en-US" sz="1170" dirty="0"/>
           </a:p>
         </p:txBody>
       </p:sp>
@@ -8773,8 +9107,8 @@
         </p:nvSpPr>
         <p:spPr>
           <a:xfrm>
-            <a:off x="1051560" y="3767328"/>
-            <a:ext cx="7635240" cy="0"/>
+            <a:off x="1051560" y="3959352"/>
+            <a:ext cx="5760720" cy="0"/>
           </a:xfrm>
           <a:prstGeom prst="line">
             <a:avLst/>
@@ -8796,7 +9130,7 @@
         </p:nvSpPr>
         <p:spPr>
           <a:xfrm>
-            <a:off x="457200" y="3831336"/>
+            <a:off x="457200" y="4023360"/>
             <a:ext cx="420624" cy="420624"/>
           </a:xfrm>
           <a:prstGeom prst="ellipse">
@@ -8829,7 +9163,7 @@
         </p:blipFill>
         <p:spPr>
           <a:xfrm>
-            <a:off x="558150" y="3932286"/>
+            <a:off x="558150" y="4124310"/>
             <a:ext cx="218724" cy="218724"/>
           </a:xfrm>
           <a:prstGeom prst="rect">
@@ -8845,8 +9179,8 @@
         </p:nvSpPr>
         <p:spPr>
           <a:xfrm>
-            <a:off x="1051560" y="3813048"/>
-            <a:ext cx="7635240" cy="256032"/>
+            <a:off x="1051560" y="4005072"/>
+            <a:ext cx="5760720" cy="256032"/>
           </a:xfrm>
           <a:prstGeom prst="rect">
             <a:avLst/>
@@ -8884,8 +9218,8 @@
         </p:nvSpPr>
         <p:spPr>
           <a:xfrm>
-            <a:off x="1051560" y="4087368"/>
-            <a:ext cx="7635240" cy="475488"/>
+            <a:off x="1051560" y="4279392"/>
+            <a:ext cx="5760720" cy="475488"/>
           </a:xfrm>
           <a:prstGeom prst="rect">
             <a:avLst/>
@@ -8901,7 +9235,7 @@
               <a:buNone/>
             </a:pPr>
             <a:r>
-              <a:rPr lang="en-US" sz="1300" dirty="0">
+              <a:rPr lang="en-US" sz="1170" dirty="0">
                 <a:solidFill>
                   <a:srgbClr val="1E2633"/>
                 </a:solidFill>
@@ -8911,10 +9245,34 @@
               </a:rPr>
               <a:t>Indicative split 20 / 55 / 15 / 10 across the three moves and measurement, to be re-derived from cost per funded loan. Return of XXX times on lifetime margin per funded loan.</a:t>
             </a:r>
-            <a:endParaRPr lang="en-US" sz="1300" dirty="0"/>
-          </a:p>
-        </p:txBody>
-      </p:sp>
+            <a:endParaRPr lang="en-US" sz="1170" dirty="0"/>
+          </a:p>
+        </p:txBody>
+      </p:sp>
+      <p:pic>
+        <p:nvPicPr>
+          <p:cNvPr id="25" name="Picture 24" descr="s2_pg1.jpg"/>
+          <p:cNvPicPr>
+            <a:picLocks noChangeAspect="1"/>
+          </p:cNvPicPr>
+          <p:nvPr/>
+        </p:nvPicPr>
+        <p:blipFill>
+          <a:blip r:embed="rId7"/>
+          <a:stretch>
+            <a:fillRect/>
+          </a:stretch>
+        </p:blipFill>
+        <p:spPr>
+          <a:xfrm>
+            <a:off x="7040880" y="1188720"/>
+            <a:ext cx="2103120" cy="3954780"/>
+          </a:xfrm>
+          <a:prstGeom prst="rect">
+            <a:avLst/>
+          </a:prstGeom>
+        </p:spPr>
+      </p:pic>
       <p:sp>
         <p:nvSpPr>
           <p:cNvPr id="24" name="Text 17"/>
@@ -8942,7 +9300,7 @@
             <a:r>
               <a:rPr lang="en-US" sz="1000" dirty="0">
                 <a:solidFill>
-                  <a:srgbClr val="556070"/>
+                  <a:srgbClr val="FFFFFF"/>
                 </a:solidFill>
                 <a:latin typeface="Calibri" pitchFamily="34" charset="0"/>
                 <a:ea typeface="Calibri" pitchFamily="34" charset="-122"/>
@@ -9456,33 +9814,30 @@
           </a:p>
         </p:txBody>
       </p:sp>
-      <p:sp>
-        <p:nvSpPr>
-          <p:cNvPr id="15" name="Shape 10"/>
-          <p:cNvSpPr/>
-          <p:nvPr/>
-        </p:nvSpPr>
+      <p:pic>
+        <p:nvPicPr>
+          <p:cNvPr id="21" name="Picture 20" descr="s3_pg89.jpg"/>
+          <p:cNvPicPr>
+            <a:picLocks noChangeAspect="1"/>
+          </p:cNvPicPr>
+          <p:nvPr/>
+        </p:nvPicPr>
+        <p:blipFill>
+          <a:blip r:embed="rId6"/>
+          <a:stretch>
+            <a:fillRect/>
+          </a:stretch>
+        </p:blipFill>
         <p:spPr>
           <a:xfrm>
             <a:off x="6035040" y="1325880"/>
             <a:ext cx="2651760" cy="3200400"/>
           </a:xfrm>
-          <a:prstGeom prst="roundRect">
-            <a:avLst>
-              <a:gd name="adj" fmla="val 2759"/>
-            </a:avLst>
-          </a:prstGeom>
-          <a:solidFill>
-            <a:srgbClr val="152B56"/>
-          </a:solidFill>
-          <a:ln w="12700">
-            <a:solidFill>
-              <a:srgbClr val="152B56"/>
-            </a:solidFill>
-            <a:prstDash val="solid"/>
-          </a:ln>
-        </p:spPr>
-      </p:sp>
+          <a:prstGeom prst="rect">
+            <a:avLst/>
+          </a:prstGeom>
+        </p:spPr>
+      </p:pic>
       <p:sp>
         <p:nvSpPr>
           <p:cNvPr id="16" name="Shape 11"/>
@@ -10547,32 +10902,75 @@
           </a:graphicData>
         </a:graphic>
       </p:graphicFrame>
-      <p:sp>
-        <p:nvSpPr>
-          <p:cNvPr id="6" name="Shape 2"/>
-          <p:cNvSpPr/>
-          <p:nvPr/>
-        </p:nvSpPr>
+      <p:pic>
+        <p:nvPicPr>
+          <p:cNvPr id="13" name="Picture 12" descr="s5_pg34.jpg"/>
+          <p:cNvPicPr>
+            <a:picLocks noChangeAspect="1"/>
+          </p:cNvPicPr>
+          <p:nvPr/>
+        </p:nvPicPr>
+        <p:blipFill>
+          <a:blip r:embed="rId4"/>
+          <a:stretch>
+            <a:fillRect/>
+          </a:stretch>
+        </p:blipFill>
         <p:spPr>
           <a:xfrm>
             <a:off x="5212080" y="1325880"/>
             <a:ext cx="3474720" cy="3108960"/>
           </a:xfrm>
-          <a:prstGeom prst="roundRect">
-            <a:avLst>
-              <a:gd name="adj" fmla="val 2353"/>
-            </a:avLst>
+          <a:prstGeom prst="rect">
+            <a:avLst/>
+          </a:prstGeom>
+        </p:spPr>
+      </p:pic>
+      <p:sp>
+        <p:nvSpPr>
+          <p:cNvPr id="14" name="Rectangle 13"/>
+          <p:cNvSpPr/>
+          <p:nvPr/>
+        </p:nvSpPr>
+        <p:spPr>
+          <a:xfrm>
+            <a:off x="5440680" y="1874519"/>
+            <a:ext cx="3017520" cy="2331720"/>
+          </a:xfrm>
+          <a:prstGeom prst="rect">
+            <a:avLst/>
           </a:prstGeom>
           <a:solidFill>
-            <a:srgbClr val="F1F4F9"/>
+            <a:srgbClr val="FFFFFF"/>
           </a:solidFill>
-          <a:ln w="12700">
+          <a:ln w="9525">
             <a:solidFill>
-              <a:srgbClr val="F1F4F9"/>
+              <a:srgbClr val="D9DEE7"/>
             </a:solidFill>
-            <a:prstDash val="solid"/>
           </a:ln>
-        </p:spPr>
+          <a:effectLst/>
+        </p:spPr>
+        <p:style>
+          <a:lnRef idx="1">
+            <a:schemeClr val="accent1"/>
+          </a:lnRef>
+          <a:fillRef idx="3">
+            <a:schemeClr val="accent1"/>
+          </a:fillRef>
+          <a:effectRef idx="2">
+            <a:schemeClr val="accent1"/>
+          </a:effectRef>
+          <a:fontRef idx="minor">
+            <a:schemeClr val="lt1"/>
+          </a:fontRef>
+        </p:style>
+        <p:txBody>
+          <a:bodyPr rtlCol="0" anchor="ctr"/>
+          <a:lstStyle/>
+          <a:p>
+            <a:pPr algn="ctr"/>
+          </a:p>
+        </p:txBody>
       </p:sp>
       <p:sp>
         <p:nvSpPr>
@@ -10582,8 +10980,8 @@
         </p:nvSpPr>
         <p:spPr>
           <a:xfrm>
-            <a:off x="5440680" y="1463040"/>
-            <a:ext cx="3017520" cy="777240"/>
+            <a:off x="5623560" y="1965960"/>
+            <a:ext cx="2651760" cy="548640"/>
           </a:xfrm>
           <a:prstGeom prst="rect">
             <a:avLst/>
@@ -10599,7 +10997,7 @@
               <a:buNone/>
             </a:pPr>
             <a:r>
-              <a:rPr lang="en-US" sz="4800" b="1" dirty="0">
+              <a:rPr lang="en-US" sz="3840" b="1" dirty="0">
                 <a:solidFill>
                   <a:srgbClr val="166257"/>
                 </a:solidFill>
@@ -10609,7 +11007,7 @@
               </a:rPr>
               <a:t>3.7%</a:t>
             </a:r>
-            <a:endParaRPr lang="en-US" sz="4800" dirty="0"/>
+            <a:endParaRPr lang="en-US" sz="3840" dirty="0"/>
           </a:p>
         </p:txBody>
       </p:sp>
@@ -10621,8 +11019,8 @@
         </p:nvSpPr>
         <p:spPr>
           <a:xfrm>
-            <a:off x="5440680" y="2240280"/>
-            <a:ext cx="3017520" cy="822960"/>
+            <a:off x="5623560" y="2542032"/>
+            <a:ext cx="2651760" cy="640080"/>
           </a:xfrm>
           <a:prstGeom prst="rect">
             <a:avLst/>
@@ -10638,7 +11036,7 @@
               <a:buNone/>
             </a:pPr>
             <a:r>
-              <a:rPr lang="en-US" sz="1400" dirty="0">
+              <a:rPr lang="en-US" sz="1232" dirty="0">
                 <a:solidFill>
                   <a:srgbClr val="1E2633"/>
                 </a:solidFill>
@@ -10648,7 +11046,7 @@
               </a:rPr>
               <a:t>of broker-originated lending went to mutual banks in 2024, against 39.9% to the major banks</a:t>
             </a:r>
-            <a:endParaRPr lang="en-US" sz="1400" dirty="0"/>
+            <a:endParaRPr lang="en-US" sz="1232" dirty="0"/>
           </a:p>
         </p:txBody>
       </p:sp>
@@ -10660,8 +11058,8 @@
         </p:nvSpPr>
         <p:spPr>
           <a:xfrm>
-            <a:off x="5440680" y="3154680"/>
-            <a:ext cx="3017520" cy="0"/>
+            <a:off x="5623560" y="3246120"/>
+            <a:ext cx="2651760" cy="0"/>
           </a:xfrm>
           <a:prstGeom prst="line">
             <a:avLst/>
@@ -10683,8 +11081,8 @@
         </p:nvSpPr>
         <p:spPr>
           <a:xfrm>
-            <a:off x="5440680" y="3291840"/>
-            <a:ext cx="3017520" cy="1051560"/>
+            <a:off x="5623560" y="3337560"/>
+            <a:ext cx="2651760" cy="868680"/>
           </a:xfrm>
           <a:prstGeom prst="rect">
             <a:avLst/>
@@ -10700,7 +11098,7 @@
               <a:buNone/>
             </a:pPr>
             <a:r>
-              <a:rPr lang="en-US" sz="1400" dirty="0">
+              <a:rPr lang="en-US" sz="1260" dirty="0">
                 <a:solidFill>
                   <a:srgbClr val="1E2633"/>
                 </a:solidFill>
@@ -10710,7 +11108,7 @@
               </a:rPr>
               <a:t>74% of Australians cannot say what a customer-owned bank is, although the sector has been the most trusted in banking for two years running.</a:t>
             </a:r>
-            <a:endParaRPr lang="en-US" sz="1400" dirty="0"/>
+            <a:endParaRPr lang="en-US" sz="1260" dirty="0"/>
           </a:p>
         </p:txBody>
       </p:sp>
@@ -12820,74 +13218,61 @@
       </p:sp>
       <p:sp>
         <p:nvSpPr>
-          <p:cNvPr id="5" name="Shape 2"/>
-          <p:cNvSpPr/>
-          <p:nvPr/>
-        </p:nvSpPr>
-        <p:spPr>
-          <a:xfrm>
-            <a:off x="457200" y="1280160"/>
-            <a:ext cx="4023360" cy="2468880"/>
-          </a:xfrm>
-          <a:prstGeom prst="roundRect">
-            <a:avLst>
-              <a:gd name="adj" fmla="val 2963"/>
-            </a:avLst>
-          </a:prstGeom>
-          <a:solidFill>
-            <a:srgbClr val="152B56"/>
-          </a:solidFill>
-          <a:ln w="12700">
-            <a:solidFill>
-              <a:srgbClr val="152B56"/>
-            </a:solidFill>
-            <a:prstDash val="solid"/>
-          </a:ln>
-        </p:spPr>
-      </p:sp>
-      <p:sp>
-        <p:nvSpPr>
-          <p:cNvPr id="6" name="Shape 3"/>
-          <p:cNvSpPr/>
-          <p:nvPr/>
-        </p:nvSpPr>
-        <p:spPr>
-          <a:xfrm>
-            <a:off x="685800" y="1463040"/>
-            <a:ext cx="457200" cy="457200"/>
-          </a:xfrm>
-          <a:prstGeom prst="ellipse">
-            <a:avLst/>
-          </a:prstGeom>
-          <a:solidFill>
-            <a:srgbClr val="1F8F74"/>
-          </a:solidFill>
-          <a:ln w="12700">
-            <a:solidFill>
-              <a:srgbClr val="1F8F74"/>
-            </a:solidFill>
-            <a:prstDash val="solid"/>
-          </a:ln>
-        </p:spPr>
+          <p:cNvPr id="25" name="Text 19"/>
+          <p:cNvSpPr txBox="1"/>
+          <p:nvPr/>
+        </p:nvSpPr>
+        <p:spPr>
+          <a:xfrm>
+            <a:off x="8229600" y="4754880"/>
+            <a:ext cx="457200" cy="228600"/>
+          </a:xfrm>
+          <a:prstGeom prst="rect">
+            <a:avLst/>
+          </a:prstGeom>
+          <a:noFill/>
+          <a:ln/>
+        </p:spPr>
+        <p:txBody>
+          <a:bodyPr wrap="square" lIns="0" tIns="0" rIns="0" bIns="0" rtlCol="0" anchor="ctr"/>
+          <a:lstStyle/>
+          <a:p>
+            <a:pPr algn="r" indent="0" marL="0">
+              <a:buNone/>
+            </a:pPr>
+            <a:r>
+              <a:rPr lang="en-US" sz="1000" dirty="0">
+                <a:solidFill>
+                  <a:srgbClr val="556070"/>
+                </a:solidFill>
+                <a:latin typeface="Calibri" pitchFamily="34" charset="0"/>
+                <a:ea typeface="Calibri" pitchFamily="34" charset="-122"/>
+                <a:cs typeface="Calibri" pitchFamily="34" charset="-120"/>
+              </a:rPr>
+              <a:t>7</a:t>
+            </a:r>
+            <a:endParaRPr lang="en-US" sz="1000" dirty="0"/>
+          </a:p>
+        </p:txBody>
       </p:sp>
       <p:pic>
         <p:nvPicPr>
-          <p:cNvPr id="7" name="Image 0" descr="preencoded.png">    </p:cNvPr>
+          <p:cNvPr id="26" name="Picture 25" descr="s7_pg16-000.jpg"/>
           <p:cNvPicPr>
             <a:picLocks noChangeAspect="1"/>
           </p:cNvPicPr>
           <p:nvPr/>
         </p:nvPicPr>
         <p:blipFill>
-          <a:blip r:embed="rId1"/>
+          <a:blip r:embed="rId6"/>
           <a:stretch>
             <a:fillRect/>
           </a:stretch>
         </p:blipFill>
         <p:spPr>
           <a:xfrm>
-            <a:off x="795528" y="1572768"/>
-            <a:ext cx="237744" cy="237744"/>
+            <a:off x="457200" y="1188720"/>
+            <a:ext cx="4023360" cy="2743200"/>
           </a:xfrm>
           <a:prstGeom prst="rect">
             <a:avLst/>
@@ -12896,271 +13281,305 @@
       </p:pic>
       <p:sp>
         <p:nvSpPr>
-          <p:cNvPr id="8" name="Shape 4"/>
+          <p:cNvPr id="27" name="Rectangle 26"/>
           <p:cNvSpPr/>
           <p:nvPr/>
         </p:nvSpPr>
         <p:spPr>
           <a:xfrm>
-            <a:off x="3291840" y="1508760"/>
-            <a:ext cx="960120" cy="292608"/>
-          </a:xfrm>
-          <a:prstGeom prst="roundRect">
-            <a:avLst>
-              <a:gd name="adj" fmla="val 50000"/>
-            </a:avLst>
+            <a:off x="685800" y="1371600"/>
+            <a:ext cx="1005840" cy="237744"/>
+          </a:xfrm>
+          <a:prstGeom prst="rect">
+            <a:avLst/>
+          </a:prstGeom>
+          <a:solidFill>
+            <a:srgbClr val="166257"/>
+          </a:solidFill>
+          <a:ln>
+            <a:noFill/>
+          </a:ln>
+          <a:effectLst/>
+        </p:spPr>
+        <p:style>
+          <a:lnRef idx="1">
+            <a:schemeClr val="accent1"/>
+          </a:lnRef>
+          <a:fillRef idx="3">
+            <a:schemeClr val="accent1"/>
+          </a:fillRef>
+          <a:effectRef idx="2">
+            <a:schemeClr val="accent1"/>
+          </a:effectRef>
+          <a:fontRef idx="minor">
+            <a:schemeClr val="lt1"/>
+          </a:fontRef>
+        </p:style>
+        <p:txBody>
+          <a:bodyPr rtlCol="0" anchor="ctr"/>
+          <a:lstStyle/>
+          <a:p>
+            <a:pPr algn="ctr"/>
+          </a:p>
+        </p:txBody>
+      </p:sp>
+      <p:sp>
+        <p:nvSpPr>
+          <p:cNvPr id="28" name="TextBox 27"/>
+          <p:cNvSpPr txBox="1"/>
+          <p:nvPr/>
+        </p:nvSpPr>
+        <p:spPr>
+          <a:xfrm>
+            <a:off x="685800" y="1371600"/>
+            <a:ext cx="1005840" cy="237744"/>
+          </a:xfrm>
+          <a:prstGeom prst="rect">
+            <a:avLst/>
+          </a:prstGeom>
+          <a:noFill/>
+        </p:spPr>
+        <p:txBody>
+          <a:bodyPr wrap="square" lIns="0" rIns="0" tIns="0" bIns="0" anchor="ctr">
+            <a:spAutoFit/>
+          </a:bodyPr>
+          <a:lstStyle/>
+          <a:p>
+            <a:pPr algn="ctr"/>
+            <a:r>
+              <a:rPr sz="1000" b="1">
+                <a:solidFill>
+                  <a:srgbClr val="FFFFFF"/>
+                </a:solidFill>
+                <a:latin typeface="Calibri"/>
+              </a:rPr>
+              <a:t>PRIORITY 1</a:t>
+            </a:r>
+          </a:p>
+        </p:txBody>
+      </p:sp>
+      <p:sp>
+        <p:nvSpPr>
+          <p:cNvPr id="29" name="TextBox 28"/>
+          <p:cNvSpPr txBox="1"/>
+          <p:nvPr/>
+        </p:nvSpPr>
+        <p:spPr>
+          <a:xfrm>
+            <a:off x="685800" y="2395728"/>
+            <a:ext cx="3566160" cy="347472"/>
+          </a:xfrm>
+          <a:prstGeom prst="rect">
+            <a:avLst/>
+          </a:prstGeom>
+          <a:noFill/>
+        </p:spPr>
+        <p:txBody>
+          <a:bodyPr wrap="square" lIns="0" rIns="0" tIns="0" bIns="0" anchor="t">
+            <a:spAutoFit/>
+          </a:bodyPr>
+          <a:lstStyle/>
+          <a:p>
+            <a:pPr algn="l"/>
+            <a:r>
+              <a:rPr sz="2000" b="1">
+                <a:solidFill>
+                  <a:srgbClr val="FFFFFF"/>
+                </a:solidFill>
+                <a:latin typeface="Cambria"/>
+              </a:rPr>
+              <a:t>DIY online borrowers</a:t>
+            </a:r>
+          </a:p>
+        </p:txBody>
+      </p:sp>
+      <p:sp>
+        <p:nvSpPr>
+          <p:cNvPr id="30" name="TextBox 29"/>
+          <p:cNvSpPr txBox="1"/>
+          <p:nvPr/>
+        </p:nvSpPr>
+        <p:spPr>
+          <a:xfrm>
+            <a:off x="685800" y="2798064"/>
+            <a:ext cx="3566160" cy="731520"/>
+          </a:xfrm>
+          <a:prstGeom prst="rect">
+            <a:avLst/>
+          </a:prstGeom>
+          <a:noFill/>
+        </p:spPr>
+        <p:txBody>
+          <a:bodyPr wrap="square" lIns="0" rIns="0" tIns="0" bIns="0" anchor="t">
+            <a:spAutoFit/>
+          </a:bodyPr>
+          <a:lstStyle/>
+          <a:p>
+            <a:pPr algn="l"/>
+            <a:r>
+              <a:rPr sz="1100" b="0">
+                <a:solidFill>
+                  <a:srgbClr val="EEF2F8"/>
+                </a:solidFill>
+                <a:latin typeface="Calibri"/>
+              </a:rPr>
+              <a:t>Build their own shortlist in search, comparison sites and AI tools, the channels a digital budget touches directly. Refinancers and upgraders behave the same way once a trigger fires.</a:t>
+            </a:r>
+          </a:p>
+        </p:txBody>
+      </p:sp>
+      <p:sp>
+        <p:nvSpPr>
+          <p:cNvPr id="31" name="Rectangle 30"/>
+          <p:cNvSpPr/>
+          <p:nvPr/>
+        </p:nvSpPr>
+        <p:spPr>
+          <a:xfrm>
+            <a:off x="685800" y="3675887"/>
+            <a:ext cx="3566160" cy="475488"/>
+          </a:xfrm>
+          <a:prstGeom prst="rect">
+            <a:avLst/>
+          </a:prstGeom>
+          <a:solidFill>
+            <a:srgbClr val="FFFFFF"/>
+          </a:solidFill>
+          <a:ln w="9525">
+            <a:solidFill>
+              <a:srgbClr val="D9DEE7"/>
+            </a:solidFill>
+          </a:ln>
+          <a:effectLst/>
+        </p:spPr>
+        <p:style>
+          <a:lnRef idx="1">
+            <a:schemeClr val="accent1"/>
+          </a:lnRef>
+          <a:fillRef idx="3">
+            <a:schemeClr val="accent1"/>
+          </a:fillRef>
+          <a:effectRef idx="2">
+            <a:schemeClr val="accent1"/>
+          </a:effectRef>
+          <a:fontRef idx="minor">
+            <a:schemeClr val="lt1"/>
+          </a:fontRef>
+        </p:style>
+        <p:txBody>
+          <a:bodyPr rtlCol="0" anchor="ctr"/>
+          <a:lstStyle/>
+          <a:p>
+            <a:pPr algn="ctr"/>
+          </a:p>
+        </p:txBody>
+      </p:sp>
+      <p:sp>
+        <p:nvSpPr>
+          <p:cNvPr id="32" name="Rectangle 31"/>
+          <p:cNvSpPr/>
+          <p:nvPr/>
+        </p:nvSpPr>
+        <p:spPr>
+          <a:xfrm>
+            <a:off x="685800" y="3675887"/>
+            <a:ext cx="45720" cy="475488"/>
+          </a:xfrm>
+          <a:prstGeom prst="rect">
+            <a:avLst/>
           </a:prstGeom>
           <a:solidFill>
             <a:srgbClr val="1F8F74"/>
           </a:solidFill>
-          <a:ln w="12700">
-            <a:solidFill>
-              <a:srgbClr val="1F8F74"/>
-            </a:solidFill>
-            <a:prstDash val="solid"/>
+          <a:ln>
+            <a:noFill/>
           </a:ln>
-        </p:spPr>
-      </p:sp>
-      <p:sp>
-        <p:nvSpPr>
-          <p:cNvPr id="9" name="Text 5"/>
-          <p:cNvSpPr txBox="1"/>
-          <p:nvPr/>
-        </p:nvSpPr>
-        <p:spPr>
-          <a:xfrm>
-            <a:off x="3291840" y="1508760"/>
-            <a:ext cx="960120" cy="292608"/>
-          </a:xfrm>
-          <a:prstGeom prst="rect">
-            <a:avLst/>
-          </a:prstGeom>
-          <a:noFill/>
-          <a:ln/>
-        </p:spPr>
-        <p:txBody>
-          <a:bodyPr wrap="square" lIns="0" tIns="0" rIns="0" bIns="0" rtlCol="0" anchor="ctr"/>
-          <a:lstStyle/>
-          <a:p>
-            <a:pPr algn="ctr" indent="0" marL="0">
-              <a:buNone/>
-            </a:pPr>
-            <a:r>
-              <a:rPr lang="en-US" sz="1100" b="1" dirty="0">
+          <a:effectLst/>
+        </p:spPr>
+        <p:style>
+          <a:lnRef idx="1">
+            <a:schemeClr val="accent1"/>
+          </a:lnRef>
+          <a:fillRef idx="3">
+            <a:schemeClr val="accent1"/>
+          </a:fillRef>
+          <a:effectRef idx="2">
+            <a:schemeClr val="accent1"/>
+          </a:effectRef>
+          <a:fontRef idx="minor">
+            <a:schemeClr val="lt1"/>
+          </a:fontRef>
+        </p:style>
+        <p:txBody>
+          <a:bodyPr rtlCol="0" anchor="ctr"/>
+          <a:lstStyle/>
+          <a:p>
+            <a:pPr algn="ctr"/>
+          </a:p>
+        </p:txBody>
+      </p:sp>
+      <p:sp>
+        <p:nvSpPr>
+          <p:cNvPr id="33" name="TextBox 32"/>
+          <p:cNvSpPr txBox="1"/>
+          <p:nvPr/>
+        </p:nvSpPr>
+        <p:spPr>
+          <a:xfrm>
+            <a:off x="841247" y="3675887"/>
+            <a:ext cx="3337560" cy="475488"/>
+          </a:xfrm>
+          <a:prstGeom prst="rect">
+            <a:avLst/>
+          </a:prstGeom>
+          <a:noFill/>
+        </p:spPr>
+        <p:txBody>
+          <a:bodyPr wrap="square" lIns="0" rIns="0" tIns="0" bIns="0" anchor="ctr">
+            <a:spAutoFit/>
+          </a:bodyPr>
+          <a:lstStyle/>
+          <a:p>
+            <a:pPr algn="l"/>
+            <a:r>
+              <a:rPr sz="1100" b="1">
+                <a:solidFill>
+                  <a:srgbClr val="166257"/>
+                </a:solidFill>
+                <a:latin typeface="Calibri"/>
+              </a:rPr>
+              <a:t>Job to be done: </a:t>
+            </a:r>
+            <a:r>
+              <a:rPr sz="1100" b="1">
                 <a:solidFill>
                   <a:srgbClr val="152B56"/>
                 </a:solidFill>
-                <a:latin typeface="Calibri" pitchFamily="34" charset="0"/>
-                <a:ea typeface="Calibri" pitchFamily="34" charset="-122"/>
-                <a:cs typeface="Calibri" pitchFamily="34" charset="-120"/>
-              </a:rPr>
-              <a:t>Priority 1</a:t>
-            </a:r>
-            <a:endParaRPr lang="en-US" sz="1100" dirty="0"/>
-          </a:p>
-        </p:txBody>
-      </p:sp>
-      <p:sp>
-        <p:nvSpPr>
-          <p:cNvPr id="10" name="Text 6"/>
-          <p:cNvSpPr txBox="1"/>
-          <p:nvPr/>
-        </p:nvSpPr>
-        <p:spPr>
-          <a:xfrm>
-            <a:off x="685800" y="2029968"/>
-            <a:ext cx="3566160" cy="320040"/>
-          </a:xfrm>
-          <a:prstGeom prst="rect">
-            <a:avLst/>
-          </a:prstGeom>
-          <a:noFill/>
-          <a:ln/>
-        </p:spPr>
-        <p:txBody>
-          <a:bodyPr wrap="square" lIns="0" tIns="0" rIns="0" bIns="0" rtlCol="0" anchor="t"/>
-          <a:lstStyle/>
-          <a:p>
-            <a:pPr indent="0" marL="0">
-              <a:buNone/>
-            </a:pPr>
-            <a:r>
-              <a:rPr lang="en-US" sz="1700" b="1" dirty="0">
-                <a:solidFill>
-                  <a:srgbClr val="FFFFFF"/>
-                </a:solidFill>
-                <a:latin typeface="Calibri" pitchFamily="34" charset="0"/>
-                <a:ea typeface="Calibri" pitchFamily="34" charset="-122"/>
-                <a:cs typeface="Calibri" pitchFamily="34" charset="-120"/>
-              </a:rPr>
-              <a:t>DIY online borrowers</a:t>
-            </a:r>
-            <a:endParaRPr lang="en-US" sz="1700" dirty="0"/>
-          </a:p>
-        </p:txBody>
-      </p:sp>
-      <p:sp>
-        <p:nvSpPr>
-          <p:cNvPr id="11" name="Text 7"/>
-          <p:cNvSpPr txBox="1"/>
-          <p:nvPr/>
-        </p:nvSpPr>
-        <p:spPr>
-          <a:xfrm>
-            <a:off x="685800" y="2377440"/>
-            <a:ext cx="3566160" cy="960120"/>
-          </a:xfrm>
-          <a:prstGeom prst="rect">
-            <a:avLst/>
-          </a:prstGeom>
-          <a:noFill/>
-          <a:ln/>
-        </p:spPr>
-        <p:txBody>
-          <a:bodyPr wrap="square" lIns="0" tIns="0" rIns="0" bIns="0" rtlCol="0" anchor="t"/>
-          <a:lstStyle/>
-          <a:p>
-            <a:pPr indent="0" marL="0">
-              <a:buNone/>
-            </a:pPr>
-            <a:r>
-              <a:rPr lang="en-US" sz="1300" dirty="0">
-                <a:solidFill>
-                  <a:srgbClr val="C9D6E8"/>
-                </a:solidFill>
-                <a:latin typeface="Calibri" pitchFamily="34" charset="0"/>
-                <a:ea typeface="Calibri" pitchFamily="34" charset="-122"/>
-                <a:cs typeface="Calibri" pitchFamily="34" charset="-120"/>
-              </a:rPr>
-              <a:t>Build their own shortlist in search, comparison sites and AI tools, the channels a digital budget touches directly. Refinancers and upgraders behave the same way once a trigger fires.</a:t>
-            </a:r>
-            <a:endParaRPr lang="en-US" sz="1300" dirty="0"/>
-          </a:p>
-        </p:txBody>
-      </p:sp>
-      <p:sp>
-        <p:nvSpPr>
-          <p:cNvPr id="12" name="Text 8"/>
-          <p:cNvSpPr txBox="1"/>
-          <p:nvPr/>
-        </p:nvSpPr>
-        <p:spPr>
-          <a:xfrm>
-            <a:off x="685800" y="3273552"/>
-            <a:ext cx="3566160" cy="411480"/>
-          </a:xfrm>
-          <a:prstGeom prst="rect">
-            <a:avLst/>
-          </a:prstGeom>
-          <a:noFill/>
-          <a:ln/>
-        </p:spPr>
-        <p:txBody>
-          <a:bodyPr wrap="square" lIns="0" tIns="0" rIns="0" bIns="0" rtlCol="0" anchor="t"/>
-          <a:lstStyle/>
-          <a:p>
-            <a:pPr indent="0" marL="0">
-              <a:buNone/>
-            </a:pPr>
-            <a:r>
-              <a:rPr lang="en-US" sz="1200" b="1" dirty="0">
-                <a:solidFill>
-                  <a:srgbClr val="1F8F74"/>
-                </a:solidFill>
-                <a:latin typeface="Calibri" pitchFamily="34" charset="0"/>
-                <a:ea typeface="Calibri" pitchFamily="34" charset="-122"/>
-                <a:cs typeface="Calibri" pitchFamily="34" charset="-120"/>
-              </a:rPr>
-              <a:t>Job to be done: </a:t>
-            </a:r>
-            <a:pPr indent="0" marL="0">
-              <a:buNone/>
-            </a:pPr>
-            <a:r>
-              <a:rPr lang="en-US" sz="1200" dirty="0">
-                <a:solidFill>
-                  <a:srgbClr val="1F8F74"/>
-                </a:solidFill>
-                <a:latin typeface="Calibri" pitchFamily="34" charset="0"/>
-                <a:ea typeface="Calibri" pitchFamily="34" charset="-122"/>
-                <a:cs typeface="Calibri" pitchFamily="34" charset="-120"/>
+                <a:latin typeface="Calibri"/>
               </a:rPr>
               <a:t>Confirm a better deal is safe before committing</a:t>
             </a:r>
-            <a:endParaRPr lang="en-US" sz="1200" dirty="0"/>
-          </a:p>
-        </p:txBody>
-      </p:sp>
-      <p:sp>
-        <p:nvSpPr>
-          <p:cNvPr id="13" name="Shape 9"/>
-          <p:cNvSpPr/>
-          <p:nvPr/>
-        </p:nvSpPr>
-        <p:spPr>
-          <a:xfrm>
-            <a:off x="4663440" y="1280160"/>
-            <a:ext cx="4023360" cy="2468880"/>
-          </a:xfrm>
-          <a:prstGeom prst="roundRect">
-            <a:avLst>
-              <a:gd name="adj" fmla="val 2963"/>
-            </a:avLst>
-          </a:prstGeom>
-          <a:solidFill>
-            <a:srgbClr val="152B56"/>
-          </a:solidFill>
-          <a:ln w="12700">
-            <a:solidFill>
-              <a:srgbClr val="152B56"/>
-            </a:solidFill>
-            <a:prstDash val="solid"/>
-          </a:ln>
-        </p:spPr>
-      </p:sp>
-      <p:sp>
-        <p:nvSpPr>
-          <p:cNvPr id="14" name="Shape 10"/>
-          <p:cNvSpPr/>
-          <p:nvPr/>
-        </p:nvSpPr>
-        <p:spPr>
-          <a:xfrm>
-            <a:off x="4892040" y="1463040"/>
-            <a:ext cx="457200" cy="457200"/>
-          </a:xfrm>
-          <a:prstGeom prst="ellipse">
-            <a:avLst/>
-          </a:prstGeom>
-          <a:solidFill>
-            <a:srgbClr val="1F8F74"/>
-          </a:solidFill>
-          <a:ln w="12700">
-            <a:solidFill>
-              <a:srgbClr val="1F8F74"/>
-            </a:solidFill>
-            <a:prstDash val="solid"/>
-          </a:ln>
-        </p:spPr>
+          </a:p>
+        </p:txBody>
       </p:sp>
       <p:pic>
         <p:nvPicPr>
-          <p:cNvPr id="15" name="Image 1" descr="preencoded.png">    </p:cNvPr>
+          <p:cNvPr id="34" name="Picture 33" descr="s7_pg9-000.jpg"/>
           <p:cNvPicPr>
             <a:picLocks noChangeAspect="1"/>
           </p:cNvPicPr>
           <p:nvPr/>
         </p:nvPicPr>
         <p:blipFill>
-          <a:blip r:embed="rId2"/>
+          <a:blip r:embed="rId7"/>
           <a:stretch>
             <a:fillRect/>
           </a:stretch>
         </p:blipFill>
         <p:spPr>
           <a:xfrm>
-            <a:off x="5001768" y="1572768"/>
-            <a:ext cx="237744" cy="237744"/>
+            <a:off x="4663440" y="1188720"/>
+            <a:ext cx="4023360" cy="2743200"/>
           </a:xfrm>
           <a:prstGeom prst="rect">
             <a:avLst/>
@@ -13169,366 +13588,372 @@
       </p:pic>
       <p:sp>
         <p:nvSpPr>
-          <p:cNvPr id="16" name="Shape 11"/>
+          <p:cNvPr id="35" name="Rectangle 34"/>
           <p:cNvSpPr/>
           <p:nvPr/>
         </p:nvSpPr>
         <p:spPr>
           <a:xfrm>
-            <a:off x="7498080" y="1508760"/>
-            <a:ext cx="960120" cy="292608"/>
-          </a:xfrm>
-          <a:prstGeom prst="roundRect">
-            <a:avLst>
-              <a:gd name="adj" fmla="val 50000"/>
-            </a:avLst>
+            <a:off x="4892040" y="1371600"/>
+            <a:ext cx="1005840" cy="237744"/>
+          </a:xfrm>
+          <a:prstGeom prst="rect">
+            <a:avLst/>
+          </a:prstGeom>
+          <a:solidFill>
+            <a:srgbClr val="166257"/>
+          </a:solidFill>
+          <a:ln>
+            <a:noFill/>
+          </a:ln>
+          <a:effectLst/>
+        </p:spPr>
+        <p:style>
+          <a:lnRef idx="1">
+            <a:schemeClr val="accent1"/>
+          </a:lnRef>
+          <a:fillRef idx="3">
+            <a:schemeClr val="accent1"/>
+          </a:fillRef>
+          <a:effectRef idx="2">
+            <a:schemeClr val="accent1"/>
+          </a:effectRef>
+          <a:fontRef idx="minor">
+            <a:schemeClr val="lt1"/>
+          </a:fontRef>
+        </p:style>
+        <p:txBody>
+          <a:bodyPr rtlCol="0" anchor="ctr"/>
+          <a:lstStyle/>
+          <a:p>
+            <a:pPr algn="ctr"/>
+          </a:p>
+        </p:txBody>
+      </p:sp>
+      <p:sp>
+        <p:nvSpPr>
+          <p:cNvPr id="36" name="TextBox 35"/>
+          <p:cNvSpPr txBox="1"/>
+          <p:nvPr/>
+        </p:nvSpPr>
+        <p:spPr>
+          <a:xfrm>
+            <a:off x="4892040" y="1371600"/>
+            <a:ext cx="1005840" cy="237744"/>
+          </a:xfrm>
+          <a:prstGeom prst="rect">
+            <a:avLst/>
+          </a:prstGeom>
+          <a:noFill/>
+        </p:spPr>
+        <p:txBody>
+          <a:bodyPr wrap="square" lIns="0" rIns="0" tIns="0" bIns="0" anchor="ctr">
+            <a:spAutoFit/>
+          </a:bodyPr>
+          <a:lstStyle/>
+          <a:p>
+            <a:pPr algn="ctr"/>
+            <a:r>
+              <a:rPr sz="1000" b="1">
+                <a:solidFill>
+                  <a:srgbClr val="FFFFFF"/>
+                </a:solidFill>
+                <a:latin typeface="Calibri"/>
+              </a:rPr>
+              <a:t>PRIORITY 2</a:t>
+            </a:r>
+          </a:p>
+        </p:txBody>
+      </p:sp>
+      <p:sp>
+        <p:nvSpPr>
+          <p:cNvPr id="37" name="TextBox 36"/>
+          <p:cNvSpPr txBox="1"/>
+          <p:nvPr/>
+        </p:nvSpPr>
+        <p:spPr>
+          <a:xfrm>
+            <a:off x="4892040" y="2395728"/>
+            <a:ext cx="3566160" cy="347472"/>
+          </a:xfrm>
+          <a:prstGeom prst="rect">
+            <a:avLst/>
+          </a:prstGeom>
+          <a:noFill/>
+        </p:spPr>
+        <p:txBody>
+          <a:bodyPr wrap="square" lIns="0" rIns="0" tIns="0" bIns="0" anchor="t">
+            <a:spAutoFit/>
+          </a:bodyPr>
+          <a:lstStyle/>
+          <a:p>
+            <a:pPr algn="l"/>
+            <a:r>
+              <a:rPr sz="2000" b="1">
+                <a:solidFill>
+                  <a:srgbClr val="FFFFFF"/>
+                </a:solidFill>
+                <a:latin typeface="Cambria"/>
+              </a:rPr>
+              <a:t>Broker-placed borrowers</a:t>
+            </a:r>
+          </a:p>
+        </p:txBody>
+      </p:sp>
+      <p:sp>
+        <p:nvSpPr>
+          <p:cNvPr id="38" name="TextBox 37"/>
+          <p:cNvSpPr txBox="1"/>
+          <p:nvPr/>
+        </p:nvSpPr>
+        <p:spPr>
+          <a:xfrm>
+            <a:off x="4892040" y="2798064"/>
+            <a:ext cx="3566160" cy="731520"/>
+          </a:xfrm>
+          <a:prstGeom prst="rect">
+            <a:avLst/>
+          </a:prstGeom>
+          <a:noFill/>
+        </p:spPr>
+        <p:txBody>
+          <a:bodyPr wrap="square" lIns="0" rIns="0" tIns="0" bIns="0" anchor="t">
+            <a:spAutoFit/>
+          </a:bodyPr>
+          <a:lstStyle/>
+          <a:p>
+            <a:pPr algn="l"/>
+            <a:r>
+              <a:rPr sz="1100" b="0">
+                <a:solidFill>
+                  <a:srgbClr val="EEF2F8"/>
+                </a:solidFill>
+                <a:latin typeface="Calibri"/>
+              </a:rPr>
+              <a:t>Four in five loans. The broker builds the shortlist from lenders they know and can place quickly. Brokers do not need to hear of AMB; they need a reason to swap a familiar name for it.</a:t>
+            </a:r>
+          </a:p>
+        </p:txBody>
+      </p:sp>
+      <p:sp>
+        <p:nvSpPr>
+          <p:cNvPr id="39" name="Rectangle 38"/>
+          <p:cNvSpPr/>
+          <p:nvPr/>
+        </p:nvSpPr>
+        <p:spPr>
+          <a:xfrm>
+            <a:off x="4892040" y="3675887"/>
+            <a:ext cx="3566160" cy="475488"/>
+          </a:xfrm>
+          <a:prstGeom prst="rect">
+            <a:avLst/>
+          </a:prstGeom>
+          <a:solidFill>
+            <a:srgbClr val="FFFFFF"/>
+          </a:solidFill>
+          <a:ln w="9525">
+            <a:solidFill>
+              <a:srgbClr val="D9DEE7"/>
+            </a:solidFill>
+          </a:ln>
+          <a:effectLst/>
+        </p:spPr>
+        <p:style>
+          <a:lnRef idx="1">
+            <a:schemeClr val="accent1"/>
+          </a:lnRef>
+          <a:fillRef idx="3">
+            <a:schemeClr val="accent1"/>
+          </a:fillRef>
+          <a:effectRef idx="2">
+            <a:schemeClr val="accent1"/>
+          </a:effectRef>
+          <a:fontRef idx="minor">
+            <a:schemeClr val="lt1"/>
+          </a:fontRef>
+        </p:style>
+        <p:txBody>
+          <a:bodyPr rtlCol="0" anchor="ctr"/>
+          <a:lstStyle/>
+          <a:p>
+            <a:pPr algn="ctr"/>
+          </a:p>
+        </p:txBody>
+      </p:sp>
+      <p:sp>
+        <p:nvSpPr>
+          <p:cNvPr id="40" name="Rectangle 39"/>
+          <p:cNvSpPr/>
+          <p:nvPr/>
+        </p:nvSpPr>
+        <p:spPr>
+          <a:xfrm>
+            <a:off x="4892040" y="3675887"/>
+            <a:ext cx="45720" cy="475488"/>
+          </a:xfrm>
+          <a:prstGeom prst="rect">
+            <a:avLst/>
           </a:prstGeom>
           <a:solidFill>
             <a:srgbClr val="1F8F74"/>
           </a:solidFill>
-          <a:ln w="12700">
-            <a:solidFill>
-              <a:srgbClr val="1F8F74"/>
-            </a:solidFill>
-            <a:prstDash val="solid"/>
+          <a:ln>
+            <a:noFill/>
           </a:ln>
-        </p:spPr>
-      </p:sp>
-      <p:sp>
-        <p:nvSpPr>
-          <p:cNvPr id="17" name="Text 12"/>
-          <p:cNvSpPr txBox="1"/>
-          <p:nvPr/>
-        </p:nvSpPr>
-        <p:spPr>
-          <a:xfrm>
-            <a:off x="7498080" y="1508760"/>
-            <a:ext cx="960120" cy="292608"/>
-          </a:xfrm>
-          <a:prstGeom prst="rect">
-            <a:avLst/>
-          </a:prstGeom>
-          <a:noFill/>
-          <a:ln/>
-        </p:spPr>
-        <p:txBody>
-          <a:bodyPr wrap="square" lIns="0" tIns="0" rIns="0" bIns="0" rtlCol="0" anchor="ctr"/>
-          <a:lstStyle/>
-          <a:p>
-            <a:pPr algn="ctr" indent="0" marL="0">
-              <a:buNone/>
-            </a:pPr>
-            <a:r>
-              <a:rPr lang="en-US" sz="1100" b="1" dirty="0">
+          <a:effectLst/>
+        </p:spPr>
+        <p:style>
+          <a:lnRef idx="1">
+            <a:schemeClr val="accent1"/>
+          </a:lnRef>
+          <a:fillRef idx="3">
+            <a:schemeClr val="accent1"/>
+          </a:fillRef>
+          <a:effectRef idx="2">
+            <a:schemeClr val="accent1"/>
+          </a:effectRef>
+          <a:fontRef idx="minor">
+            <a:schemeClr val="lt1"/>
+          </a:fontRef>
+        </p:style>
+        <p:txBody>
+          <a:bodyPr rtlCol="0" anchor="ctr"/>
+          <a:lstStyle/>
+          <a:p>
+            <a:pPr algn="ctr"/>
+          </a:p>
+        </p:txBody>
+      </p:sp>
+      <p:sp>
+        <p:nvSpPr>
+          <p:cNvPr id="41" name="TextBox 40"/>
+          <p:cNvSpPr txBox="1"/>
+          <p:nvPr/>
+        </p:nvSpPr>
+        <p:spPr>
+          <a:xfrm>
+            <a:off x="5047488" y="3675887"/>
+            <a:ext cx="3337560" cy="475488"/>
+          </a:xfrm>
+          <a:prstGeom prst="rect">
+            <a:avLst/>
+          </a:prstGeom>
+          <a:noFill/>
+        </p:spPr>
+        <p:txBody>
+          <a:bodyPr wrap="square" lIns="0" rIns="0" tIns="0" bIns="0" anchor="ctr">
+            <a:spAutoFit/>
+          </a:bodyPr>
+          <a:lstStyle/>
+          <a:p>
+            <a:pPr algn="l"/>
+            <a:r>
+              <a:rPr sz="1100" b="1">
+                <a:solidFill>
+                  <a:srgbClr val="166257"/>
+                </a:solidFill>
+                <a:latin typeface="Calibri"/>
+              </a:rPr>
+              <a:t>Job to be done: </a:t>
+            </a:r>
+            <a:r>
+              <a:rPr sz="1100" b="1">
                 <a:solidFill>
                   <a:srgbClr val="152B56"/>
                 </a:solidFill>
-                <a:latin typeface="Calibri" pitchFamily="34" charset="0"/>
-                <a:ea typeface="Calibri" pitchFamily="34" charset="-122"/>
-                <a:cs typeface="Calibri" pitchFamily="34" charset="-120"/>
-              </a:rPr>
-              <a:t>Priority 2</a:t>
-            </a:r>
-            <a:endParaRPr lang="en-US" sz="1100" dirty="0"/>
-          </a:p>
-        </p:txBody>
-      </p:sp>
-      <p:sp>
-        <p:nvSpPr>
-          <p:cNvPr id="18" name="Text 13"/>
-          <p:cNvSpPr txBox="1"/>
-          <p:nvPr/>
-        </p:nvSpPr>
-        <p:spPr>
-          <a:xfrm>
-            <a:off x="4892040" y="2029968"/>
-            <a:ext cx="3566160" cy="320040"/>
-          </a:xfrm>
-          <a:prstGeom prst="rect">
-            <a:avLst/>
-          </a:prstGeom>
-          <a:noFill/>
-          <a:ln/>
-        </p:spPr>
-        <p:txBody>
-          <a:bodyPr wrap="square" lIns="0" tIns="0" rIns="0" bIns="0" rtlCol="0" anchor="t"/>
-          <a:lstStyle/>
-          <a:p>
-            <a:pPr indent="0" marL="0">
-              <a:buNone/>
-            </a:pPr>
-            <a:r>
-              <a:rPr lang="en-US" sz="1700" b="1" dirty="0">
-                <a:solidFill>
-                  <a:srgbClr val="FFFFFF"/>
-                </a:solidFill>
-                <a:latin typeface="Calibri" pitchFamily="34" charset="0"/>
-                <a:ea typeface="Calibri" pitchFamily="34" charset="-122"/>
-                <a:cs typeface="Calibri" pitchFamily="34" charset="-120"/>
-              </a:rPr>
-              <a:t>Broker-placed borrowers</a:t>
-            </a:r>
-            <a:endParaRPr lang="en-US" sz="1700" dirty="0"/>
-          </a:p>
-        </p:txBody>
-      </p:sp>
-      <p:sp>
-        <p:nvSpPr>
-          <p:cNvPr id="19" name="Text 14"/>
-          <p:cNvSpPr txBox="1"/>
-          <p:nvPr/>
-        </p:nvSpPr>
-        <p:spPr>
-          <a:xfrm>
-            <a:off x="4892040" y="2377440"/>
-            <a:ext cx="3566160" cy="960120"/>
-          </a:xfrm>
-          <a:prstGeom prst="rect">
-            <a:avLst/>
-          </a:prstGeom>
-          <a:noFill/>
-          <a:ln/>
-        </p:spPr>
-        <p:txBody>
-          <a:bodyPr wrap="square" lIns="0" tIns="0" rIns="0" bIns="0" rtlCol="0" anchor="t"/>
-          <a:lstStyle/>
-          <a:p>
-            <a:pPr indent="0" marL="0">
-              <a:buNone/>
-            </a:pPr>
-            <a:r>
-              <a:rPr lang="en-US" sz="1300" dirty="0">
-                <a:solidFill>
-                  <a:srgbClr val="C9D6E8"/>
-                </a:solidFill>
-                <a:latin typeface="Calibri" pitchFamily="34" charset="0"/>
-                <a:ea typeface="Calibri" pitchFamily="34" charset="-122"/>
-                <a:cs typeface="Calibri" pitchFamily="34" charset="-120"/>
-              </a:rPr>
-              <a:t>Four in five loans. The broker builds the shortlist from lenders they know and can place quickly. Brokers do not need to hear of AMB; they need a reason to swap a familiar name for it.</a:t>
-            </a:r>
-            <a:endParaRPr lang="en-US" sz="1300" dirty="0"/>
-          </a:p>
-        </p:txBody>
-      </p:sp>
-      <p:sp>
-        <p:nvSpPr>
-          <p:cNvPr id="20" name="Text 15"/>
-          <p:cNvSpPr txBox="1"/>
-          <p:nvPr/>
-        </p:nvSpPr>
-        <p:spPr>
-          <a:xfrm>
-            <a:off x="4892040" y="3273552"/>
-            <a:ext cx="3566160" cy="411480"/>
-          </a:xfrm>
-          <a:prstGeom prst="rect">
-            <a:avLst/>
-          </a:prstGeom>
-          <a:noFill/>
-          <a:ln/>
-        </p:spPr>
-        <p:txBody>
-          <a:bodyPr wrap="square" lIns="0" tIns="0" rIns="0" bIns="0" rtlCol="0" anchor="t"/>
-          <a:lstStyle/>
-          <a:p>
-            <a:pPr indent="0" marL="0">
-              <a:buNone/>
-            </a:pPr>
-            <a:r>
-              <a:rPr lang="en-US" sz="1200" b="1" dirty="0">
-                <a:solidFill>
-                  <a:srgbClr val="1F8F74"/>
-                </a:solidFill>
-                <a:latin typeface="Calibri" pitchFamily="34" charset="0"/>
-                <a:ea typeface="Calibri" pitchFamily="34" charset="-122"/>
-                <a:cs typeface="Calibri" pitchFamily="34" charset="-120"/>
-              </a:rPr>
-              <a:t>Job to be done: </a:t>
-            </a:r>
-            <a:pPr indent="0" marL="0">
-              <a:buNone/>
-            </a:pPr>
-            <a:r>
-              <a:rPr lang="en-US" sz="1200" dirty="0">
-                <a:solidFill>
-                  <a:srgbClr val="1F8F74"/>
-                </a:solidFill>
-                <a:latin typeface="Calibri" pitchFamily="34" charset="0"/>
-                <a:ea typeface="Calibri" pitchFamily="34" charset="-122"/>
-                <a:cs typeface="Calibri" pitchFamily="34" charset="-120"/>
+                <a:latin typeface="Calibri"/>
               </a:rPr>
               <a:t>Get a loan sorted without becoming an expert</a:t>
             </a:r>
-            <a:endParaRPr lang="en-US" sz="1200" dirty="0"/>
-          </a:p>
-        </p:txBody>
-      </p:sp>
-      <p:sp>
-        <p:nvSpPr>
-          <p:cNvPr id="21" name="Shape 16"/>
+          </a:p>
+        </p:txBody>
+      </p:sp>
+      <p:sp>
+        <p:nvSpPr>
+          <p:cNvPr id="42" name="Rectangle 41"/>
           <p:cNvSpPr/>
           <p:nvPr/>
         </p:nvSpPr>
         <p:spPr>
           <a:xfrm>
-            <a:off x="457200" y="3858768"/>
-            <a:ext cx="8229600" cy="731520"/>
-          </a:xfrm>
-          <a:prstGeom prst="roundRect">
-            <a:avLst>
-              <a:gd name="adj" fmla="val 10000"/>
-            </a:avLst>
+            <a:off x="457200" y="4425696"/>
+            <a:ext cx="457200" cy="27432"/>
+          </a:xfrm>
+          <a:prstGeom prst="rect">
+            <a:avLst/>
           </a:prstGeom>
           <a:solidFill>
-            <a:srgbClr val="F1F4F9"/>
+            <a:srgbClr val="1F8F74"/>
           </a:solidFill>
-          <a:ln w="12700">
-            <a:solidFill>
-              <a:srgbClr val="F1F4F9"/>
-            </a:solidFill>
-            <a:prstDash val="solid"/>
+          <a:ln>
+            <a:noFill/>
           </a:ln>
-        </p:spPr>
-      </p:sp>
-      <p:sp>
-        <p:nvSpPr>
-          <p:cNvPr id="22" name="Shape 17"/>
-          <p:cNvSpPr/>
-          <p:nvPr/>
-        </p:nvSpPr>
-        <p:spPr>
-          <a:xfrm>
-            <a:off x="640080" y="3995928"/>
-            <a:ext cx="457200" cy="457200"/>
-          </a:xfrm>
-          <a:prstGeom prst="ellipse">
-            <a:avLst/>
-          </a:prstGeom>
-          <a:solidFill>
-            <a:srgbClr val="8A94A6"/>
-          </a:solidFill>
-          <a:ln w="12700">
-            <a:solidFill>
-              <a:srgbClr val="8A94A6"/>
-            </a:solidFill>
-            <a:prstDash val="solid"/>
-          </a:ln>
-        </p:spPr>
-      </p:sp>
-      <p:pic>
-        <p:nvPicPr>
-          <p:cNvPr id="23" name="Image 2" descr="preencoded.png">    </p:cNvPr>
-          <p:cNvPicPr>
-            <a:picLocks noChangeAspect="1"/>
-          </p:cNvPicPr>
-          <p:nvPr/>
-        </p:nvPicPr>
-        <p:blipFill>
-          <a:blip r:embed="rId3"/>
-          <a:stretch>
-            <a:fillRect/>
-          </a:stretch>
-        </p:blipFill>
-        <p:spPr>
-          <a:xfrm>
-            <a:off x="749808" y="4105656"/>
-            <a:ext cx="237744" cy="237744"/>
-          </a:xfrm>
-          <a:prstGeom prst="rect">
-            <a:avLst/>
-          </a:prstGeom>
-        </p:spPr>
-      </p:pic>
-      <p:sp>
-        <p:nvSpPr>
-          <p:cNvPr id="24" name="Text 18"/>
-          <p:cNvSpPr txBox="1"/>
-          <p:nvPr/>
-        </p:nvSpPr>
-        <p:spPr>
-          <a:xfrm>
-            <a:off x="1234440" y="3886200"/>
-            <a:ext cx="7315200" cy="676656"/>
-          </a:xfrm>
-          <a:prstGeom prst="rect">
-            <a:avLst/>
-          </a:prstGeom>
-          <a:noFill/>
-          <a:ln/>
-        </p:spPr>
-        <p:txBody>
-          <a:bodyPr wrap="square" lIns="0" tIns="0" rIns="0" bIns="0" rtlCol="0" anchor="ctr"/>
-          <a:lstStyle/>
-          <a:p>
-            <a:pPr indent="0" marL="0">
-              <a:buNone/>
-            </a:pPr>
-            <a:r>
-              <a:rPr lang="en-US" sz="1200" b="1" dirty="0">
+          <a:effectLst/>
+        </p:spPr>
+        <p:style>
+          <a:lnRef idx="1">
+            <a:schemeClr val="accent1"/>
+          </a:lnRef>
+          <a:fillRef idx="3">
+            <a:schemeClr val="accent1"/>
+          </a:fillRef>
+          <a:effectRef idx="2">
+            <a:schemeClr val="accent1"/>
+          </a:effectRef>
+          <a:fontRef idx="minor">
+            <a:schemeClr val="lt1"/>
+          </a:fontRef>
+        </p:style>
+        <p:txBody>
+          <a:bodyPr rtlCol="0" anchor="ctr"/>
+          <a:lstStyle/>
+          <a:p>
+            <a:pPr algn="ctr"/>
+          </a:p>
+        </p:txBody>
+      </p:sp>
+      <p:sp>
+        <p:nvSpPr>
+          <p:cNvPr id="43" name="TextBox 42"/>
+          <p:cNvSpPr txBox="1"/>
+          <p:nvPr/>
+        </p:nvSpPr>
+        <p:spPr>
+          <a:xfrm>
+            <a:off x="457200" y="4517136"/>
+            <a:ext cx="7589520" cy="457200"/>
+          </a:xfrm>
+          <a:prstGeom prst="rect">
+            <a:avLst/>
+          </a:prstGeom>
+          <a:noFill/>
+        </p:spPr>
+        <p:txBody>
+          <a:bodyPr wrap="square" lIns="0" rIns="0" tIns="0" bIns="0" anchor="t">
+            <a:spAutoFit/>
+          </a:bodyPr>
+          <a:lstStyle/>
+          <a:p>
+            <a:pPr algn="l"/>
+            <a:r>
+              <a:rPr sz="1050" b="1">
                 <a:solidFill>
                   <a:srgbClr val="152B56"/>
                 </a:solidFill>
-                <a:latin typeface="Calibri" pitchFamily="34" charset="0"/>
-                <a:ea typeface="Calibri" pitchFamily="34" charset="-122"/>
-                <a:cs typeface="Calibri" pitchFamily="34" charset="-120"/>
+                <a:latin typeface="Calibri"/>
               </a:rPr>
               <a:t>Not prioritised  </a:t>
             </a:r>
-            <a:pPr indent="0" marL="0">
-              <a:buNone/>
-            </a:pPr>
-            <a:r>
-              <a:rPr lang="en-US" sz="1200" dirty="0">
-                <a:solidFill>
-                  <a:srgbClr val="1E2633"/>
-                </a:solidFill>
-                <a:latin typeface="Calibri" pitchFamily="34" charset="0"/>
-                <a:ea typeface="Calibri" pitchFamily="34" charset="-122"/>
-                <a:cs typeface="Calibri" pitchFamily="34" charset="-120"/>
+            <a:r>
+              <a:rPr sz="1050" b="0">
+                <a:solidFill>
+                  <a:srgbClr val="556070"/>
+                </a:solidFill>
+                <a:latin typeface="Calibri"/>
               </a:rPr>
               <a:t>Borrowers who go straight to the family's big-four bank have no evaluation step to intercept. First-home, refinance and upgrade are triggers rather than channels: when they fire, the person either searches online or calls a broker, so the two moves above reach them.</a:t>
             </a:r>
-            <a:endParaRPr lang="en-US" sz="1200" dirty="0"/>
-          </a:p>
-        </p:txBody>
-      </p:sp>
-      <p:sp>
-        <p:nvSpPr>
-          <p:cNvPr id="25" name="Text 19"/>
-          <p:cNvSpPr txBox="1"/>
-          <p:nvPr/>
-        </p:nvSpPr>
-        <p:spPr>
-          <a:xfrm>
-            <a:off x="8229600" y="4754880"/>
-            <a:ext cx="457200" cy="228600"/>
-          </a:xfrm>
-          <a:prstGeom prst="rect">
-            <a:avLst/>
-          </a:prstGeom>
-          <a:noFill/>
-          <a:ln/>
-        </p:spPr>
-        <p:txBody>
-          <a:bodyPr wrap="square" lIns="0" tIns="0" rIns="0" bIns="0" rtlCol="0" anchor="ctr"/>
-          <a:lstStyle/>
-          <a:p>
-            <a:pPr algn="r" indent="0" marL="0">
-              <a:buNone/>
-            </a:pPr>
-            <a:r>
-              <a:rPr lang="en-US" sz="1000" dirty="0">
-                <a:solidFill>
-                  <a:srgbClr val="556070"/>
-                </a:solidFill>
-                <a:latin typeface="Calibri" pitchFamily="34" charset="0"/>
-                <a:ea typeface="Calibri" pitchFamily="34" charset="-122"/>
-                <a:cs typeface="Calibri" pitchFamily="34" charset="-120"/>
-              </a:rPr>
-              <a:t>7</a:t>
-            </a:r>
-            <a:endParaRPr lang="en-US" sz="1000" dirty="0"/>
           </a:p>
         </p:txBody>
       </p:sp>
@@ -13785,49 +14210,24 @@
           </a:ln>
         </p:spPr>
       </p:sp>
-      <p:sp>
-        <p:nvSpPr>
-          <p:cNvPr id="8" name="Shape 3"/>
-          <p:cNvSpPr/>
-          <p:nvPr/>
-        </p:nvSpPr>
-        <p:spPr>
-          <a:xfrm>
-            <a:off x="5852160" y="1444752"/>
-            <a:ext cx="384048" cy="384048"/>
-          </a:xfrm>
-          <a:prstGeom prst="ellipse">
-            <a:avLst/>
-          </a:prstGeom>
-          <a:solidFill>
-            <a:srgbClr val="152B56"/>
-          </a:solidFill>
-          <a:ln w="12700">
-            <a:solidFill>
-              <a:srgbClr val="152B56"/>
-            </a:solidFill>
-            <a:prstDash val="solid"/>
-          </a:ln>
-        </p:spPr>
-      </p:sp>
       <p:pic>
         <p:nvPicPr>
-          <p:cNvPr id="9" name="Image 0" descr="preencoded.png">    </p:cNvPr>
+          <p:cNvPr id="15" name="Picture 14" descr="s8_pg18.jpg"/>
           <p:cNvPicPr>
             <a:picLocks noChangeAspect="1"/>
           </p:cNvPicPr>
           <p:nvPr/>
         </p:nvPicPr>
         <p:blipFill>
-          <a:blip r:embed="rId3"/>
+          <a:blip r:embed="rId6"/>
           <a:stretch>
             <a:fillRect/>
           </a:stretch>
         </p:blipFill>
         <p:spPr>
           <a:xfrm>
-            <a:off x="5944332" y="1536924"/>
-            <a:ext cx="199705" cy="199705"/>
+            <a:off x="5669280" y="1280160"/>
+            <a:ext cx="3017520" cy="777240"/>
           </a:xfrm>
           <a:prstGeom prst="rect">
             <a:avLst/>
@@ -13842,8 +14242,8 @@
         </p:nvSpPr>
         <p:spPr>
           <a:xfrm>
-            <a:off x="6355080" y="1444752"/>
-            <a:ext cx="2240280" cy="411480"/>
+            <a:off x="5852160" y="2176272"/>
+            <a:ext cx="2697480" cy="274320"/>
           </a:xfrm>
           <a:prstGeom prst="rect">
             <a:avLst/>
@@ -13859,7 +14259,7 @@
               <a:buNone/>
             </a:pPr>
             <a:r>
-              <a:rPr lang="en-US" sz="1350" b="1" dirty="0">
+              <a:rPr lang="en-US" sz="1282" b="1" dirty="0">
                 <a:solidFill>
                   <a:srgbClr val="152B56"/>
                 </a:solidFill>
@@ -13869,7 +14269,7 @@
               </a:rPr>
               <a:t>What would make them comfortable</a:t>
             </a:r>
-            <a:endParaRPr lang="en-US" sz="1350" dirty="0"/>
+            <a:endParaRPr lang="en-US" sz="1282" dirty="0"/>
           </a:p>
         </p:txBody>
       </p:sp>
@@ -13881,7 +14281,7 @@
         </p:nvSpPr>
         <p:spPr>
           <a:xfrm>
-            <a:off x="5852160" y="1920240"/>
+            <a:off x="5852160" y="2514600"/>
             <a:ext cx="2697480" cy="1645920"/>
           </a:xfrm>
           <a:prstGeom prst="rect">
@@ -13902,7 +14302,7 @@
               <a:buChar char="•"/>
             </a:pPr>
             <a:r>
-              <a:rPr lang="en-US" sz="1200" dirty="0">
+              <a:rPr lang="en-US" sz="1104" dirty="0">
                 <a:solidFill>
                   <a:srgbClr val="1E2633"/>
                 </a:solidFill>
@@ -13912,7 +14312,7 @@
               </a:rPr>
               <a:t>Real rate, fees and approval time up front (7 of 8)</a:t>
             </a:r>
-            <a:endParaRPr lang="en-US" sz="1200" dirty="0"/>
+            <a:endParaRPr lang="en-US" sz="1104" dirty="0"/>
           </a:p>
           <a:p>
             <a:pPr marL="342900" indent="-342900">
@@ -13923,7 +14323,7 @@
               <a:buChar char="•"/>
             </a:pPr>
             <a:r>
-              <a:rPr lang="en-US" sz="1200" dirty="0">
+              <a:rPr lang="en-US" sz="1104" dirty="0">
                 <a:solidFill>
                   <a:srgbClr val="1E2633"/>
                 </a:solidFill>
@@ -13933,7 +14333,7 @@
               </a:rPr>
               <a:t>Knowing someone like them had used it (6 of 8)</a:t>
             </a:r>
-            <a:endParaRPr lang="en-US" sz="1200" dirty="0"/>
+            <a:endParaRPr lang="en-US" sz="1104" dirty="0"/>
           </a:p>
           <a:p>
             <a:pPr marL="342900" indent="-342900">
@@ -13944,7 +14344,7 @@
               <a:buChar char="•"/>
             </a:pPr>
             <a:r>
-              <a:rPr lang="en-US" sz="1200" dirty="0">
+              <a:rPr lang="en-US" sz="1104" dirty="0">
                 <a:solidFill>
                   <a:srgbClr val="1E2633"/>
                 </a:solidFill>
@@ -13954,7 +14354,7 @@
               </a:rPr>
               <a:t>Independent reviews or ratings (6 of 8)</a:t>
             </a:r>
-            <a:endParaRPr lang="en-US" sz="1200" dirty="0"/>
+            <a:endParaRPr lang="en-US" sz="1104" dirty="0"/>
           </a:p>
           <a:p>
             <a:pPr marL="342900" indent="-342900">
@@ -13965,7 +14365,7 @@
               <a:buChar char="•"/>
             </a:pPr>
             <a:r>
-              <a:rPr lang="en-US" sz="1200" dirty="0">
+              <a:rPr lang="en-US" sz="1104" dirty="0">
                 <a:solidFill>
                   <a:srgbClr val="1E2633"/>
                 </a:solidFill>
@@ -13975,7 +14375,7 @@
               </a:rPr>
               <a:t>A quantified, easy-to-verify advantage (6 of 8)</a:t>
             </a:r>
-            <a:endParaRPr lang="en-US" sz="1200" dirty="0"/>
+            <a:endParaRPr lang="en-US" sz="1104" dirty="0"/>
           </a:p>
         </p:txBody>
       </p:sp>
@@ -13987,8 +14387,8 @@
         </p:nvSpPr>
         <p:spPr>
           <a:xfrm>
-            <a:off x="5852160" y="3675888"/>
-            <a:ext cx="2697480" cy="777240"/>
+            <a:off x="5852160" y="3986784"/>
+            <a:ext cx="2697480" cy="457200"/>
           </a:xfrm>
           <a:prstGeom prst="rect">
             <a:avLst/>
@@ -14004,7 +14404,7 @@
               <a:buNone/>
             </a:pPr>
             <a:r>
-              <a:rPr lang="en-US" sz="1100" i="1" dirty="0">
+              <a:rPr lang="en-US" sz="990" i="1" dirty="0">
                 <a:solidFill>
                   <a:srgbClr val="556070"/>
                 </a:solidFill>
@@ -14014,7 +14414,7 @@
               </a:rPr>
               <a:t>The customer-owned label appealed to the three respondents who had never taken a loan and moved two of the seven who had.</a:t>
             </a:r>
-            <a:endParaRPr lang="en-US" sz="1100" dirty="0"/>
+            <a:endParaRPr lang="en-US" sz="990" dirty="0"/>
           </a:p>
         </p:txBody>
       </p:sp>
@@ -14737,49 +15137,24 @@
           </a:ln>
         </p:spPr>
       </p:sp>
-      <p:sp>
-        <p:nvSpPr>
-          <p:cNvPr id="18" name="Shape 15"/>
-          <p:cNvSpPr/>
-          <p:nvPr/>
-        </p:nvSpPr>
-        <p:spPr>
-          <a:xfrm>
-            <a:off x="685800" y="3520440"/>
-            <a:ext cx="457200" cy="457200"/>
-          </a:xfrm>
-          <a:prstGeom prst="ellipse">
-            <a:avLst/>
-          </a:prstGeom>
-          <a:solidFill>
-            <a:srgbClr val="1F8F74"/>
-          </a:solidFill>
-          <a:ln w="12700">
-            <a:solidFill>
-              <a:srgbClr val="1F8F74"/>
-            </a:solidFill>
-            <a:prstDash val="solid"/>
-          </a:ln>
-        </p:spPr>
-      </p:sp>
       <p:pic>
         <p:nvPicPr>
-          <p:cNvPr id="19" name="Image 0" descr="preencoded.png">    </p:cNvPr>
+          <p:cNvPr id="23" name="Picture 22" descr="s9_pg10.jpg"/>
           <p:cNvPicPr>
             <a:picLocks noChangeAspect="1"/>
           </p:cNvPicPr>
           <p:nvPr/>
         </p:nvPicPr>
         <p:blipFill>
-          <a:blip r:embed="rId1"/>
+          <a:blip r:embed="rId4"/>
           <a:stretch>
             <a:fillRect/>
           </a:stretch>
         </p:blipFill>
         <p:spPr>
           <a:xfrm>
-            <a:off x="795528" y="3630168"/>
-            <a:ext cx="237744" cy="237744"/>
+            <a:off x="457200" y="3246120"/>
+            <a:ext cx="1371600" cy="1234440"/>
           </a:xfrm>
           <a:prstGeom prst="rect">
             <a:avLst/>
@@ -14794,8 +15169,8 @@
         </p:nvSpPr>
         <p:spPr>
           <a:xfrm>
-            <a:off x="1325880" y="3337560"/>
-            <a:ext cx="7178040" cy="1051560"/>
+            <a:off x="2057400" y="3337560"/>
+            <a:ext cx="6446520" cy="1051560"/>
           </a:xfrm>
           <a:prstGeom prst="rect">
             <a:avLst/>

</xml_diff>

<commit_message>
Slide 4: report-style highlights layout with three photo+stat rows and tall photo
Co-Authored-By: Claude Sonnet 5.5 <noreply@anthropic.com>
Claude-Session: https://claude.ai/code/session_018FYC5nzQydn1DiijEsEsUi
</commit_message>
<xml_diff>
--- a/AMB_Draft_4_remaster_wip.pptx
+++ b/AMB_Draft_4_remaster_wip.pptx
@@ -10167,8 +10167,8 @@
         </p:nvSpPr>
         <p:spPr>
           <a:xfrm>
-            <a:off x="457200" y="384048"/>
-            <a:ext cx="8229600" cy="731520"/>
+            <a:off x="658368" y="475488"/>
+            <a:ext cx="5257800" cy="914400"/>
           </a:xfrm>
           <a:prstGeom prst="rect">
             <a:avLst/>
@@ -10184,7 +10184,7 @@
               <a:buNone/>
             </a:pPr>
             <a:r>
-              <a:rPr lang="en-US" sz="2000" b="1" dirty="0">
+              <a:rPr lang="en-US" sz="1900" b="1" dirty="0">
                 <a:solidFill>
                   <a:srgbClr val="152B56"/>
                 </a:solidFill>
@@ -10194,7 +10194,7 @@
               </a:rPr>
               <a:t>Three sources of evidence: six journey maps, 17 questionnaire responses and five industry datasets</a:t>
             </a:r>
-            <a:endParaRPr lang="en-US" sz="2000" dirty="0"/>
+            <a:endParaRPr lang="en-US" sz="1900" dirty="0"/>
           </a:p>
         </p:txBody>
       </p:sp>
@@ -10206,8 +10206,8 @@
         </p:nvSpPr>
         <p:spPr>
           <a:xfrm>
-            <a:off x="457200" y="4645152"/>
-            <a:ext cx="7680960" cy="347472"/>
+            <a:off x="457200" y="4572000"/>
+            <a:ext cx="5486400" cy="347472"/>
           </a:xfrm>
           <a:prstGeom prst="rect">
             <a:avLst/>
@@ -10239,149 +10239,25 @@
       </p:sp>
       <p:sp>
         <p:nvSpPr>
-          <p:cNvPr id="24" name="Text 18"/>
-          <p:cNvSpPr txBox="1"/>
-          <p:nvPr/>
-        </p:nvSpPr>
-        <p:spPr>
-          <a:xfrm>
-            <a:off x="8229600" y="4754880"/>
-            <a:ext cx="457200" cy="228600"/>
-          </a:xfrm>
-          <a:prstGeom prst="rect">
-            <a:avLst/>
-          </a:prstGeom>
-          <a:noFill/>
-          <a:ln/>
-        </p:spPr>
-        <p:txBody>
-          <a:bodyPr wrap="square" lIns="0" tIns="0" rIns="0" bIns="0" rtlCol="0" anchor="ctr"/>
-          <a:lstStyle/>
-          <a:p>
-            <a:pPr algn="r" indent="0" marL="0">
-              <a:buNone/>
-            </a:pPr>
-            <a:r>
-              <a:rPr lang="en-US" sz="1000" dirty="0">
-                <a:solidFill>
-                  <a:srgbClr val="556070"/>
-                </a:solidFill>
-                <a:latin typeface="Calibri" pitchFamily="34" charset="0"/>
-                <a:ea typeface="Calibri" pitchFamily="34" charset="-122"/>
-                <a:cs typeface="Calibri" pitchFamily="34" charset="-120"/>
-              </a:rPr>
-              <a:t>4</a:t>
-            </a:r>
-            <a:endParaRPr lang="en-US" sz="1000" dirty="0"/>
-          </a:p>
-        </p:txBody>
-      </p:sp>
-      <p:sp>
-        <p:nvSpPr>
-          <p:cNvPr id="26" name="TextBox 25"/>
-          <p:cNvSpPr txBox="1"/>
-          <p:nvPr/>
-        </p:nvSpPr>
-        <p:spPr>
-          <a:xfrm>
-            <a:off x="2537200" y="1190000"/>
-            <a:ext cx="1200000" cy="1080000"/>
-          </a:xfrm>
-          <a:prstGeom prst="rect">
-            <a:avLst/>
-          </a:prstGeom>
-          <a:noFill/>
-        </p:spPr>
-        <p:txBody>
-          <a:bodyPr wrap="square">
-            <a:spAutoFit/>
-          </a:bodyPr>
-          <a:lstStyle/>
-          <a:p>
-            <a:r>
-              <a:rPr sz="4000" b="1">
-                <a:solidFill>
-                  <a:srgbClr val="152B56"/>
-                </a:solidFill>
-                <a:latin typeface="Cambria"/>
-              </a:rPr>
-              <a:t>6</a:t>
-            </a:r>
-          </a:p>
-        </p:txBody>
-      </p:sp>
-      <p:sp>
-        <p:nvSpPr>
-          <p:cNvPr id="27" name="TextBox 26"/>
-          <p:cNvSpPr txBox="1"/>
-          <p:nvPr/>
-        </p:nvSpPr>
-        <p:spPr>
-          <a:xfrm>
-            <a:off x="3837200" y="1250000"/>
-            <a:ext cx="4849600" cy="1080000"/>
-          </a:xfrm>
-          <a:prstGeom prst="rect">
-            <a:avLst/>
-          </a:prstGeom>
-          <a:noFill/>
-        </p:spPr>
-        <p:txBody>
-          <a:bodyPr wrap="square">
-            <a:spAutoFit/>
-          </a:bodyPr>
-          <a:lstStyle/>
-          <a:p>
-            <a:pPr>
-              <a:defRPr sz="1400" b="1">
-                <a:solidFill>
-                  <a:srgbClr val="166257"/>
-                </a:solidFill>
-                <a:latin typeface="Calibri"/>
-              </a:defRPr>
-            </a:pPr>
-            <a:r>
-              <a:t>customer journey maps</a:t>
-            </a:r>
-          </a:p>
-          <a:p>
-            <a:pPr>
-              <a:spcBef>
-                <a:spcPts val="400"/>
-              </a:spcBef>
-              <a:defRPr sz="1050">
-                <a:solidFill>
-                  <a:srgbClr val="556070"/>
-                </a:solidFill>
-                <a:latin typeface="Calibri"/>
-              </a:defRPr>
-            </a:pPr>
-            <a:r>
-              <a:t>One borrower group each. We wrote the map we assumed, did primary research, then rewrote it. Combined primary sample of 42 across the six.</a:t>
-            </a:r>
-          </a:p>
-        </p:txBody>
-      </p:sp>
-      <p:sp>
-        <p:nvSpPr>
-          <p:cNvPr id="28" name="Rectangle 27"/>
+          <p:cNvPr id="25" name="Rectangle 24"/>
           <p:cNvSpPr/>
           <p:nvPr/>
         </p:nvSpPr>
         <p:spPr>
           <a:xfrm>
-            <a:off x="457200" y="2365000"/>
-            <a:ext cx="8229600" cy="10000"/>
+            <a:off x="457200" y="493776"/>
+            <a:ext cx="45720" cy="841248"/>
           </a:xfrm>
           <a:prstGeom prst="rect">
             <a:avLst/>
           </a:prstGeom>
           <a:solidFill>
-            <a:srgbClr val="D9DEE7"/>
+            <a:srgbClr val="1F8F74"/>
           </a:solidFill>
           <a:ln>
             <a:noFill/>
           </a:ln>
+          <a:effectLst/>
         </p:spPr>
         <p:style>
           <a:lnRef idx="1">
@@ -10407,134 +10283,73 @@
       </p:sp>
       <p:pic>
         <p:nvPicPr>
-          <p:cNvPr id="29" name="Picture 28" descr="s4_row2.jpg"/>
+          <p:cNvPr id="26" name="Picture 25" descr="s4_pg5.jpg"/>
           <p:cNvPicPr>
             <a:picLocks noChangeAspect="1"/>
           </p:cNvPicPr>
           <p:nvPr/>
         </p:nvPicPr>
         <p:blipFill>
-          <a:blip r:embed="rId7"/>
+          <a:blip r:embed="rId10"/>
           <a:stretch>
             <a:fillRect/>
           </a:stretch>
         </p:blipFill>
         <p:spPr>
           <a:xfrm>
-            <a:off x="457200" y="2400000"/>
-            <a:ext cx="1618983" cy="1080000"/>
+            <a:off x="6263640" y="411480"/>
+            <a:ext cx="2880360" cy="4732020"/>
           </a:xfrm>
           <a:prstGeom prst="rect">
             <a:avLst/>
           </a:prstGeom>
         </p:spPr>
       </p:pic>
-      <p:sp>
-        <p:nvSpPr>
-          <p:cNvPr id="30" name="TextBox 29"/>
-          <p:cNvSpPr txBox="1"/>
-          <p:nvPr/>
-        </p:nvSpPr>
-        <p:spPr>
-          <a:xfrm>
-            <a:off x="2537200" y="2340000"/>
-            <a:ext cx="1200000" cy="1080000"/>
-          </a:xfrm>
-          <a:prstGeom prst="rect">
-            <a:avLst/>
-          </a:prstGeom>
-          <a:noFill/>
-        </p:spPr>
-        <p:txBody>
-          <a:bodyPr wrap="square">
-            <a:spAutoFit/>
-          </a:bodyPr>
-          <a:lstStyle/>
-          <a:p>
-            <a:r>
-              <a:rPr sz="4000" b="1">
-                <a:solidFill>
-                  <a:srgbClr val="152B56"/>
-                </a:solidFill>
-                <a:latin typeface="Cambria"/>
-              </a:rPr>
-              <a:t>17</a:t>
-            </a:r>
-          </a:p>
-        </p:txBody>
-      </p:sp>
-      <p:sp>
-        <p:nvSpPr>
-          <p:cNvPr id="31" name="TextBox 30"/>
-          <p:cNvSpPr txBox="1"/>
-          <p:nvPr/>
-        </p:nvSpPr>
-        <p:spPr>
-          <a:xfrm>
-            <a:off x="3837200" y="2400000"/>
-            <a:ext cx="4849600" cy="1080000"/>
-          </a:xfrm>
-          <a:prstGeom prst="rect">
-            <a:avLst/>
-          </a:prstGeom>
-          <a:noFill/>
-        </p:spPr>
-        <p:txBody>
-          <a:bodyPr wrap="square">
-            <a:spAutoFit/>
-          </a:bodyPr>
-          <a:lstStyle/>
-          <a:p>
-            <a:pPr>
-              <a:defRPr sz="1400" b="1">
-                <a:solidFill>
-                  <a:srgbClr val="166257"/>
-                </a:solidFill>
-                <a:latin typeface="Calibri"/>
-              </a:defRPr>
-            </a:pPr>
-            <a:r>
-              <a:t>questionnaire responses</a:t>
-            </a:r>
-          </a:p>
-          <a:p>
-            <a:pPr>
-              <a:spcBef>
-                <a:spcPts val="400"/>
-              </a:spcBef>
-              <a:defRPr sz="1050">
-                <a:solidFill>
-                  <a:srgbClr val="556070"/>
-                </a:solidFill>
-                <a:latin typeface="Calibri"/>
-              </a:defRPr>
-            </a:pPr>
-            <a:r>
-              <a:t>One shared questionnaire across the two priority groups: 10 DIY borrowers, 4 broker-placed borrowers, plus 3 broker-side interviews (XXX to be added).</a:t>
-            </a:r>
-          </a:p>
-        </p:txBody>
-      </p:sp>
-      <p:sp>
-        <p:nvSpPr>
-          <p:cNvPr id="32" name="Rectangle 31"/>
+      <p:pic>
+        <p:nvPicPr>
+          <p:cNvPr id="27" name="Picture 26" descr="s4_row0.jpg"/>
+          <p:cNvPicPr>
+            <a:picLocks noChangeAspect="1"/>
+          </p:cNvPicPr>
+          <p:nvPr/>
+        </p:nvPicPr>
+        <p:blipFill>
+          <a:blip r:embed="rId11"/>
+          <a:stretch>
+            <a:fillRect/>
+          </a:stretch>
+        </p:blipFill>
+        <p:spPr>
+          <a:xfrm>
+            <a:off x="457200" y="1508760"/>
+            <a:ext cx="1417320" cy="914400"/>
+          </a:xfrm>
+          <a:prstGeom prst="rect">
+            <a:avLst/>
+          </a:prstGeom>
+        </p:spPr>
+      </p:pic>
+      <p:sp>
+        <p:nvSpPr>
+          <p:cNvPr id="28" name="Rectangle 27"/>
           <p:cNvSpPr/>
           <p:nvPr/>
         </p:nvSpPr>
         <p:spPr>
           <a:xfrm>
-            <a:off x="457200" y="3515000"/>
-            <a:ext cx="8229600" cy="10000"/>
+            <a:off x="1874519" y="1508760"/>
+            <a:ext cx="4114800" cy="914400"/>
           </a:xfrm>
           <a:prstGeom prst="rect">
             <a:avLst/>
           </a:prstGeom>
           <a:solidFill>
-            <a:srgbClr val="D9DEE7"/>
+            <a:srgbClr val="EEF1F6"/>
           </a:solidFill>
           <a:ln>
             <a:noFill/>
           </a:ln>
+          <a:effectLst/>
         </p:spPr>
         <p:style>
           <a:lnRef idx="1">
@@ -10558,24 +10373,110 @@
           </a:p>
         </p:txBody>
       </p:sp>
+      <p:sp>
+        <p:nvSpPr>
+          <p:cNvPr id="29" name="TextBox 28"/>
+          <p:cNvSpPr txBox="1"/>
+          <p:nvPr/>
+        </p:nvSpPr>
+        <p:spPr>
+          <a:xfrm>
+            <a:off x="2011680" y="1508760"/>
+            <a:ext cx="777240" cy="914400"/>
+          </a:xfrm>
+          <a:prstGeom prst="rect">
+            <a:avLst/>
+          </a:prstGeom>
+          <a:noFill/>
+        </p:spPr>
+        <p:txBody>
+          <a:bodyPr wrap="square" lIns="0" rIns="0" tIns="0" bIns="0" anchor="ctr">
+            <a:spAutoFit/>
+          </a:bodyPr>
+          <a:lstStyle/>
+          <a:p>
+            <a:pPr algn="ctr"/>
+            <a:r>
+              <a:rPr sz="3400" b="1">
+                <a:solidFill>
+                  <a:srgbClr val="152B56"/>
+                </a:solidFill>
+                <a:latin typeface="Cambria"/>
+              </a:rPr>
+              <a:t>6</a:t>
+            </a:r>
+          </a:p>
+        </p:txBody>
+      </p:sp>
+      <p:sp>
+        <p:nvSpPr>
+          <p:cNvPr id="30" name="TextBox 29"/>
+          <p:cNvSpPr txBox="1"/>
+          <p:nvPr/>
+        </p:nvSpPr>
+        <p:spPr>
+          <a:xfrm>
+            <a:off x="2834640" y="1508760"/>
+            <a:ext cx="3063240" cy="914400"/>
+          </a:xfrm>
+          <a:prstGeom prst="rect">
+            <a:avLst/>
+          </a:prstGeom>
+          <a:noFill/>
+        </p:spPr>
+        <p:txBody>
+          <a:bodyPr wrap="square" lIns="0" rIns="0" tIns="0" bIns="0" anchor="ctr">
+            <a:spAutoFit/>
+          </a:bodyPr>
+          <a:lstStyle/>
+          <a:p>
+            <a:pPr algn="l"/>
+            <a:r>
+              <a:rPr sz="1200" b="1">
+                <a:solidFill>
+                  <a:srgbClr val="166257"/>
+                </a:solidFill>
+                <a:latin typeface="Calibri"/>
+              </a:rPr>
+              <a:t>customer journey maps</a:t>
+            </a:r>
+          </a:p>
+          <a:p>
+            <a:pPr algn="l">
+              <a:spcBef>
+                <a:spcPts val="200"/>
+              </a:spcBef>
+            </a:pPr>
+            <a:r>
+              <a:rPr sz="950" b="0">
+                <a:solidFill>
+                  <a:srgbClr val="556070"/>
+                </a:solidFill>
+                <a:latin typeface="Calibri"/>
+              </a:rPr>
+              <a:t>One borrower group each. We wrote the map we assumed, did primary research, then rewrote it. Combined primary sample of 42 across the six.</a:t>
+            </a:r>
+          </a:p>
+        </p:txBody>
+      </p:sp>
       <p:pic>
         <p:nvPicPr>
-          <p:cNvPr id="33" name="Picture 32" descr="s4_row3.jpg"/>
+          <p:cNvPr id="31" name="Picture 30" descr="s4_row1.jpg"/>
           <p:cNvPicPr>
             <a:picLocks noChangeAspect="1"/>
           </p:cNvPicPr>
           <p:nvPr/>
         </p:nvPicPr>
         <p:blipFill>
-          <a:blip r:embed="rId8"/>
+          <a:blip r:embed="rId12"/>
           <a:stretch>
             <a:fillRect/>
           </a:stretch>
         </p:blipFill>
         <p:spPr>
           <a:xfrm>
-            <a:off x="457200" y="3550000"/>
-            <a:ext cx="1620976" cy="1080000"/>
+            <a:off x="457200" y="2514600"/>
+            <a:ext cx="1417320" cy="914400"/>
           </a:xfrm>
           <a:prstGeom prst="rect">
             <a:avLst/>
@@ -10584,114 +10485,327 @@
       </p:pic>
       <p:sp>
         <p:nvSpPr>
-          <p:cNvPr id="34" name="TextBox 33"/>
-          <p:cNvSpPr txBox="1"/>
-          <p:nvPr/>
-        </p:nvSpPr>
-        <p:spPr>
-          <a:xfrm>
-            <a:off x="2537200" y="3490000"/>
-            <a:ext cx="1200000" cy="1080000"/>
-          </a:xfrm>
-          <a:prstGeom prst="rect">
-            <a:avLst/>
-          </a:prstGeom>
-          <a:noFill/>
-        </p:spPr>
-        <p:txBody>
-          <a:bodyPr wrap="square">
+          <p:cNvPr id="32" name="Rectangle 31"/>
+          <p:cNvSpPr/>
+          <p:nvPr/>
+        </p:nvSpPr>
+        <p:spPr>
+          <a:xfrm>
+            <a:off x="1874519" y="2514600"/>
+            <a:ext cx="4114800" cy="914400"/>
+          </a:xfrm>
+          <a:prstGeom prst="rect">
+            <a:avLst/>
+          </a:prstGeom>
+          <a:solidFill>
+            <a:srgbClr val="EEF1F6"/>
+          </a:solidFill>
+          <a:ln>
+            <a:noFill/>
+          </a:ln>
+          <a:effectLst/>
+        </p:spPr>
+        <p:style>
+          <a:lnRef idx="1">
+            <a:schemeClr val="accent1"/>
+          </a:lnRef>
+          <a:fillRef idx="3">
+            <a:schemeClr val="accent1"/>
+          </a:fillRef>
+          <a:effectRef idx="2">
+            <a:schemeClr val="accent1"/>
+          </a:effectRef>
+          <a:fontRef idx="minor">
+            <a:schemeClr val="lt1"/>
+          </a:fontRef>
+        </p:style>
+        <p:txBody>
+          <a:bodyPr rtlCol="0" anchor="ctr"/>
+          <a:lstStyle/>
+          <a:p>
+            <a:pPr algn="ctr"/>
+          </a:p>
+        </p:txBody>
+      </p:sp>
+      <p:sp>
+        <p:nvSpPr>
+          <p:cNvPr id="33" name="TextBox 32"/>
+          <p:cNvSpPr txBox="1"/>
+          <p:nvPr/>
+        </p:nvSpPr>
+        <p:spPr>
+          <a:xfrm>
+            <a:off x="2011680" y="2514600"/>
+            <a:ext cx="777240" cy="914400"/>
+          </a:xfrm>
+          <a:prstGeom prst="rect">
+            <a:avLst/>
+          </a:prstGeom>
+          <a:noFill/>
+        </p:spPr>
+        <p:txBody>
+          <a:bodyPr wrap="square" lIns="0" rIns="0" tIns="0" bIns="0" anchor="ctr">
             <a:spAutoFit/>
           </a:bodyPr>
           <a:lstStyle/>
           <a:p>
-            <a:r>
-              <a:rPr sz="4000" b="1">
+            <a:pPr algn="ctr"/>
+            <a:r>
+              <a:rPr sz="3400" b="1">
                 <a:solidFill>
                   <a:srgbClr val="152B56"/>
                 </a:solidFill>
                 <a:latin typeface="Cambria"/>
               </a:rPr>
-              <a:t>5</a:t>
-            </a:r>
-          </a:p>
-        </p:txBody>
-      </p:sp>
-      <p:sp>
-        <p:nvSpPr>
-          <p:cNvPr id="35" name="TextBox 34"/>
-          <p:cNvSpPr txBox="1"/>
-          <p:nvPr/>
-        </p:nvSpPr>
-        <p:spPr>
-          <a:xfrm>
-            <a:off x="3837200" y="3550000"/>
-            <a:ext cx="4849600" cy="1080000"/>
-          </a:xfrm>
-          <a:prstGeom prst="rect">
-            <a:avLst/>
-          </a:prstGeom>
-          <a:noFill/>
-        </p:spPr>
-        <p:txBody>
-          <a:bodyPr wrap="square">
+              <a:t>17</a:t>
+            </a:r>
+          </a:p>
+        </p:txBody>
+      </p:sp>
+      <p:sp>
+        <p:nvSpPr>
+          <p:cNvPr id="34" name="TextBox 33"/>
+          <p:cNvSpPr txBox="1"/>
+          <p:nvPr/>
+        </p:nvSpPr>
+        <p:spPr>
+          <a:xfrm>
+            <a:off x="2834640" y="2514600"/>
+            <a:ext cx="3063240" cy="914400"/>
+          </a:xfrm>
+          <a:prstGeom prst="rect">
+            <a:avLst/>
+          </a:prstGeom>
+          <a:noFill/>
+        </p:spPr>
+        <p:txBody>
+          <a:bodyPr wrap="square" lIns="0" rIns="0" tIns="0" bIns="0" anchor="ctr">
             <a:spAutoFit/>
           </a:bodyPr>
           <a:lstStyle/>
           <a:p>
-            <a:pPr>
-              <a:defRPr sz="1400" b="1">
+            <a:pPr algn="l"/>
+            <a:r>
+              <a:rPr sz="1200" b="1">
                 <a:solidFill>
                   <a:srgbClr val="166257"/>
                 </a:solidFill>
                 <a:latin typeface="Calibri"/>
-              </a:defRPr>
-            </a:pPr>
-            <a:r>
-              <a:t>industry datasets</a:t>
-            </a:r>
-          </a:p>
-          <a:p>
-            <a:pPr>
+              </a:rPr>
+              <a:t>questionnaire responses</a:t>
+            </a:r>
+          </a:p>
+          <a:p>
+            <a:pPr algn="l">
               <a:spcBef>
-                <a:spcPts val="400"/>
+                <a:spcPts val="200"/>
               </a:spcBef>
-              <a:defRPr sz="1050">
+            </a:pPr>
+            <a:r>
+              <a:rPr sz="950" b="0">
                 <a:solidFill>
                   <a:srgbClr val="556070"/>
                 </a:solidFill>
                 <a:latin typeface="Calibri"/>
-              </a:defRPr>
-            </a:pPr>
-            <a:r>
-              <a:t>MFAA broker share, ACCC home loan pricing inquiry, COBA and Roy Morgan trust data, ASIC consumer research.</a:t>
+              </a:rPr>
+              <a:t>One shared questionnaire across the two priority groups: 10 DIY borrowers, 4 broker-placed borrowers, plus 3 broker-side interviews (XXX to be added).</a:t>
             </a:r>
           </a:p>
         </p:txBody>
       </p:sp>
       <p:pic>
         <p:nvPicPr>
-          <p:cNvPr id="36" name="Picture 35" descr="s4_row1.jpg"/>
+          <p:cNvPr id="35" name="Picture 34" descr="s4_row2.jpg"/>
           <p:cNvPicPr>
             <a:picLocks noChangeAspect="1"/>
           </p:cNvPicPr>
           <p:nvPr/>
         </p:nvPicPr>
         <p:blipFill>
-          <a:blip r:embed="rId9"/>
+          <a:blip r:embed="rId13"/>
           <a:stretch>
             <a:fillRect/>
           </a:stretch>
         </p:blipFill>
         <p:spPr>
           <a:xfrm>
-            <a:off x="457200" y="1250000"/>
-            <a:ext cx="1620000" cy="1080000"/>
+            <a:off x="457200" y="3520440"/>
+            <a:ext cx="1417320" cy="914400"/>
           </a:xfrm>
           <a:prstGeom prst="rect">
             <a:avLst/>
           </a:prstGeom>
         </p:spPr>
       </p:pic>
+      <p:sp>
+        <p:nvSpPr>
+          <p:cNvPr id="36" name="Rectangle 35"/>
+          <p:cNvSpPr/>
+          <p:nvPr/>
+        </p:nvSpPr>
+        <p:spPr>
+          <a:xfrm>
+            <a:off x="1874519" y="3520440"/>
+            <a:ext cx="4114800" cy="914400"/>
+          </a:xfrm>
+          <a:prstGeom prst="rect">
+            <a:avLst/>
+          </a:prstGeom>
+          <a:solidFill>
+            <a:srgbClr val="EEF1F6"/>
+          </a:solidFill>
+          <a:ln>
+            <a:noFill/>
+          </a:ln>
+          <a:effectLst/>
+        </p:spPr>
+        <p:style>
+          <a:lnRef idx="1">
+            <a:schemeClr val="accent1"/>
+          </a:lnRef>
+          <a:fillRef idx="3">
+            <a:schemeClr val="accent1"/>
+          </a:fillRef>
+          <a:effectRef idx="2">
+            <a:schemeClr val="accent1"/>
+          </a:effectRef>
+          <a:fontRef idx="minor">
+            <a:schemeClr val="lt1"/>
+          </a:fontRef>
+        </p:style>
+        <p:txBody>
+          <a:bodyPr rtlCol="0" anchor="ctr"/>
+          <a:lstStyle/>
+          <a:p>
+            <a:pPr algn="ctr"/>
+          </a:p>
+        </p:txBody>
+      </p:sp>
+      <p:sp>
+        <p:nvSpPr>
+          <p:cNvPr id="37" name="TextBox 36"/>
+          <p:cNvSpPr txBox="1"/>
+          <p:nvPr/>
+        </p:nvSpPr>
+        <p:spPr>
+          <a:xfrm>
+            <a:off x="2011680" y="3520440"/>
+            <a:ext cx="777240" cy="914400"/>
+          </a:xfrm>
+          <a:prstGeom prst="rect">
+            <a:avLst/>
+          </a:prstGeom>
+          <a:noFill/>
+        </p:spPr>
+        <p:txBody>
+          <a:bodyPr wrap="square" lIns="0" rIns="0" tIns="0" bIns="0" anchor="ctr">
+            <a:spAutoFit/>
+          </a:bodyPr>
+          <a:lstStyle/>
+          <a:p>
+            <a:pPr algn="ctr"/>
+            <a:r>
+              <a:rPr sz="3400" b="1">
+                <a:solidFill>
+                  <a:srgbClr val="152B56"/>
+                </a:solidFill>
+                <a:latin typeface="Cambria"/>
+              </a:rPr>
+              <a:t>5</a:t>
+            </a:r>
+          </a:p>
+        </p:txBody>
+      </p:sp>
+      <p:sp>
+        <p:nvSpPr>
+          <p:cNvPr id="38" name="TextBox 37"/>
+          <p:cNvSpPr txBox="1"/>
+          <p:nvPr/>
+        </p:nvSpPr>
+        <p:spPr>
+          <a:xfrm>
+            <a:off x="2834640" y="3520440"/>
+            <a:ext cx="3063240" cy="914400"/>
+          </a:xfrm>
+          <a:prstGeom prst="rect">
+            <a:avLst/>
+          </a:prstGeom>
+          <a:noFill/>
+        </p:spPr>
+        <p:txBody>
+          <a:bodyPr wrap="square" lIns="0" rIns="0" tIns="0" bIns="0" anchor="ctr">
+            <a:spAutoFit/>
+          </a:bodyPr>
+          <a:lstStyle/>
+          <a:p>
+            <a:pPr algn="l"/>
+            <a:r>
+              <a:rPr sz="1200" b="1">
+                <a:solidFill>
+                  <a:srgbClr val="166257"/>
+                </a:solidFill>
+                <a:latin typeface="Calibri"/>
+              </a:rPr>
+              <a:t>industry datasets</a:t>
+            </a:r>
+          </a:p>
+          <a:p>
+            <a:pPr algn="l">
+              <a:spcBef>
+                <a:spcPts val="200"/>
+              </a:spcBef>
+            </a:pPr>
+            <a:r>
+              <a:rPr sz="950" b="0">
+                <a:solidFill>
+                  <a:srgbClr val="556070"/>
+                </a:solidFill>
+                <a:latin typeface="Calibri"/>
+              </a:rPr>
+              <a:t>MFAA broker share, ACCC home loan pricing inquiry, COBA and Roy Morgan trust data, ASIC consumer research.</a:t>
+            </a:r>
+          </a:p>
+        </p:txBody>
+      </p:sp>
+      <p:sp>
+        <p:nvSpPr>
+          <p:cNvPr id="24" name="Text 18"/>
+          <p:cNvSpPr txBox="1"/>
+          <p:nvPr/>
+        </p:nvSpPr>
+        <p:spPr>
+          <a:xfrm>
+            <a:off x="8229600" y="4754880"/>
+            <a:ext cx="457200" cy="228600"/>
+          </a:xfrm>
+          <a:prstGeom prst="rect">
+            <a:avLst/>
+          </a:prstGeom>
+          <a:noFill/>
+          <a:ln/>
+        </p:spPr>
+        <p:txBody>
+          <a:bodyPr wrap="square" lIns="0" tIns="0" rIns="0" bIns="0" rtlCol="0" anchor="ctr"/>
+          <a:lstStyle/>
+          <a:p>
+            <a:pPr algn="r" indent="0" marL="0">
+              <a:buNone/>
+            </a:pPr>
+            <a:r>
+              <a:rPr lang="en-US" sz="1000" dirty="0">
+                <a:solidFill>
+                  <a:srgbClr val="FFFFFF"/>
+                </a:solidFill>
+                <a:latin typeface="Calibri" pitchFamily="34" charset="0"/>
+                <a:ea typeface="Calibri" pitchFamily="34" charset="-122"/>
+                <a:cs typeface="Calibri" pitchFamily="34" charset="-120"/>
+              </a:rPr>
+              <a:t>4</a:t>
+            </a:r>
+            <a:endParaRPr lang="en-US" sz="1000" dirty="0"/>
+          </a:p>
+        </p:txBody>
+      </p:sp>
     </p:spTree>
   </p:cSld>
   <p:clrMapOvr>

</xml_diff>

<commit_message>
Slide 2: clarify shortlist boxes
Co-Authored-By: Claude Sonnet 5.5 <noreply@anthropic.com>
Claude-Session: https://claude.ai/code/session_018FYC5nzQydn1DiijEsEsUi
</commit_message>
<xml_diff>
--- a/AMB_Draft_4_remaster_wip.pptx
+++ b/AMB_Draft_4_remaster_wip.pptx
@@ -10724,7 +10724,7 @@
                 </a:solidFill>
                 <a:latin typeface="Calibri"/>
               </a:rPr>
-              <a:t>WHAT WE FOUND IN ALL SIX GROUPS</a:t>
+              <a:t>THE BORROWER'S SHORTLIST: 2 TO 4 LENDERS</a:t>
             </a:r>
           </a:p>
         </p:txBody>
@@ -10799,25 +10799,25 @@
           <a:p>
             <a:pPr algn="ctr"/>
             <a:r>
-              <a:rPr sz="1000" b="0">
-                <a:solidFill>
-                  <a:srgbClr val="AFC0DA"/>
+              <a:rPr sz="1050" b="1">
+                <a:solidFill>
+                  <a:srgbClr val="FFFFFF"/>
                 </a:solidFill>
                 <a:latin typeface="Calibri"/>
               </a:rPr>
-              <a:t>Lender</a:t>
+              <a:t>Familiar</a:t>
             </a:r>
           </a:p>
           <a:p>
             <a:pPr algn="ctr"/>
             <a:r>
-              <a:rPr sz="1000" b="0">
-                <a:solidFill>
-                  <a:srgbClr val="AFC0DA"/>
+              <a:rPr sz="1050" b="1">
+                <a:solidFill>
+                  <a:srgbClr val="FFFFFF"/>
                 </a:solidFill>
                 <a:latin typeface="Calibri"/>
               </a:rPr>
-              <a:t>they knew</a:t>
+              <a:t>lender</a:t>
             </a:r>
           </a:p>
         </p:txBody>
@@ -10892,25 +10892,25 @@
           <a:p>
             <a:pPr algn="ctr"/>
             <a:r>
-              <a:rPr sz="1000" b="0">
-                <a:solidFill>
-                  <a:srgbClr val="AFC0DA"/>
+              <a:rPr sz="1050" b="1">
+                <a:solidFill>
+                  <a:srgbClr val="FFFFFF"/>
                 </a:solidFill>
                 <a:latin typeface="Calibri"/>
               </a:rPr>
-              <a:t>Lender</a:t>
+              <a:t>Familiar</a:t>
             </a:r>
           </a:p>
           <a:p>
             <a:pPr algn="ctr"/>
             <a:r>
-              <a:rPr sz="1000" b="0">
-                <a:solidFill>
-                  <a:srgbClr val="AFC0DA"/>
+              <a:rPr sz="1050" b="1">
+                <a:solidFill>
+                  <a:srgbClr val="FFFFFF"/>
                 </a:solidFill>
                 <a:latin typeface="Calibri"/>
               </a:rPr>
-              <a:t>they knew</a:t>
+              <a:t>lender</a:t>
             </a:r>
           </a:p>
         </p:txBody>
@@ -10985,25 +10985,25 @@
           <a:p>
             <a:pPr algn="ctr"/>
             <a:r>
-              <a:rPr sz="1000" b="0">
-                <a:solidFill>
-                  <a:srgbClr val="AFC0DA"/>
+              <a:rPr sz="1050" b="1">
+                <a:solidFill>
+                  <a:srgbClr val="FFFFFF"/>
                 </a:solidFill>
                 <a:latin typeface="Calibri"/>
               </a:rPr>
-              <a:t>Lender</a:t>
+              <a:t>Familiar</a:t>
             </a:r>
           </a:p>
           <a:p>
             <a:pPr algn="ctr"/>
             <a:r>
-              <a:rPr sz="1000" b="0">
-                <a:solidFill>
-                  <a:srgbClr val="AFC0DA"/>
+              <a:rPr sz="1050" b="1">
+                <a:solidFill>
+                  <a:srgbClr val="FFFFFF"/>
                 </a:solidFill>
                 <a:latin typeface="Calibri"/>
               </a:rPr>
-              <a:t>they knew</a:t>
+              <a:t>lender</a:t>
             </a:r>
           </a:p>
         </p:txBody>
@@ -11078,25 +11078,25 @@
           <a:p>
             <a:pPr algn="ctr"/>
             <a:r>
-              <a:rPr sz="1000" b="0">
-                <a:solidFill>
-                  <a:srgbClr val="AFC0DA"/>
+              <a:rPr sz="1050" b="1">
+                <a:solidFill>
+                  <a:srgbClr val="FFFFFF"/>
                 </a:solidFill>
                 <a:latin typeface="Calibri"/>
               </a:rPr>
-              <a:t>Lender</a:t>
+              <a:t>Familiar</a:t>
             </a:r>
           </a:p>
           <a:p>
             <a:pPr algn="ctr"/>
             <a:r>
-              <a:rPr sz="1000" b="0">
-                <a:solidFill>
-                  <a:srgbClr val="AFC0DA"/>
+              <a:rPr sz="1050" b="1">
+                <a:solidFill>
+                  <a:srgbClr val="FFFFFF"/>
                 </a:solidFill>
                 <a:latin typeface="Calibri"/>
               </a:rPr>
-              <a:t>they knew</a:t>
+              <a:t>lender</a:t>
             </a:r>
           </a:p>
         </p:txBody>
@@ -11131,7 +11131,7 @@
                 </a:solidFill>
                 <a:latin typeface="Calibri"/>
               </a:rPr>
-              <a:t>Two to four lenders compared. The list was built before any rate was seen.</a:t>
+              <a:t>Found in all six groups: borrowers compared only lenders they already knew.</a:t>
             </a:r>
           </a:p>
         </p:txBody>
@@ -11245,13 +11245,13 @@
           <a:p>
             <a:pPr algn="l"/>
             <a:r>
-              <a:rPr sz="950" b="0">
+              <a:rPr sz="900" b="0">
                 <a:solidFill>
                   <a:srgbClr val="556070"/>
                 </a:solidFill>
                 <a:latin typeface="Calibri"/>
               </a:rPr>
-              <a:t>absent</a:t>
+              <a:t>not on list</a:t>
             </a:r>
           </a:p>
         </p:txBody>
@@ -11286,7 +11286,7 @@
                 </a:solidFill>
                 <a:latin typeface="Calibri"/>
               </a:rPr>
-              <a:t>Never among them</a:t>
+              <a:t>Never considered</a:t>
             </a:r>
           </a:p>
         </p:txBody>

</xml_diff>

<commit_message>
Slide 2: show 3 numbered familiar lenders plus optional 4th
Co-Authored-By: Claude Sonnet 5.5 <noreply@anthropic.com>
Claude-Session: https://claude.ai/code/session_018FYC5nzQydn1DiijEsEsUi
</commit_message>
<xml_diff>
--- a/AMB_Draft_4_remaster_wip.pptx
+++ b/AMB_Draft_4_remaster_wip.pptx
@@ -10724,7 +10724,7 @@
                 </a:solidFill>
                 <a:latin typeface="Calibri"/>
               </a:rPr>
-              <a:t>THE BORROWER'S SHORTLIST: 2 TO 4 LENDERS</a:t>
+              <a:t>WHAT A BORROWER'S SHORTLIST LOOKED LIKE</a:t>
             </a:r>
           </a:p>
         </p:txBody>
@@ -10817,7 +10817,7 @@
                 </a:solidFill>
                 <a:latin typeface="Calibri"/>
               </a:rPr>
-              <a:t>lender</a:t>
+              <a:t>lender 1</a:t>
             </a:r>
           </a:p>
         </p:txBody>
@@ -10910,7 +10910,7 @@
                 </a:solidFill>
                 <a:latin typeface="Calibri"/>
               </a:rPr>
-              <a:t>lender</a:t>
+              <a:t>lender 2</a:t>
             </a:r>
           </a:p>
         </p:txBody>
@@ -11003,7 +11003,7 @@
                 </a:solidFill>
                 <a:latin typeface="Calibri"/>
               </a:rPr>
-              <a:t>lender</a:t>
+              <a:t>lender 3</a:t>
             </a:r>
           </a:p>
         </p:txBody>
@@ -11025,10 +11025,13 @@
             </a:avLst>
           </a:prstGeom>
           <a:solidFill>
-            <a:srgbClr val="152B56"/>
+            <a:srgbClr val="F1F4F9"/>
           </a:solidFill>
-          <a:ln>
-            <a:noFill/>
+          <a:ln w="12700">
+            <a:solidFill>
+              <a:srgbClr val="8A94A6"/>
+            </a:solidFill>
+            <a:prstDash val="dash"/>
           </a:ln>
           <a:effectLst/>
         </p:spPr>
@@ -11080,23 +11083,23 @@
             <a:r>
               <a:rPr sz="1050" b="1">
                 <a:solidFill>
-                  <a:srgbClr val="FFFFFF"/>
+                  <a:srgbClr val="556070"/>
                 </a:solidFill>
                 <a:latin typeface="Calibri"/>
               </a:rPr>
-              <a:t>Familiar</a:t>
+              <a:t>Lender 4</a:t>
             </a:r>
           </a:p>
           <a:p>
             <a:pPr algn="ctr"/>
             <a:r>
-              <a:rPr sz="1050" b="1">
-                <a:solidFill>
-                  <a:srgbClr val="FFFFFF"/>
+              <a:rPr sz="950" b="0">
+                <a:solidFill>
+                  <a:srgbClr val="556070"/>
                 </a:solidFill>
                 <a:latin typeface="Calibri"/>
               </a:rPr>
-              <a:t>lender</a:t>
+              <a:t>(sometimes)</a:t>
             </a:r>
           </a:p>
         </p:txBody>
@@ -11131,7 +11134,7 @@
                 </a:solidFill>
                 <a:latin typeface="Calibri"/>
               </a:rPr>
-              <a:t>Found in all six groups: borrowers compared only lenders they already knew.</a:t>
+              <a:t>All six groups compared two to four lenders, all names they already knew.</a:t>
             </a:r>
           </a:p>
         </p:txBody>

</xml_diff>